<commit_message>
feat: rewrite ICAIDES deck, Slides 2-3 Motivation/Gap + Objective (2/6)
Co-Authored-By: Claude Sonnet 5 <noreply@anthropic.com>
</commit_message>
<xml_diff>
--- a/docs/presentation/icaides2026_jev.pptx
+++ b/docs/presentation/icaides2026_jev.pptx
@@ -6,6 +6,8 @@
   </p:sldMasterIdLst>
   <p:sldIdLst>
     <p:sldId id="256" r:id="rId7"/>
+    <p:sldId id="257" r:id="rId8"/>
+    <p:sldId id="258" r:id="rId9"/>
   </p:sldIdLst>
   <p:sldSz cx="12191695" cy="6858000" type="screen4x3"/>
   <p:notesSz cx="6858000" cy="9144000"/>
@@ -3232,6 +3234,569 @@
                 <a:latin typeface="Arial"/>
               </a:rPr>
               <a:t>Can a model that only fills in structured answers rank applicants better than one that writes free text?</a:t>
+            </a:r>
+          </a:p>
+        </p:txBody>
+      </p:sp>
+    </p:spTree>
+  </p:cSld>
+  <p:clrMapOvr>
+    <a:masterClrMapping/>
+  </p:clrMapOvr>
+</p:sld>
+</file>
+
+<file path=ppt/slides/slide2.xml><?xml version="1.0" encoding="utf-8"?>
+<p:sld xmlns:a="http://schemas.openxmlformats.org/drawingml/2006/main" xmlns:p="http://schemas.openxmlformats.org/presentationml/2006/main" xmlns:r="http://schemas.openxmlformats.org/officeDocument/2006/relationships">
+  <p:cSld>
+    <p:bg>
+      <p:bgPr>
+        <a:solidFill>
+          <a:srgbClr val="FFFFFF"/>
+        </a:solidFill>
+        <a:effectLst/>
+      </p:bgPr>
+    </p:bg>
+    <p:spTree>
+      <p:nvGrpSpPr>
+        <p:cNvPr id="1" name=""/>
+        <p:cNvGrpSpPr/>
+        <p:nvPr/>
+      </p:nvGrpSpPr>
+      <p:grpSpPr/>
+      <p:sp>
+        <p:nvSpPr>
+          <p:cNvPr id="2" name="TextBox 1"/>
+          <p:cNvSpPr txBox="1"/>
+          <p:nvPr/>
+        </p:nvSpPr>
+        <p:spPr>
+          <a:xfrm>
+            <a:off x="731520" y="411480"/>
+            <a:ext cx="10728655" cy="320040"/>
+          </a:xfrm>
+          <a:prstGeom prst="rect">
+            <a:avLst/>
+          </a:prstGeom>
+          <a:noFill/>
+        </p:spPr>
+        <p:txBody>
+          <a:bodyPr wrap="square">
+            <a:spAutoFit/>
+          </a:bodyPr>
+          <a:lstStyle/>
+          <a:p>
+            <a:pPr algn="l"/>
+            <a:r>
+              <a:rPr sz="1300" b="1" i="0" u="none">
+                <a:solidFill>
+                  <a:srgbClr val="595959"/>
+                </a:solidFill>
+                <a:latin typeface="Arial"/>
+              </a:rPr>
+              <a:t>INTRODUCTION</a:t>
+            </a:r>
+          </a:p>
+        </p:txBody>
+      </p:sp>
+      <p:sp>
+        <p:nvSpPr>
+          <p:cNvPr id="3" name="TextBox 2"/>
+          <p:cNvSpPr txBox="1"/>
+          <p:nvPr/>
+        </p:nvSpPr>
+        <p:spPr>
+          <a:xfrm>
+            <a:off x="731520" y="777240"/>
+            <a:ext cx="10728655" cy="1005840"/>
+          </a:xfrm>
+          <a:prstGeom prst="rect">
+            <a:avLst/>
+          </a:prstGeom>
+          <a:noFill/>
+        </p:spPr>
+        <p:txBody>
+          <a:bodyPr wrap="square">
+            <a:spAutoFit/>
+          </a:bodyPr>
+          <a:lstStyle/>
+          <a:p>
+            <a:pPr algn="l"/>
+            <a:r>
+              <a:rPr sz="3000" b="1" i="0" u="none">
+                <a:solidFill>
+                  <a:srgbClr val="000000"/>
+                </a:solidFill>
+                <a:latin typeface="Arial"/>
+              </a:rPr>
+              <a:t>Motivation &amp; Gap</a:t>
+            </a:r>
+          </a:p>
+        </p:txBody>
+      </p:sp>
+      <p:sp>
+        <p:nvSpPr>
+          <p:cNvPr id="4" name="TextBox 3"/>
+          <p:cNvSpPr txBox="1"/>
+          <p:nvPr/>
+        </p:nvSpPr>
+        <p:spPr>
+          <a:xfrm>
+            <a:off x="1005840" y="2103120"/>
+            <a:ext cx="10180015" cy="3200400"/>
+          </a:xfrm>
+          <a:prstGeom prst="rect">
+            <a:avLst/>
+          </a:prstGeom>
+          <a:noFill/>
+        </p:spPr>
+        <p:txBody>
+          <a:bodyPr wrap="square">
+            <a:spAutoFit/>
+          </a:bodyPr>
+          <a:lstStyle/>
+          <a:p>
+            <a:pPr>
+              <a:spcAft>
+                <a:spcPts val="1200"/>
+              </a:spcAft>
+            </a:pPr>
+            <a:r>
+              <a:rPr sz="2000">
+                <a:solidFill>
+                  <a:srgbClr val="000000"/>
+                </a:solidFill>
+                <a:latin typeface="Arial"/>
+              </a:rPr>
+              <a:t>•  Free-text assessment can assert a strength or weakness the resume never supports — a hallucination — with no built-in confidence signal.</a:t>
+            </a:r>
+          </a:p>
+          <a:p>
+            <a:pPr>
+              <a:spcAft>
+                <a:spcPts val="1200"/>
+              </a:spcAft>
+            </a:pPr>
+            <a:r>
+              <a:rPr sz="2000">
+                <a:solidFill>
+                  <a:srgbClr val="000000"/>
+                </a:solidFill>
+                <a:latin typeface="Arial"/>
+              </a:rPr>
+              <a:t>•  In September 2026, TypeSafe released Jev, the first "System One Model."</a:t>
+            </a:r>
+          </a:p>
+          <a:p>
+            <a:pPr>
+              <a:spcAft>
+                <a:spcPts val="1200"/>
+              </a:spcAft>
+            </a:pPr>
+            <a:r>
+              <a:rPr sz="2000">
+                <a:solidFill>
+                  <a:srgbClr val="000000"/>
+                </a:solidFill>
+                <a:latin typeface="Arial"/>
+              </a:rPr>
+              <a:t>•  No independent, peer-reviewed evaluation of it existed before this paper.</a:t>
+            </a:r>
+          </a:p>
+        </p:txBody>
+      </p:sp>
+      <p:sp>
+        <p:nvSpPr>
+          <p:cNvPr id="5" name="TextBox 4"/>
+          <p:cNvSpPr txBox="1"/>
+          <p:nvPr/>
+        </p:nvSpPr>
+        <p:spPr>
+          <a:xfrm>
+            <a:off x="731520" y="6355080"/>
+            <a:ext cx="10728655" cy="365760"/>
+          </a:xfrm>
+          <a:prstGeom prst="rect">
+            <a:avLst/>
+          </a:prstGeom>
+          <a:noFill/>
+        </p:spPr>
+        <p:txBody>
+          <a:bodyPr wrap="square">
+            <a:spAutoFit/>
+          </a:bodyPr>
+          <a:lstStyle/>
+          <a:p>
+            <a:pPr algn="l"/>
+            <a:r>
+              <a:rPr sz="1200" b="0" i="1" u="none">
+                <a:solidFill>
+                  <a:srgbClr val="595959"/>
+                </a:solidFill>
+                <a:latin typeface="Arial"/>
+              </a:rPr>
+              <a:t>Section I — Introduction</a:t>
+            </a:r>
+          </a:p>
+        </p:txBody>
+      </p:sp>
+    </p:spTree>
+  </p:cSld>
+  <p:clrMapOvr>
+    <a:masterClrMapping/>
+  </p:clrMapOvr>
+</p:sld>
+</file>
+
+<file path=ppt/slides/slide3.xml><?xml version="1.0" encoding="utf-8"?>
+<p:sld xmlns:a="http://schemas.openxmlformats.org/drawingml/2006/main" xmlns:p="http://schemas.openxmlformats.org/presentationml/2006/main" xmlns:r="http://schemas.openxmlformats.org/officeDocument/2006/relationships">
+  <p:cSld>
+    <p:bg>
+      <p:bgPr>
+        <a:solidFill>
+          <a:srgbClr val="FFFFFF"/>
+        </a:solidFill>
+        <a:effectLst/>
+      </p:bgPr>
+    </p:bg>
+    <p:spTree>
+      <p:nvGrpSpPr>
+        <p:cNvPr id="1" name=""/>
+        <p:cNvGrpSpPr/>
+        <p:nvPr/>
+      </p:nvGrpSpPr>
+      <p:grpSpPr/>
+      <p:sp>
+        <p:nvSpPr>
+          <p:cNvPr id="2" name="TextBox 1"/>
+          <p:cNvSpPr txBox="1"/>
+          <p:nvPr/>
+        </p:nvSpPr>
+        <p:spPr>
+          <a:xfrm>
+            <a:off x="731520" y="411480"/>
+            <a:ext cx="10728655" cy="320040"/>
+          </a:xfrm>
+          <a:prstGeom prst="rect">
+            <a:avLst/>
+          </a:prstGeom>
+          <a:noFill/>
+        </p:spPr>
+        <p:txBody>
+          <a:bodyPr wrap="square">
+            <a:spAutoFit/>
+          </a:bodyPr>
+          <a:lstStyle/>
+          <a:p>
+            <a:pPr algn="l"/>
+            <a:r>
+              <a:rPr sz="1300" b="1" i="0" u="none">
+                <a:solidFill>
+                  <a:srgbClr val="595959"/>
+                </a:solidFill>
+                <a:latin typeface="Arial"/>
+              </a:rPr>
+              <a:t>INTRODUCTION</a:t>
+            </a:r>
+          </a:p>
+        </p:txBody>
+      </p:sp>
+      <p:sp>
+        <p:nvSpPr>
+          <p:cNvPr id="3" name="TextBox 2"/>
+          <p:cNvSpPr txBox="1"/>
+          <p:nvPr/>
+        </p:nvSpPr>
+        <p:spPr>
+          <a:xfrm>
+            <a:off x="731520" y="777240"/>
+            <a:ext cx="10728655" cy="1005840"/>
+          </a:xfrm>
+          <a:prstGeom prst="rect">
+            <a:avLst/>
+          </a:prstGeom>
+          <a:noFill/>
+        </p:spPr>
+        <p:txBody>
+          <a:bodyPr wrap="square">
+            <a:spAutoFit/>
+          </a:bodyPr>
+          <a:lstStyle/>
+          <a:p>
+            <a:pPr algn="l"/>
+            <a:r>
+              <a:rPr sz="3000" b="1" i="0" u="none">
+                <a:solidFill>
+                  <a:srgbClr val="000000"/>
+                </a:solidFill>
+                <a:latin typeface="Arial"/>
+              </a:rPr>
+              <a:t>Objective</a:t>
+            </a:r>
+          </a:p>
+        </p:txBody>
+      </p:sp>
+      <p:sp>
+        <p:nvSpPr>
+          <p:cNvPr id="4" name="Rectangle 3"/>
+          <p:cNvSpPr/>
+          <p:nvPr/>
+        </p:nvSpPr>
+        <p:spPr>
+          <a:xfrm>
+            <a:off x="655167" y="2103120"/>
+            <a:ext cx="3383280" cy="2011680"/>
+          </a:xfrm>
+          <a:prstGeom prst="rect">
+            <a:avLst/>
+          </a:prstGeom>
+          <a:noFill/>
+          <a:ln w="19050">
+            <a:solidFill>
+              <a:srgbClr val="000000"/>
+            </a:solidFill>
+          </a:ln>
+          <a:effectLst/>
+        </p:spPr>
+        <p:style>
+          <a:lnRef idx="1">
+            <a:schemeClr val="accent1"/>
+          </a:lnRef>
+          <a:fillRef idx="3">
+            <a:schemeClr val="accent1"/>
+          </a:fillRef>
+          <a:effectRef idx="2">
+            <a:schemeClr val="accent1"/>
+          </a:effectRef>
+          <a:fontRef idx="minor">
+            <a:schemeClr val="lt1"/>
+          </a:fontRef>
+        </p:style>
+        <p:txBody>
+          <a:bodyPr rtlCol="0" anchor="ctr" wrap="square" lIns="127000" rIns="127000"/>
+          <a:lstStyle/>
+          <a:p>
+            <a:pPr algn="ctr"/>
+            <a:r>
+              <a:rPr sz="1700" b="1">
+                <a:solidFill>
+                  <a:srgbClr val="000000"/>
+                </a:solidFill>
+                <a:latin typeface="Arial"/>
+              </a:rPr>
+              <a:t>Criteria-Grounded</a:t>
+            </a:r>
+          </a:p>
+          <a:p>
+            <a:pPr algn="ctr"/>
+            <a:r>
+              <a:rPr sz="1700" b="1">
+                <a:solidFill>
+                  <a:srgbClr val="000000"/>
+                </a:solidFill>
+                <a:latin typeface="Arial"/>
+              </a:rPr>
+              <a:t>Question Design</a:t>
+            </a:r>
+          </a:p>
+        </p:txBody>
+      </p:sp>
+      <p:sp>
+        <p:nvSpPr>
+          <p:cNvPr id="5" name="Rectangle 4"/>
+          <p:cNvSpPr/>
+          <p:nvPr/>
+        </p:nvSpPr>
+        <p:spPr>
+          <a:xfrm>
+            <a:off x="4404207" y="2103120"/>
+            <a:ext cx="3383280" cy="2011680"/>
+          </a:xfrm>
+          <a:prstGeom prst="rect">
+            <a:avLst/>
+          </a:prstGeom>
+          <a:noFill/>
+          <a:ln w="19050">
+            <a:solidFill>
+              <a:srgbClr val="000000"/>
+            </a:solidFill>
+          </a:ln>
+          <a:effectLst/>
+        </p:spPr>
+        <p:style>
+          <a:lnRef idx="1">
+            <a:schemeClr val="accent1"/>
+          </a:lnRef>
+          <a:fillRef idx="3">
+            <a:schemeClr val="accent1"/>
+          </a:fillRef>
+          <a:effectRef idx="2">
+            <a:schemeClr val="accent1"/>
+          </a:effectRef>
+          <a:fontRef idx="minor">
+            <a:schemeClr val="lt1"/>
+          </a:fontRef>
+        </p:style>
+        <p:txBody>
+          <a:bodyPr rtlCol="0" anchor="ctr" wrap="square" lIns="127000" rIns="127000"/>
+          <a:lstStyle/>
+          <a:p>
+            <a:pPr algn="ctr"/>
+            <a:r>
+              <a:rPr sz="1700" b="1">
+                <a:solidFill>
+                  <a:srgbClr val="000000"/>
+                </a:solidFill>
+                <a:latin typeface="Arial"/>
+              </a:rPr>
+              <a:t>Cost &amp; Latency</a:t>
+            </a:r>
+          </a:p>
+          <a:p>
+            <a:pPr algn="ctr"/>
+            <a:r>
+              <a:rPr sz="1700" b="1">
+                <a:solidFill>
+                  <a:srgbClr val="000000"/>
+                </a:solidFill>
+                <a:latin typeface="Arial"/>
+              </a:rPr>
+              <a:t>Efficiency</a:t>
+            </a:r>
+          </a:p>
+        </p:txBody>
+      </p:sp>
+      <p:sp>
+        <p:nvSpPr>
+          <p:cNvPr id="6" name="Rectangle 5"/>
+          <p:cNvSpPr/>
+          <p:nvPr/>
+        </p:nvSpPr>
+        <p:spPr>
+          <a:xfrm>
+            <a:off x="8153247" y="2103120"/>
+            <a:ext cx="3383280" cy="2011680"/>
+          </a:xfrm>
+          <a:prstGeom prst="rect">
+            <a:avLst/>
+          </a:prstGeom>
+          <a:noFill/>
+          <a:ln w="19050">
+            <a:solidFill>
+              <a:srgbClr val="000000"/>
+            </a:solidFill>
+          </a:ln>
+          <a:effectLst/>
+        </p:spPr>
+        <p:style>
+          <a:lnRef idx="1">
+            <a:schemeClr val="accent1"/>
+          </a:lnRef>
+          <a:fillRef idx="3">
+            <a:schemeClr val="accent1"/>
+          </a:fillRef>
+          <a:effectRef idx="2">
+            <a:schemeClr val="accent1"/>
+          </a:effectRef>
+          <a:fontRef idx="minor">
+            <a:schemeClr val="lt1"/>
+          </a:fontRef>
+        </p:style>
+        <p:txBody>
+          <a:bodyPr rtlCol="0" anchor="ctr" wrap="square" lIns="127000" rIns="127000"/>
+          <a:lstStyle/>
+          <a:p>
+            <a:pPr algn="ctr"/>
+            <a:r>
+              <a:rPr sz="1700" b="1">
+                <a:solidFill>
+                  <a:srgbClr val="000000"/>
+                </a:solidFill>
+                <a:latin typeface="Arial"/>
+              </a:rPr>
+              <a:t>Repeat-to-Repeat</a:t>
+            </a:r>
+          </a:p>
+          <a:p>
+            <a:pPr algn="ctr"/>
+            <a:r>
+              <a:rPr sz="1700" b="1">
+                <a:solidFill>
+                  <a:srgbClr val="000000"/>
+                </a:solidFill>
+                <a:latin typeface="Arial"/>
+              </a:rPr>
+              <a:t>Reliability</a:t>
+            </a:r>
+          </a:p>
+        </p:txBody>
+      </p:sp>
+      <p:sp>
+        <p:nvSpPr>
+          <p:cNvPr id="7" name="TextBox 6"/>
+          <p:cNvSpPr txBox="1"/>
+          <p:nvPr/>
+        </p:nvSpPr>
+        <p:spPr>
+          <a:xfrm>
+            <a:off x="914400" y="4572000"/>
+            <a:ext cx="10362895" cy="731520"/>
+          </a:xfrm>
+          <a:prstGeom prst="rect">
+            <a:avLst/>
+          </a:prstGeom>
+          <a:noFill/>
+        </p:spPr>
+        <p:txBody>
+          <a:bodyPr wrap="square">
+            <a:spAutoFit/>
+          </a:bodyPr>
+          <a:lstStyle/>
+          <a:p>
+            <a:pPr algn="ctr"/>
+            <a:r>
+              <a:rPr sz="1600" b="0" i="1" u="none">
+                <a:solidFill>
+                  <a:srgbClr val="595959"/>
+                </a:solidFill>
+                <a:latin typeface="Arial"/>
+              </a:rPr>
+              <a:t>Three contributions for deploying Jev reliably in a real applicant-ranking pipeline.</a:t>
+            </a:r>
+          </a:p>
+        </p:txBody>
+      </p:sp>
+      <p:sp>
+        <p:nvSpPr>
+          <p:cNvPr id="8" name="TextBox 7"/>
+          <p:cNvSpPr txBox="1"/>
+          <p:nvPr/>
+        </p:nvSpPr>
+        <p:spPr>
+          <a:xfrm>
+            <a:off x="731520" y="6355080"/>
+            <a:ext cx="10728655" cy="365760"/>
+          </a:xfrm>
+          <a:prstGeom prst="rect">
+            <a:avLst/>
+          </a:prstGeom>
+          <a:noFill/>
+        </p:spPr>
+        <p:txBody>
+          <a:bodyPr wrap="square">
+            <a:spAutoFit/>
+          </a:bodyPr>
+          <a:lstStyle/>
+          <a:p>
+            <a:pPr algn="l"/>
+            <a:r>
+              <a:rPr sz="1200" b="0" i="1" u="none">
+                <a:solidFill>
+                  <a:srgbClr val="595959"/>
+                </a:solidFill>
+                <a:latin typeface="Arial"/>
+              </a:rPr>
+              <a:t>Section I — Introduction</a:t>
             </a:r>
           </a:p>
         </p:txBody>

</xml_diff>

<commit_message>
feat: rewrite ICAIDES deck, Slides 4-6 Background x2 + Architecture (3/6)
Adds the add_pipeline primitive: vertical outline boxes joined by a text
arrow, no filled shapes.

Co-Authored-By: Claude Sonnet 5 <noreply@anthropic.com>
</commit_message>
<xml_diff>
--- a/docs/presentation/icaides2026_jev.pptx
+++ b/docs/presentation/icaides2026_jev.pptx
@@ -8,6 +8,9 @@
     <p:sldId id="256" r:id="rId7"/>
     <p:sldId id="257" r:id="rId8"/>
     <p:sldId id="258" r:id="rId9"/>
+    <p:sldId id="259" r:id="rId10"/>
+    <p:sldId id="260" r:id="rId11"/>
+    <p:sldId id="261" r:id="rId12"/>
   </p:sldIdLst>
   <p:sldSz cx="12191695" cy="6858000" type="screen4x3"/>
   <p:notesSz cx="6858000" cy="9144000"/>
@@ -3797,6 +3800,981 @@
                 <a:latin typeface="Arial"/>
               </a:rPr>
               <a:t>Section I — Introduction</a:t>
+            </a:r>
+          </a:p>
+        </p:txBody>
+      </p:sp>
+    </p:spTree>
+  </p:cSld>
+  <p:clrMapOvr>
+    <a:masterClrMapping/>
+  </p:clrMapOvr>
+</p:sld>
+</file>
+
+<file path=ppt/slides/slide4.xml><?xml version="1.0" encoding="utf-8"?>
+<p:sld xmlns:a="http://schemas.openxmlformats.org/drawingml/2006/main" xmlns:p="http://schemas.openxmlformats.org/presentationml/2006/main" xmlns:r="http://schemas.openxmlformats.org/officeDocument/2006/relationships">
+  <p:cSld>
+    <p:bg>
+      <p:bgPr>
+        <a:solidFill>
+          <a:srgbClr val="FFFFFF"/>
+        </a:solidFill>
+        <a:effectLst/>
+      </p:bgPr>
+    </p:bg>
+    <p:spTree>
+      <p:nvGrpSpPr>
+        <p:cNvPr id="1" name=""/>
+        <p:cNvGrpSpPr/>
+        <p:nvPr/>
+      </p:nvGrpSpPr>
+      <p:grpSpPr/>
+      <p:sp>
+        <p:nvSpPr>
+          <p:cNvPr id="2" name="TextBox 1"/>
+          <p:cNvSpPr txBox="1"/>
+          <p:nvPr/>
+        </p:nvSpPr>
+        <p:spPr>
+          <a:xfrm>
+            <a:off x="731520" y="411480"/>
+            <a:ext cx="10728655" cy="320040"/>
+          </a:xfrm>
+          <a:prstGeom prst="rect">
+            <a:avLst/>
+          </a:prstGeom>
+          <a:noFill/>
+        </p:spPr>
+        <p:txBody>
+          <a:bodyPr wrap="square">
+            <a:spAutoFit/>
+          </a:bodyPr>
+          <a:lstStyle/>
+          <a:p>
+            <a:pPr algn="l"/>
+            <a:r>
+              <a:rPr sz="1300" b="1" i="0" u="none">
+                <a:solidFill>
+                  <a:srgbClr val="595959"/>
+                </a:solidFill>
+                <a:latin typeface="Arial"/>
+              </a:rPr>
+              <a:t>BACKGROUND</a:t>
+            </a:r>
+          </a:p>
+        </p:txBody>
+      </p:sp>
+      <p:sp>
+        <p:nvSpPr>
+          <p:cNvPr id="3" name="TextBox 2"/>
+          <p:cNvSpPr txBox="1"/>
+          <p:nvPr/>
+        </p:nvSpPr>
+        <p:spPr>
+          <a:xfrm>
+            <a:off x="731520" y="777240"/>
+            <a:ext cx="10728655" cy="1005840"/>
+          </a:xfrm>
+          <a:prstGeom prst="rect">
+            <a:avLst/>
+          </a:prstGeom>
+          <a:noFill/>
+        </p:spPr>
+        <p:txBody>
+          <a:bodyPr wrap="square">
+            <a:spAutoFit/>
+          </a:bodyPr>
+          <a:lstStyle/>
+          <a:p>
+            <a:pPr algn="l"/>
+            <a:r>
+              <a:rPr sz="3000" b="1" i="0" u="none">
+                <a:solidFill>
+                  <a:srgbClr val="000000"/>
+                </a:solidFill>
+                <a:latin typeface="Arial"/>
+              </a:rPr>
+              <a:t>What Is a System One Model</a:t>
+            </a:r>
+          </a:p>
+        </p:txBody>
+      </p:sp>
+      <p:sp>
+        <p:nvSpPr>
+          <p:cNvPr id="4" name="TextBox 3"/>
+          <p:cNvSpPr txBox="1"/>
+          <p:nvPr/>
+        </p:nvSpPr>
+        <p:spPr>
+          <a:xfrm>
+            <a:off x="1005840" y="2103120"/>
+            <a:ext cx="10180015" cy="3200400"/>
+          </a:xfrm>
+          <a:prstGeom prst="rect">
+            <a:avLst/>
+          </a:prstGeom>
+          <a:noFill/>
+        </p:spPr>
+        <p:txBody>
+          <a:bodyPr wrap="square">
+            <a:spAutoFit/>
+          </a:bodyPr>
+          <a:lstStyle/>
+          <a:p>
+            <a:pPr>
+              <a:spcAft>
+                <a:spcPts val="1200"/>
+              </a:spcAft>
+            </a:pPr>
+            <a:r>
+              <a:rPr sz="2000">
+                <a:solidFill>
+                  <a:srgbClr val="000000"/>
+                </a:solidFill>
+                <a:latin typeface="Arial"/>
+              </a:rPr>
+              <a:t>•  Non-autoregressive: answers typed questions in one parallel pass — no generated tokens.</a:t>
+            </a:r>
+          </a:p>
+          <a:p>
+            <a:pPr>
+              <a:spcAft>
+                <a:spcPts val="1200"/>
+              </a:spcAft>
+            </a:pPr>
+            <a:r>
+              <a:rPr sz="2000">
+                <a:solidFill>
+                  <a:srgbClr val="000000"/>
+                </a:solidFill>
+                <a:latin typeface="Arial"/>
+              </a:rPr>
+              <a:t>•  Three typed primitives: Noul (yes/no + confidence), Choice (multiple-choice), Score (ordinal scale).</a:t>
+            </a:r>
+          </a:p>
+          <a:p>
+            <a:pPr>
+              <a:spcAft>
+                <a:spcPts val="1200"/>
+              </a:spcAft>
+            </a:pPr>
+            <a:r>
+              <a:rPr sz="2000">
+                <a:solidFill>
+                  <a:srgbClr val="000000"/>
+                </a:solidFill>
+                <a:latin typeface="Arial"/>
+              </a:rPr>
+              <a:t>•  This paper's questions all use Score.</a:t>
+            </a:r>
+          </a:p>
+        </p:txBody>
+      </p:sp>
+      <p:sp>
+        <p:nvSpPr>
+          <p:cNvPr id="5" name="TextBox 4"/>
+          <p:cNvSpPr txBox="1"/>
+          <p:nvPr/>
+        </p:nvSpPr>
+        <p:spPr>
+          <a:xfrm>
+            <a:off x="731520" y="6355080"/>
+            <a:ext cx="10728655" cy="365760"/>
+          </a:xfrm>
+          <a:prstGeom prst="rect">
+            <a:avLst/>
+          </a:prstGeom>
+          <a:noFill/>
+        </p:spPr>
+        <p:txBody>
+          <a:bodyPr wrap="square">
+            <a:spAutoFit/>
+          </a:bodyPr>
+          <a:lstStyle/>
+          <a:p>
+            <a:pPr algn="l"/>
+            <a:r>
+              <a:rPr sz="1200" b="0" i="1" u="none">
+                <a:solidFill>
+                  <a:srgbClr val="595959"/>
+                </a:solidFill>
+                <a:latin typeface="Arial"/>
+              </a:rPr>
+              <a:t>Section II — Literature Review</a:t>
+            </a:r>
+          </a:p>
+        </p:txBody>
+      </p:sp>
+    </p:spTree>
+  </p:cSld>
+  <p:clrMapOvr>
+    <a:masterClrMapping/>
+  </p:clrMapOvr>
+</p:sld>
+</file>
+
+<file path=ppt/slides/slide5.xml><?xml version="1.0" encoding="utf-8"?>
+<p:sld xmlns:a="http://schemas.openxmlformats.org/drawingml/2006/main" xmlns:p="http://schemas.openxmlformats.org/presentationml/2006/main" xmlns:r="http://schemas.openxmlformats.org/officeDocument/2006/relationships">
+  <p:cSld>
+    <p:bg>
+      <p:bgPr>
+        <a:solidFill>
+          <a:srgbClr val="FFFFFF"/>
+        </a:solidFill>
+        <a:effectLst/>
+      </p:bgPr>
+    </p:bg>
+    <p:spTree>
+      <p:nvGrpSpPr>
+        <p:cNvPr id="1" name=""/>
+        <p:cNvGrpSpPr/>
+        <p:nvPr/>
+      </p:nvGrpSpPr>
+      <p:grpSpPr/>
+      <p:sp>
+        <p:nvSpPr>
+          <p:cNvPr id="2" name="TextBox 1"/>
+          <p:cNvSpPr txBox="1"/>
+          <p:nvPr/>
+        </p:nvSpPr>
+        <p:spPr>
+          <a:xfrm>
+            <a:off x="731520" y="411480"/>
+            <a:ext cx="10728655" cy="320040"/>
+          </a:xfrm>
+          <a:prstGeom prst="rect">
+            <a:avLst/>
+          </a:prstGeom>
+          <a:noFill/>
+        </p:spPr>
+        <p:txBody>
+          <a:bodyPr wrap="square">
+            <a:spAutoFit/>
+          </a:bodyPr>
+          <a:lstStyle/>
+          <a:p>
+            <a:pPr algn="l"/>
+            <a:r>
+              <a:rPr sz="1300" b="1" i="0" u="none">
+                <a:solidFill>
+                  <a:srgbClr val="595959"/>
+                </a:solidFill>
+                <a:latin typeface="Arial"/>
+              </a:rPr>
+              <a:t>BACKGROUND</a:t>
+            </a:r>
+          </a:p>
+        </p:txBody>
+      </p:sp>
+      <p:sp>
+        <p:nvSpPr>
+          <p:cNvPr id="3" name="TextBox 2"/>
+          <p:cNvSpPr txBox="1"/>
+          <p:nvPr/>
+        </p:nvSpPr>
+        <p:spPr>
+          <a:xfrm>
+            <a:off x="731520" y="777240"/>
+            <a:ext cx="10728655" cy="1005840"/>
+          </a:xfrm>
+          <a:prstGeom prst="rect">
+            <a:avLst/>
+          </a:prstGeom>
+          <a:noFill/>
+        </p:spPr>
+        <p:txBody>
+          <a:bodyPr wrap="square">
+            <a:spAutoFit/>
+          </a:bodyPr>
+          <a:lstStyle/>
+          <a:p>
+            <a:pPr algn="l"/>
+            <a:r>
+              <a:rPr sz="3000" b="1" i="0" u="none">
+                <a:solidFill>
+                  <a:srgbClr val="000000"/>
+                </a:solidFill>
+                <a:latin typeface="Arial"/>
+              </a:rPr>
+              <a:t>Why It Works</a:t>
+            </a:r>
+          </a:p>
+        </p:txBody>
+      </p:sp>
+      <p:sp>
+        <p:nvSpPr>
+          <p:cNvPr id="4" name="TextBox 3"/>
+          <p:cNvSpPr txBox="1"/>
+          <p:nvPr/>
+        </p:nvSpPr>
+        <p:spPr>
+          <a:xfrm>
+            <a:off x="1005840" y="2103120"/>
+            <a:ext cx="10180015" cy="3200400"/>
+          </a:xfrm>
+          <a:prstGeom prst="rect">
+            <a:avLst/>
+          </a:prstGeom>
+          <a:noFill/>
+        </p:spPr>
+        <p:txBody>
+          <a:bodyPr wrap="square">
+            <a:spAutoFit/>
+          </a:bodyPr>
+          <a:lstStyle/>
+          <a:p>
+            <a:pPr>
+              <a:spcAft>
+                <a:spcPts val="1200"/>
+              </a:spcAft>
+            </a:pPr>
+            <a:r>
+              <a:rPr sz="2000">
+                <a:solidFill>
+                  <a:srgbClr val="000000"/>
+                </a:solidFill>
+                <a:latin typeface="Arial"/>
+              </a:rPr>
+              <a:t>•  Each Score level is judged alone — no view of neighboring levels, so a bare number carries no signal.</a:t>
+            </a:r>
+          </a:p>
+          <a:p>
+            <a:pPr>
+              <a:spcAft>
+                <a:spcPts val="1200"/>
+              </a:spcAft>
+            </a:pPr>
+            <a:r>
+              <a:rPr sz="2000">
+                <a:solidFill>
+                  <a:srgbClr val="000000"/>
+                </a:solidFill>
+                <a:latin typeface="Arial"/>
+              </a:rPr>
+              <a:t>•  A concrete situation gives the model resume evidence to check against.</a:t>
+            </a:r>
+          </a:p>
+          <a:p>
+            <a:pPr>
+              <a:spcAft>
+                <a:spcPts val="1200"/>
+              </a:spcAft>
+            </a:pPr>
+            <a:r>
+              <a:rPr sz="2000">
+                <a:solidFill>
+                  <a:srgbClr val="000000"/>
+                </a:solidFill>
+                <a:latin typeface="Arial"/>
+              </a:rPr>
+              <a:t>•  Trained via RLCD, a reward for calibration — not human preference (RLHF) or a verifiable outcome (RLVR).</a:t>
+            </a:r>
+          </a:p>
+        </p:txBody>
+      </p:sp>
+      <p:sp>
+        <p:nvSpPr>
+          <p:cNvPr id="5" name="TextBox 4"/>
+          <p:cNvSpPr txBox="1"/>
+          <p:nvPr/>
+        </p:nvSpPr>
+        <p:spPr>
+          <a:xfrm>
+            <a:off x="731520" y="6355080"/>
+            <a:ext cx="10728655" cy="365760"/>
+          </a:xfrm>
+          <a:prstGeom prst="rect">
+            <a:avLst/>
+          </a:prstGeom>
+          <a:noFill/>
+        </p:spPr>
+        <p:txBody>
+          <a:bodyPr wrap="square">
+            <a:spAutoFit/>
+          </a:bodyPr>
+          <a:lstStyle/>
+          <a:p>
+            <a:pPr algn="l"/>
+            <a:r>
+              <a:rPr sz="1200" b="0" i="1" u="none">
+                <a:solidFill>
+                  <a:srgbClr val="595959"/>
+                </a:solidFill>
+                <a:latin typeface="Arial"/>
+              </a:rPr>
+              <a:t>Section II — Literature Review</a:t>
+            </a:r>
+          </a:p>
+        </p:txBody>
+      </p:sp>
+    </p:spTree>
+  </p:cSld>
+  <p:clrMapOvr>
+    <a:masterClrMapping/>
+  </p:clrMapOvr>
+</p:sld>
+</file>
+
+<file path=ppt/slides/slide6.xml><?xml version="1.0" encoding="utf-8"?>
+<p:sld xmlns:a="http://schemas.openxmlformats.org/drawingml/2006/main" xmlns:p="http://schemas.openxmlformats.org/presentationml/2006/main" xmlns:r="http://schemas.openxmlformats.org/officeDocument/2006/relationships">
+  <p:cSld>
+    <p:bg>
+      <p:bgPr>
+        <a:solidFill>
+          <a:srgbClr val="FFFFFF"/>
+        </a:solidFill>
+        <a:effectLst/>
+      </p:bgPr>
+    </p:bg>
+    <p:spTree>
+      <p:nvGrpSpPr>
+        <p:cNvPr id="1" name=""/>
+        <p:cNvGrpSpPr/>
+        <p:nvPr/>
+      </p:nvGrpSpPr>
+      <p:grpSpPr/>
+      <p:sp>
+        <p:nvSpPr>
+          <p:cNvPr id="2" name="TextBox 1"/>
+          <p:cNvSpPr txBox="1"/>
+          <p:nvPr/>
+        </p:nvSpPr>
+        <p:spPr>
+          <a:xfrm>
+            <a:off x="731520" y="411480"/>
+            <a:ext cx="10728655" cy="320040"/>
+          </a:xfrm>
+          <a:prstGeom prst="rect">
+            <a:avLst/>
+          </a:prstGeom>
+          <a:noFill/>
+        </p:spPr>
+        <p:txBody>
+          <a:bodyPr wrap="square">
+            <a:spAutoFit/>
+          </a:bodyPr>
+          <a:lstStyle/>
+          <a:p>
+            <a:pPr algn="l"/>
+            <a:r>
+              <a:rPr sz="1300" b="1" i="0" u="none">
+                <a:solidFill>
+                  <a:srgbClr val="595959"/>
+                </a:solidFill>
+                <a:latin typeface="Arial"/>
+              </a:rPr>
+              <a:t>METHODOLOGY</a:t>
+            </a:r>
+          </a:p>
+        </p:txBody>
+      </p:sp>
+      <p:sp>
+        <p:nvSpPr>
+          <p:cNvPr id="3" name="TextBox 2"/>
+          <p:cNvSpPr txBox="1"/>
+          <p:nvPr/>
+        </p:nvSpPr>
+        <p:spPr>
+          <a:xfrm>
+            <a:off x="731520" y="777240"/>
+            <a:ext cx="10728655" cy="1005840"/>
+          </a:xfrm>
+          <a:prstGeom prst="rect">
+            <a:avLst/>
+          </a:prstGeom>
+          <a:noFill/>
+        </p:spPr>
+        <p:txBody>
+          <a:bodyPr wrap="square">
+            <a:spAutoFit/>
+          </a:bodyPr>
+          <a:lstStyle/>
+          <a:p>
+            <a:pPr algn="l"/>
+            <a:r>
+              <a:rPr sz="3000" b="1" i="0" u="none">
+                <a:solidFill>
+                  <a:srgbClr val="000000"/>
+                </a:solidFill>
+                <a:latin typeface="Arial"/>
+              </a:rPr>
+              <a:t>Architecture</a:t>
+            </a:r>
+          </a:p>
+        </p:txBody>
+      </p:sp>
+      <p:sp>
+        <p:nvSpPr>
+          <p:cNvPr id="4" name="Rectangle 3"/>
+          <p:cNvSpPr/>
+          <p:nvPr/>
+        </p:nvSpPr>
+        <p:spPr>
+          <a:xfrm>
+            <a:off x="2529687" y="1371600"/>
+            <a:ext cx="7132320" cy="530352"/>
+          </a:xfrm>
+          <a:prstGeom prst="rect">
+            <a:avLst/>
+          </a:prstGeom>
+          <a:noFill/>
+          <a:ln w="19050">
+            <a:solidFill>
+              <a:srgbClr val="000000"/>
+            </a:solidFill>
+          </a:ln>
+          <a:effectLst/>
+        </p:spPr>
+        <p:style>
+          <a:lnRef idx="1">
+            <a:schemeClr val="accent1"/>
+          </a:lnRef>
+          <a:fillRef idx="3">
+            <a:schemeClr val="accent1"/>
+          </a:fillRef>
+          <a:effectRef idx="2">
+            <a:schemeClr val="accent1"/>
+          </a:effectRef>
+          <a:fontRef idx="minor">
+            <a:schemeClr val="lt1"/>
+          </a:fontRef>
+        </p:style>
+        <p:txBody>
+          <a:bodyPr rtlCol="0" anchor="ctr" wrap="square" lIns="127000" rIns="127000"/>
+          <a:lstStyle/>
+          <a:p>
+            <a:pPr algn="ctr"/>
+            <a:r>
+              <a:rPr sz="1400" b="0">
+                <a:solidFill>
+                  <a:srgbClr val="000000"/>
+                </a:solidFill>
+                <a:latin typeface="Arial"/>
+              </a:rPr>
+              <a:t>Extraction &amp; Skill Classification</a:t>
+            </a:r>
+          </a:p>
+        </p:txBody>
+      </p:sp>
+      <p:sp>
+        <p:nvSpPr>
+          <p:cNvPr id="5" name="TextBox 4"/>
+          <p:cNvSpPr txBox="1"/>
+          <p:nvPr/>
+        </p:nvSpPr>
+        <p:spPr>
+          <a:xfrm>
+            <a:off x="2529687" y="1901952"/>
+            <a:ext cx="7132320" cy="329184"/>
+          </a:xfrm>
+          <a:prstGeom prst="rect">
+            <a:avLst/>
+          </a:prstGeom>
+          <a:noFill/>
+        </p:spPr>
+        <p:txBody>
+          <a:bodyPr wrap="square">
+            <a:spAutoFit/>
+          </a:bodyPr>
+          <a:lstStyle/>
+          <a:p>
+            <a:pPr algn="ctr"/>
+            <a:r>
+              <a:rPr sz="1600" b="0" i="0" u="none">
+                <a:solidFill>
+                  <a:srgbClr val="000000"/>
+                </a:solidFill>
+                <a:latin typeface="Arial"/>
+              </a:rPr>
+              <a:t>↓</a:t>
+            </a:r>
+          </a:p>
+        </p:txBody>
+      </p:sp>
+      <p:sp>
+        <p:nvSpPr>
+          <p:cNvPr id="6" name="Rectangle 5"/>
+          <p:cNvSpPr/>
+          <p:nvPr/>
+        </p:nvSpPr>
+        <p:spPr>
+          <a:xfrm>
+            <a:off x="2529687" y="2231136"/>
+            <a:ext cx="7132320" cy="530352"/>
+          </a:xfrm>
+          <a:prstGeom prst="rect">
+            <a:avLst/>
+          </a:prstGeom>
+          <a:noFill/>
+          <a:ln w="19050">
+            <a:solidFill>
+              <a:srgbClr val="000000"/>
+            </a:solidFill>
+          </a:ln>
+          <a:effectLst/>
+        </p:spPr>
+        <p:style>
+          <a:lnRef idx="1">
+            <a:schemeClr val="accent1"/>
+          </a:lnRef>
+          <a:fillRef idx="3">
+            <a:schemeClr val="accent1"/>
+          </a:fillRef>
+          <a:effectRef idx="2">
+            <a:schemeClr val="accent1"/>
+          </a:effectRef>
+          <a:fontRef idx="minor">
+            <a:schemeClr val="lt1"/>
+          </a:fontRef>
+        </p:style>
+        <p:txBody>
+          <a:bodyPr rtlCol="0" anchor="ctr" wrap="square" lIns="127000" rIns="127000"/>
+          <a:lstStyle/>
+          <a:p>
+            <a:pPr algn="ctr"/>
+            <a:r>
+              <a:rPr sz="1400" b="0">
+                <a:solidFill>
+                  <a:srgbClr val="000000"/>
+                </a:solidFill>
+                <a:latin typeface="Arial"/>
+              </a:rPr>
+              <a:t>Shortlisting</a:t>
+            </a:r>
+          </a:p>
+        </p:txBody>
+      </p:sp>
+      <p:sp>
+        <p:nvSpPr>
+          <p:cNvPr id="7" name="TextBox 6"/>
+          <p:cNvSpPr txBox="1"/>
+          <p:nvPr/>
+        </p:nvSpPr>
+        <p:spPr>
+          <a:xfrm>
+            <a:off x="2529687" y="2761488"/>
+            <a:ext cx="7132320" cy="329184"/>
+          </a:xfrm>
+          <a:prstGeom prst="rect">
+            <a:avLst/>
+          </a:prstGeom>
+          <a:noFill/>
+        </p:spPr>
+        <p:txBody>
+          <a:bodyPr wrap="square">
+            <a:spAutoFit/>
+          </a:bodyPr>
+          <a:lstStyle/>
+          <a:p>
+            <a:pPr algn="ctr"/>
+            <a:r>
+              <a:rPr sz="1600" b="0" i="0" u="none">
+                <a:solidFill>
+                  <a:srgbClr val="000000"/>
+                </a:solidFill>
+                <a:latin typeface="Arial"/>
+              </a:rPr>
+              <a:t>↓</a:t>
+            </a:r>
+          </a:p>
+        </p:txBody>
+      </p:sp>
+      <p:sp>
+        <p:nvSpPr>
+          <p:cNvPr id="8" name="Rectangle 7"/>
+          <p:cNvSpPr/>
+          <p:nvPr/>
+        </p:nvSpPr>
+        <p:spPr>
+          <a:xfrm>
+            <a:off x="2529687" y="3090672"/>
+            <a:ext cx="7132320" cy="530352"/>
+          </a:xfrm>
+          <a:prstGeom prst="rect">
+            <a:avLst/>
+          </a:prstGeom>
+          <a:noFill/>
+          <a:ln w="19050">
+            <a:solidFill>
+              <a:srgbClr val="000000"/>
+            </a:solidFill>
+          </a:ln>
+          <a:effectLst/>
+        </p:spPr>
+        <p:style>
+          <a:lnRef idx="1">
+            <a:schemeClr val="accent1"/>
+          </a:lnRef>
+          <a:fillRef idx="3">
+            <a:schemeClr val="accent1"/>
+          </a:fillRef>
+          <a:effectRef idx="2">
+            <a:schemeClr val="accent1"/>
+          </a:effectRef>
+          <a:fontRef idx="minor">
+            <a:schemeClr val="lt1"/>
+          </a:fontRef>
+        </p:style>
+        <p:txBody>
+          <a:bodyPr rtlCol="0" anchor="ctr" wrap="square" lIns="127000" rIns="127000"/>
+          <a:lstStyle/>
+          <a:p>
+            <a:pPr algn="ctr"/>
+            <a:r>
+              <a:rPr sz="1400" b="1">
+                <a:solidFill>
+                  <a:srgbClr val="000000"/>
+                </a:solidFill>
+                <a:latin typeface="Arial"/>
+              </a:rPr>
+              <a:t>Structured Assessment via Jev — parallel calls</a:t>
+            </a:r>
+          </a:p>
+        </p:txBody>
+      </p:sp>
+      <p:sp>
+        <p:nvSpPr>
+          <p:cNvPr id="9" name="TextBox 8"/>
+          <p:cNvSpPr txBox="1"/>
+          <p:nvPr/>
+        </p:nvSpPr>
+        <p:spPr>
+          <a:xfrm>
+            <a:off x="2529687" y="3621024"/>
+            <a:ext cx="7132320" cy="329184"/>
+          </a:xfrm>
+          <a:prstGeom prst="rect">
+            <a:avLst/>
+          </a:prstGeom>
+          <a:noFill/>
+        </p:spPr>
+        <p:txBody>
+          <a:bodyPr wrap="square">
+            <a:spAutoFit/>
+          </a:bodyPr>
+          <a:lstStyle/>
+          <a:p>
+            <a:pPr algn="ctr"/>
+            <a:r>
+              <a:rPr sz="1600" b="0" i="0" u="none">
+                <a:solidFill>
+                  <a:srgbClr val="000000"/>
+                </a:solidFill>
+                <a:latin typeface="Arial"/>
+              </a:rPr>
+              <a:t>↓</a:t>
+            </a:r>
+          </a:p>
+        </p:txBody>
+      </p:sp>
+      <p:sp>
+        <p:nvSpPr>
+          <p:cNvPr id="10" name="Rectangle 9"/>
+          <p:cNvSpPr/>
+          <p:nvPr/>
+        </p:nvSpPr>
+        <p:spPr>
+          <a:xfrm>
+            <a:off x="2529687" y="3950208"/>
+            <a:ext cx="7132320" cy="530352"/>
+          </a:xfrm>
+          <a:prstGeom prst="rect">
+            <a:avLst/>
+          </a:prstGeom>
+          <a:noFill/>
+          <a:ln w="19050">
+            <a:solidFill>
+              <a:srgbClr val="000000"/>
+            </a:solidFill>
+          </a:ln>
+          <a:effectLst/>
+        </p:spPr>
+        <p:style>
+          <a:lnRef idx="1">
+            <a:schemeClr val="accent1"/>
+          </a:lnRef>
+          <a:fillRef idx="3">
+            <a:schemeClr val="accent1"/>
+          </a:fillRef>
+          <a:effectRef idx="2">
+            <a:schemeClr val="accent1"/>
+          </a:effectRef>
+          <a:fontRef idx="minor">
+            <a:schemeClr val="lt1"/>
+          </a:fontRef>
+        </p:style>
+        <p:txBody>
+          <a:bodyPr rtlCol="0" anchor="ctr" wrap="square" lIns="127000" rIns="127000"/>
+          <a:lstStyle/>
+          <a:p>
+            <a:pPr algn="ctr"/>
+            <a:r>
+              <a:rPr sz="1400" b="1">
+                <a:solidFill>
+                  <a:srgbClr val="000000"/>
+                </a:solidFill>
+                <a:latin typeface="Arial"/>
+              </a:rPr>
+              <a:t>Direct Sort</a:t>
+            </a:r>
+          </a:p>
+        </p:txBody>
+      </p:sp>
+      <p:sp>
+        <p:nvSpPr>
+          <p:cNvPr id="11" name="TextBox 10"/>
+          <p:cNvSpPr txBox="1"/>
+          <p:nvPr/>
+        </p:nvSpPr>
+        <p:spPr>
+          <a:xfrm>
+            <a:off x="2529687" y="4480560"/>
+            <a:ext cx="7132320" cy="329184"/>
+          </a:xfrm>
+          <a:prstGeom prst="rect">
+            <a:avLst/>
+          </a:prstGeom>
+          <a:noFill/>
+        </p:spPr>
+        <p:txBody>
+          <a:bodyPr wrap="square">
+            <a:spAutoFit/>
+          </a:bodyPr>
+          <a:lstStyle/>
+          <a:p>
+            <a:pPr algn="ctr"/>
+            <a:r>
+              <a:rPr sz="1600" b="0" i="0" u="none">
+                <a:solidFill>
+                  <a:srgbClr val="000000"/>
+                </a:solidFill>
+                <a:latin typeface="Arial"/>
+              </a:rPr>
+              <a:t>↓</a:t>
+            </a:r>
+          </a:p>
+        </p:txBody>
+      </p:sp>
+      <p:sp>
+        <p:nvSpPr>
+          <p:cNvPr id="12" name="Rectangle 11"/>
+          <p:cNvSpPr/>
+          <p:nvPr/>
+        </p:nvSpPr>
+        <p:spPr>
+          <a:xfrm>
+            <a:off x="2529687" y="4809744"/>
+            <a:ext cx="7132320" cy="530352"/>
+          </a:xfrm>
+          <a:prstGeom prst="rect">
+            <a:avLst/>
+          </a:prstGeom>
+          <a:noFill/>
+          <a:ln w="19050">
+            <a:solidFill>
+              <a:srgbClr val="000000"/>
+            </a:solidFill>
+          </a:ln>
+          <a:effectLst/>
+        </p:spPr>
+        <p:style>
+          <a:lnRef idx="1">
+            <a:schemeClr val="accent1"/>
+          </a:lnRef>
+          <a:fillRef idx="3">
+            <a:schemeClr val="accent1"/>
+          </a:fillRef>
+          <a:effectRef idx="2">
+            <a:schemeClr val="accent1"/>
+          </a:effectRef>
+          <a:fontRef idx="minor">
+            <a:schemeClr val="lt1"/>
+          </a:fontRef>
+        </p:style>
+        <p:txBody>
+          <a:bodyPr rtlCol="0" anchor="ctr" wrap="square" lIns="127000" rIns="127000"/>
+          <a:lstStyle/>
+          <a:p>
+            <a:pPr algn="ctr"/>
+            <a:r>
+              <a:rPr sz="1400" b="0">
+                <a:solidFill>
+                  <a:srgbClr val="000000"/>
+                </a:solidFill>
+                <a:latin typeface="Arial"/>
+              </a:rPr>
+              <a:t>Score Breakdown Test (offline)</a:t>
+            </a:r>
+          </a:p>
+        </p:txBody>
+      </p:sp>
+      <p:sp>
+        <p:nvSpPr>
+          <p:cNvPr id="13" name="TextBox 12"/>
+          <p:cNvSpPr txBox="1"/>
+          <p:nvPr/>
+        </p:nvSpPr>
+        <p:spPr>
+          <a:xfrm>
+            <a:off x="914400" y="5532120"/>
+            <a:ext cx="10362895" cy="548640"/>
+          </a:xfrm>
+          <a:prstGeom prst="rect">
+            <a:avLst/>
+          </a:prstGeom>
+          <a:noFill/>
+        </p:spPr>
+        <p:txBody>
+          <a:bodyPr wrap="square">
+            <a:spAutoFit/>
+          </a:bodyPr>
+          <a:lstStyle/>
+          <a:p>
+            <a:pPr algn="ctr"/>
+            <a:r>
+              <a:rPr sz="1500" b="0" i="1" u="none">
+                <a:solidFill>
+                  <a:srgbClr val="595959"/>
+                </a:solidFill>
+                <a:latin typeface="Arial"/>
+              </a:rPr>
+              <a:t>Steps 1–2 are unchanged from the prior system. Contributions 1 and 2 are steps 3 and 4.</a:t>
+            </a:r>
+          </a:p>
+        </p:txBody>
+      </p:sp>
+      <p:sp>
+        <p:nvSpPr>
+          <p:cNvPr id="14" name="TextBox 13"/>
+          <p:cNvSpPr txBox="1"/>
+          <p:nvPr/>
+        </p:nvSpPr>
+        <p:spPr>
+          <a:xfrm>
+            <a:off x="731520" y="6355080"/>
+            <a:ext cx="10728655" cy="365760"/>
+          </a:xfrm>
+          <a:prstGeom prst="rect">
+            <a:avLst/>
+          </a:prstGeom>
+          <a:noFill/>
+        </p:spPr>
+        <p:txBody>
+          <a:bodyPr wrap="square">
+            <a:spAutoFit/>
+          </a:bodyPr>
+          <a:lstStyle/>
+          <a:p>
+            <a:pPr algn="l"/>
+            <a:r>
+              <a:rPr sz="1200" b="0" i="1" u="none">
+                <a:solidFill>
+                  <a:srgbClr val="595959"/>
+                </a:solidFill>
+                <a:latin typeface="Arial"/>
+              </a:rPr>
+              <a:t>Section III — Methodology</a:t>
             </a:r>
           </a:p>
         </p:txBody>

</xml_diff>

<commit_message>
feat: rewrite ICAIDES deck, Slides 7-9 Contributions + Setup (4/6)
Adds the add_compare primitive: two outline-box columns joined by a text
arrow, no filled shapes.

Co-Authored-By: Claude Sonnet 5 <noreply@anthropic.com>
</commit_message>
<xml_diff>
--- a/docs/presentation/icaides2026_jev.pptx
+++ b/docs/presentation/icaides2026_jev.pptx
@@ -11,6 +11,9 @@
     <p:sldId id="259" r:id="rId10"/>
     <p:sldId id="260" r:id="rId11"/>
     <p:sldId id="261" r:id="rId12"/>
+    <p:sldId id="262" r:id="rId13"/>
+    <p:sldId id="263" r:id="rId14"/>
+    <p:sldId id="264" r:id="rId15"/>
   </p:sldIdLst>
   <p:sldSz cx="12191695" cy="6858000" type="screen4x3"/>
   <p:notesSz cx="6858000" cy="9144000"/>
@@ -4775,6 +4778,1560 @@
                 <a:latin typeface="Arial"/>
               </a:rPr>
               <a:t>Section III — Methodology</a:t>
+            </a:r>
+          </a:p>
+        </p:txBody>
+      </p:sp>
+    </p:spTree>
+  </p:cSld>
+  <p:clrMapOvr>
+    <a:masterClrMapping/>
+  </p:clrMapOvr>
+</p:sld>
+</file>
+
+<file path=ppt/slides/slide7.xml><?xml version="1.0" encoding="utf-8"?>
+<p:sld xmlns:a="http://schemas.openxmlformats.org/drawingml/2006/main" xmlns:p="http://schemas.openxmlformats.org/presentationml/2006/main" xmlns:r="http://schemas.openxmlformats.org/officeDocument/2006/relationships">
+  <p:cSld>
+    <p:bg>
+      <p:bgPr>
+        <a:solidFill>
+          <a:srgbClr val="FFFFFF"/>
+        </a:solidFill>
+        <a:effectLst/>
+      </p:bgPr>
+    </p:bg>
+    <p:spTree>
+      <p:nvGrpSpPr>
+        <p:cNvPr id="1" name=""/>
+        <p:cNvGrpSpPr/>
+        <p:nvPr/>
+      </p:nvGrpSpPr>
+      <p:grpSpPr/>
+      <p:sp>
+        <p:nvSpPr>
+          <p:cNvPr id="2" name="TextBox 1"/>
+          <p:cNvSpPr txBox="1"/>
+          <p:nvPr/>
+        </p:nvSpPr>
+        <p:spPr>
+          <a:xfrm>
+            <a:off x="731520" y="411480"/>
+            <a:ext cx="10728655" cy="320040"/>
+          </a:xfrm>
+          <a:prstGeom prst="rect">
+            <a:avLst/>
+          </a:prstGeom>
+          <a:noFill/>
+        </p:spPr>
+        <p:txBody>
+          <a:bodyPr wrap="square">
+            <a:spAutoFit/>
+          </a:bodyPr>
+          <a:lstStyle/>
+          <a:p>
+            <a:pPr algn="l"/>
+            <a:r>
+              <a:rPr sz="1300" b="1" i="0" u="none">
+                <a:solidFill>
+                  <a:srgbClr val="595959"/>
+                </a:solidFill>
+                <a:latin typeface="Arial"/>
+              </a:rPr>
+              <a:t>METHODOLOGY — CONTRIBUTION 1</a:t>
+            </a:r>
+          </a:p>
+        </p:txBody>
+      </p:sp>
+      <p:sp>
+        <p:nvSpPr>
+          <p:cNvPr id="3" name="TextBox 2"/>
+          <p:cNvSpPr txBox="1"/>
+          <p:nvPr/>
+        </p:nvSpPr>
+        <p:spPr>
+          <a:xfrm>
+            <a:off x="731520" y="777240"/>
+            <a:ext cx="10728655" cy="1005840"/>
+          </a:xfrm>
+          <a:prstGeom prst="rect">
+            <a:avLst/>
+          </a:prstGeom>
+          <a:noFill/>
+        </p:spPr>
+        <p:txBody>
+          <a:bodyPr wrap="square">
+            <a:spAutoFit/>
+          </a:bodyPr>
+          <a:lstStyle/>
+          <a:p>
+            <a:pPr algn="l"/>
+            <a:r>
+              <a:rPr sz="3000" b="1" i="0" u="none">
+                <a:solidFill>
+                  <a:srgbClr val="000000"/>
+                </a:solidFill>
+                <a:latin typeface="Arial"/>
+              </a:rPr>
+              <a:t>Criteria-Grounded Question Design</a:t>
+            </a:r>
+          </a:p>
+        </p:txBody>
+      </p:sp>
+      <p:sp>
+        <p:nvSpPr>
+          <p:cNvPr id="4" name="Rectangle 3"/>
+          <p:cNvSpPr/>
+          <p:nvPr/>
+        </p:nvSpPr>
+        <p:spPr>
+          <a:xfrm>
+            <a:off x="731520" y="1828800"/>
+            <a:ext cx="4846320" cy="3657600"/>
+          </a:xfrm>
+          <a:prstGeom prst="rect">
+            <a:avLst/>
+          </a:prstGeom>
+          <a:noFill/>
+          <a:ln w="19050">
+            <a:solidFill>
+              <a:srgbClr val="000000"/>
+            </a:solidFill>
+          </a:ln>
+          <a:effectLst/>
+        </p:spPr>
+        <p:style>
+          <a:lnRef idx="1">
+            <a:schemeClr val="accent1"/>
+          </a:lnRef>
+          <a:fillRef idx="3">
+            <a:schemeClr val="accent1"/>
+          </a:fillRef>
+          <a:effectRef idx="2">
+            <a:schemeClr val="accent1"/>
+          </a:effectRef>
+          <a:fontRef idx="minor">
+            <a:schemeClr val="lt1"/>
+          </a:fontRef>
+        </p:style>
+        <p:txBody>
+          <a:bodyPr rtlCol="0" anchor="ctr"/>
+          <a:lstStyle/>
+          <a:p>
+            <a:pPr algn="ctr"/>
+          </a:p>
+        </p:txBody>
+      </p:sp>
+      <p:sp>
+        <p:nvSpPr>
+          <p:cNvPr id="5" name="TextBox 4"/>
+          <p:cNvSpPr txBox="1"/>
+          <p:nvPr/>
+        </p:nvSpPr>
+        <p:spPr>
+          <a:xfrm>
+            <a:off x="914400" y="1965960"/>
+            <a:ext cx="4480560" cy="457200"/>
+          </a:xfrm>
+          <a:prstGeom prst="rect">
+            <a:avLst/>
+          </a:prstGeom>
+          <a:noFill/>
+        </p:spPr>
+        <p:txBody>
+          <a:bodyPr wrap="square">
+            <a:spAutoFit/>
+          </a:bodyPr>
+          <a:lstStyle/>
+          <a:p>
+            <a:pPr algn="ctr"/>
+            <a:r>
+              <a:rPr sz="1800" b="1" i="0" u="none">
+                <a:solidFill>
+                  <a:srgbClr val="000000"/>
+                </a:solidFill>
+                <a:latin typeface="Arial"/>
+              </a:rPr>
+              <a:t>Bare Ordinal Scale</a:t>
+            </a:r>
+          </a:p>
+        </p:txBody>
+      </p:sp>
+      <p:sp>
+        <p:nvSpPr>
+          <p:cNvPr id="6" name="TextBox 5"/>
+          <p:cNvSpPr txBox="1"/>
+          <p:nvPr/>
+        </p:nvSpPr>
+        <p:spPr>
+          <a:xfrm>
+            <a:off x="1005840" y="2606040"/>
+            <a:ext cx="4297680" cy="2743200"/>
+          </a:xfrm>
+          <a:prstGeom prst="rect">
+            <a:avLst/>
+          </a:prstGeom>
+          <a:noFill/>
+        </p:spPr>
+        <p:txBody>
+          <a:bodyPr wrap="square">
+            <a:spAutoFit/>
+          </a:bodyPr>
+          <a:lstStyle/>
+          <a:p>
+            <a:pPr>
+              <a:spcAft>
+                <a:spcPts val="1200"/>
+              </a:spcAft>
+            </a:pPr>
+            <a:r>
+              <a:rPr sz="1500">
+                <a:solidFill>
+                  <a:srgbClr val="000000"/>
+                </a:solidFill>
+                <a:latin typeface="Arial"/>
+              </a:rPr>
+              <a:t>•  0, 25, 50, 75, 100</a:t>
+            </a:r>
+          </a:p>
+          <a:p>
+            <a:pPr>
+              <a:spcAft>
+                <a:spcPts val="1200"/>
+              </a:spcAft>
+            </a:pPr>
+            <a:r>
+              <a:rPr sz="1500">
+                <a:solidFill>
+                  <a:srgbClr val="000000"/>
+                </a:solidFill>
+                <a:latin typeface="Arial"/>
+              </a:rPr>
+              <a:t>•  Each level judged alone</a:t>
+            </a:r>
+          </a:p>
+          <a:p>
+            <a:pPr>
+              <a:spcAft>
+                <a:spcPts val="1200"/>
+              </a:spcAft>
+            </a:pPr>
+            <a:r>
+              <a:rPr sz="1500">
+                <a:solidFill>
+                  <a:srgbClr val="000000"/>
+                </a:solidFill>
+                <a:latin typeface="Arial"/>
+              </a:rPr>
+              <a:t>•  No evidence to check against</a:t>
+            </a:r>
+          </a:p>
+        </p:txBody>
+      </p:sp>
+      <p:sp>
+        <p:nvSpPr>
+          <p:cNvPr id="7" name="Rectangle 6"/>
+          <p:cNvSpPr/>
+          <p:nvPr/>
+        </p:nvSpPr>
+        <p:spPr>
+          <a:xfrm>
+            <a:off x="6613855" y="1828800"/>
+            <a:ext cx="4846320" cy="3657600"/>
+          </a:xfrm>
+          <a:prstGeom prst="rect">
+            <a:avLst/>
+          </a:prstGeom>
+          <a:noFill/>
+          <a:ln w="19050">
+            <a:solidFill>
+              <a:srgbClr val="000000"/>
+            </a:solidFill>
+          </a:ln>
+          <a:effectLst/>
+        </p:spPr>
+        <p:style>
+          <a:lnRef idx="1">
+            <a:schemeClr val="accent1"/>
+          </a:lnRef>
+          <a:fillRef idx="3">
+            <a:schemeClr val="accent1"/>
+          </a:fillRef>
+          <a:effectRef idx="2">
+            <a:schemeClr val="accent1"/>
+          </a:effectRef>
+          <a:fontRef idx="minor">
+            <a:schemeClr val="lt1"/>
+          </a:fontRef>
+        </p:style>
+        <p:txBody>
+          <a:bodyPr rtlCol="0" anchor="ctr"/>
+          <a:lstStyle/>
+          <a:p>
+            <a:pPr algn="ctr"/>
+          </a:p>
+        </p:txBody>
+      </p:sp>
+      <p:sp>
+        <p:nvSpPr>
+          <p:cNvPr id="8" name="TextBox 7"/>
+          <p:cNvSpPr txBox="1"/>
+          <p:nvPr/>
+        </p:nvSpPr>
+        <p:spPr>
+          <a:xfrm>
+            <a:off x="6796735" y="1965960"/>
+            <a:ext cx="4480560" cy="457200"/>
+          </a:xfrm>
+          <a:prstGeom prst="rect">
+            <a:avLst/>
+          </a:prstGeom>
+          <a:noFill/>
+        </p:spPr>
+        <p:txBody>
+          <a:bodyPr wrap="square">
+            <a:spAutoFit/>
+          </a:bodyPr>
+          <a:lstStyle/>
+          <a:p>
+            <a:pPr algn="ctr"/>
+            <a:r>
+              <a:rPr sz="1800" b="1" i="0" u="none">
+                <a:solidFill>
+                  <a:srgbClr val="000000"/>
+                </a:solidFill>
+                <a:latin typeface="Arial"/>
+              </a:rPr>
+              <a:t>Concrete Situation</a:t>
+            </a:r>
+          </a:p>
+        </p:txBody>
+      </p:sp>
+      <p:sp>
+        <p:nvSpPr>
+          <p:cNvPr id="9" name="TextBox 8"/>
+          <p:cNvSpPr txBox="1"/>
+          <p:nvPr/>
+        </p:nvSpPr>
+        <p:spPr>
+          <a:xfrm>
+            <a:off x="6888175" y="2606040"/>
+            <a:ext cx="4297680" cy="2743200"/>
+          </a:xfrm>
+          <a:prstGeom prst="rect">
+            <a:avLst/>
+          </a:prstGeom>
+          <a:noFill/>
+        </p:spPr>
+        <p:txBody>
+          <a:bodyPr wrap="square">
+            <a:spAutoFit/>
+          </a:bodyPr>
+          <a:lstStyle/>
+          <a:p>
+            <a:pPr>
+              <a:spcAft>
+                <a:spcPts val="1200"/>
+              </a:spcAft>
+            </a:pPr>
+            <a:r>
+              <a:rPr sz="1500">
+                <a:solidFill>
+                  <a:srgbClr val="000000"/>
+                </a:solidFill>
+                <a:latin typeface="Arial"/>
+              </a:rPr>
+              <a:t>•  “Skill only listed” vs. “used in a real role”</a:t>
+            </a:r>
+          </a:p>
+          <a:p>
+            <a:pPr>
+              <a:spcAft>
+                <a:spcPts val="1200"/>
+              </a:spcAft>
+            </a:pPr>
+            <a:r>
+              <a:rPr sz="1500">
+                <a:solidFill>
+                  <a:srgbClr val="000000"/>
+                </a:solidFill>
+                <a:latin typeface="Arial"/>
+              </a:rPr>
+              <a:t>•  Each level still judged alone</a:t>
+            </a:r>
+          </a:p>
+          <a:p>
+            <a:pPr>
+              <a:spcAft>
+                <a:spcPts val="1200"/>
+              </a:spcAft>
+            </a:pPr>
+            <a:r>
+              <a:rPr sz="1500">
+                <a:solidFill>
+                  <a:srgbClr val="000000"/>
+                </a:solidFill>
+                <a:latin typeface="Arial"/>
+              </a:rPr>
+              <a:t>•  Gives Jev resume evidence to match</a:t>
+            </a:r>
+          </a:p>
+        </p:txBody>
+      </p:sp>
+      <p:sp>
+        <p:nvSpPr>
+          <p:cNvPr id="10" name="TextBox 9"/>
+          <p:cNvSpPr txBox="1"/>
+          <p:nvPr/>
+        </p:nvSpPr>
+        <p:spPr>
+          <a:xfrm>
+            <a:off x="5577840" y="3383280"/>
+            <a:ext cx="1036015" cy="548640"/>
+          </a:xfrm>
+          <a:prstGeom prst="rect">
+            <a:avLst/>
+          </a:prstGeom>
+          <a:noFill/>
+        </p:spPr>
+        <p:txBody>
+          <a:bodyPr wrap="square">
+            <a:spAutoFit/>
+          </a:bodyPr>
+          <a:lstStyle/>
+          <a:p>
+            <a:pPr algn="ctr"/>
+            <a:r>
+              <a:rPr sz="2800" b="0" i="0" u="none">
+                <a:solidFill>
+                  <a:srgbClr val="000000"/>
+                </a:solidFill>
+                <a:latin typeface="Arial"/>
+              </a:rPr>
+              <a:t>→</a:t>
+            </a:r>
+          </a:p>
+        </p:txBody>
+      </p:sp>
+      <p:sp>
+        <p:nvSpPr>
+          <p:cNvPr id="11" name="TextBox 10"/>
+          <p:cNvSpPr txBox="1"/>
+          <p:nvPr/>
+        </p:nvSpPr>
+        <p:spPr>
+          <a:xfrm>
+            <a:off x="731520" y="6355080"/>
+            <a:ext cx="10728655" cy="365760"/>
+          </a:xfrm>
+          <a:prstGeom prst="rect">
+            <a:avLst/>
+          </a:prstGeom>
+          <a:noFill/>
+        </p:spPr>
+        <p:txBody>
+          <a:bodyPr wrap="square">
+            <a:spAutoFit/>
+          </a:bodyPr>
+          <a:lstStyle/>
+          <a:p>
+            <a:pPr algn="l"/>
+            <a:r>
+              <a:rPr sz="1200" b="0" i="1" u="none">
+                <a:solidFill>
+                  <a:srgbClr val="595959"/>
+                </a:solidFill>
+                <a:latin typeface="Arial"/>
+              </a:rPr>
+              <a:t>Result: per-requirement confidence 0.672 → 0.894 (Results, ahead)</a:t>
+            </a:r>
+          </a:p>
+        </p:txBody>
+      </p:sp>
+    </p:spTree>
+  </p:cSld>
+  <p:clrMapOvr>
+    <a:masterClrMapping/>
+  </p:clrMapOvr>
+</p:sld>
+</file>
+
+<file path=ppt/slides/slide8.xml><?xml version="1.0" encoding="utf-8"?>
+<p:sld xmlns:a="http://schemas.openxmlformats.org/drawingml/2006/main" xmlns:p="http://schemas.openxmlformats.org/presentationml/2006/main" xmlns:r="http://schemas.openxmlformats.org/officeDocument/2006/relationships">
+  <p:cSld>
+    <p:bg>
+      <p:bgPr>
+        <a:solidFill>
+          <a:srgbClr val="FFFFFF"/>
+        </a:solidFill>
+        <a:effectLst/>
+      </p:bgPr>
+    </p:bg>
+    <p:spTree>
+      <p:nvGrpSpPr>
+        <p:cNvPr id="1" name=""/>
+        <p:cNvGrpSpPr/>
+        <p:nvPr/>
+      </p:nvGrpSpPr>
+      <p:grpSpPr/>
+      <p:sp>
+        <p:nvSpPr>
+          <p:cNvPr id="2" name="TextBox 1"/>
+          <p:cNvSpPr txBox="1"/>
+          <p:nvPr/>
+        </p:nvSpPr>
+        <p:spPr>
+          <a:xfrm>
+            <a:off x="731520" y="411480"/>
+            <a:ext cx="10728655" cy="320040"/>
+          </a:xfrm>
+          <a:prstGeom prst="rect">
+            <a:avLst/>
+          </a:prstGeom>
+          <a:noFill/>
+        </p:spPr>
+        <p:txBody>
+          <a:bodyPr wrap="square">
+            <a:spAutoFit/>
+          </a:bodyPr>
+          <a:lstStyle/>
+          <a:p>
+            <a:pPr algn="l"/>
+            <a:r>
+              <a:rPr sz="1300" b="1" i="0" u="none">
+                <a:solidFill>
+                  <a:srgbClr val="595959"/>
+                </a:solidFill>
+                <a:latin typeface="Arial"/>
+              </a:rPr>
+              <a:t>METHODOLOGY — CONTRIBUTION 2</a:t>
+            </a:r>
+          </a:p>
+        </p:txBody>
+      </p:sp>
+      <p:sp>
+        <p:nvSpPr>
+          <p:cNvPr id="3" name="TextBox 2"/>
+          <p:cNvSpPr txBox="1"/>
+          <p:nvPr/>
+        </p:nvSpPr>
+        <p:spPr>
+          <a:xfrm>
+            <a:off x="731520" y="777240"/>
+            <a:ext cx="10728655" cy="1005840"/>
+          </a:xfrm>
+          <a:prstGeom prst="rect">
+            <a:avLst/>
+          </a:prstGeom>
+          <a:noFill/>
+        </p:spPr>
+        <p:txBody>
+          <a:bodyPr wrap="square">
+            <a:spAutoFit/>
+          </a:bodyPr>
+          <a:lstStyle/>
+          <a:p>
+            <a:pPr algn="l"/>
+            <a:r>
+              <a:rPr sz="3000" b="1" i="0" u="none">
+                <a:solidFill>
+                  <a:srgbClr val="000000"/>
+                </a:solidFill>
+                <a:latin typeface="Arial"/>
+              </a:rPr>
+              <a:t>Direct Sort Ranking</a:t>
+            </a:r>
+          </a:p>
+        </p:txBody>
+      </p:sp>
+      <p:sp>
+        <p:nvSpPr>
+          <p:cNvPr id="4" name="Rectangle 3"/>
+          <p:cNvSpPr/>
+          <p:nvPr/>
+        </p:nvSpPr>
+        <p:spPr>
+          <a:xfrm>
+            <a:off x="731520" y="1828800"/>
+            <a:ext cx="4846320" cy="3657600"/>
+          </a:xfrm>
+          <a:prstGeom prst="rect">
+            <a:avLst/>
+          </a:prstGeom>
+          <a:noFill/>
+          <a:ln w="19050">
+            <a:solidFill>
+              <a:srgbClr val="000000"/>
+            </a:solidFill>
+          </a:ln>
+          <a:effectLst/>
+        </p:spPr>
+        <p:style>
+          <a:lnRef idx="1">
+            <a:schemeClr val="accent1"/>
+          </a:lnRef>
+          <a:fillRef idx="3">
+            <a:schemeClr val="accent1"/>
+          </a:fillRef>
+          <a:effectRef idx="2">
+            <a:schemeClr val="accent1"/>
+          </a:effectRef>
+          <a:fontRef idx="minor">
+            <a:schemeClr val="lt1"/>
+          </a:fontRef>
+        </p:style>
+        <p:txBody>
+          <a:bodyPr rtlCol="0" anchor="ctr"/>
+          <a:lstStyle/>
+          <a:p>
+            <a:pPr algn="ctr"/>
+          </a:p>
+        </p:txBody>
+      </p:sp>
+      <p:sp>
+        <p:nvSpPr>
+          <p:cNvPr id="5" name="TextBox 4"/>
+          <p:cNvSpPr txBox="1"/>
+          <p:nvPr/>
+        </p:nvSpPr>
+        <p:spPr>
+          <a:xfrm>
+            <a:off x="914400" y="1965960"/>
+            <a:ext cx="4480560" cy="457200"/>
+          </a:xfrm>
+          <a:prstGeom prst="rect">
+            <a:avLst/>
+          </a:prstGeom>
+          <a:noFill/>
+        </p:spPr>
+        <p:txBody>
+          <a:bodyPr wrap="square">
+            <a:spAutoFit/>
+          </a:bodyPr>
+          <a:lstStyle/>
+          <a:p>
+            <a:pPr algn="ctr"/>
+            <a:r>
+              <a:rPr sz="1800" b="1" i="0" u="none">
+                <a:solidFill>
+                  <a:srgbClr val="000000"/>
+                </a:solidFill>
+                <a:latin typeface="Arial"/>
+              </a:rPr>
+              <a:t>Iterative Tournament</a:t>
+            </a:r>
+          </a:p>
+        </p:txBody>
+      </p:sp>
+      <p:sp>
+        <p:nvSpPr>
+          <p:cNvPr id="6" name="TextBox 5"/>
+          <p:cNvSpPr txBox="1"/>
+          <p:nvPr/>
+        </p:nvSpPr>
+        <p:spPr>
+          <a:xfrm>
+            <a:off x="1005840" y="2606040"/>
+            <a:ext cx="4297680" cy="2743200"/>
+          </a:xfrm>
+          <a:prstGeom prst="rect">
+            <a:avLst/>
+          </a:prstGeom>
+          <a:noFill/>
+        </p:spPr>
+        <p:txBody>
+          <a:bodyPr wrap="square">
+            <a:spAutoFit/>
+          </a:bodyPr>
+          <a:lstStyle/>
+          <a:p>
+            <a:pPr>
+              <a:spcAft>
+                <a:spcPts val="1200"/>
+              </a:spcAft>
+            </a:pPr>
+            <a:r>
+              <a:rPr sz="1500">
+                <a:solidFill>
+                  <a:srgbClr val="000000"/>
+                </a:solidFill>
+                <a:latin typeface="Arial"/>
+              </a:rPr>
+              <a:t>•  Bayesian Plackett-Luce</a:t>
+            </a:r>
+          </a:p>
+          <a:p>
+            <a:pPr>
+              <a:spcAft>
+                <a:spcPts val="1200"/>
+              </a:spcAft>
+            </a:pPr>
+            <a:r>
+              <a:rPr sz="1500">
+                <a:solidFill>
+                  <a:srgbClr val="000000"/>
+                </a:solidFill>
+                <a:latin typeface="Arial"/>
+              </a:rPr>
+              <a:t>•  Round-by-round, waits on each iteration</a:t>
+            </a:r>
+          </a:p>
+          <a:p>
+            <a:pPr>
+              <a:spcAft>
+                <a:spcPts val="1200"/>
+              </a:spcAft>
+            </a:pPr>
+            <a:r>
+              <a:rPr sz="1500">
+                <a:solidFill>
+                  <a:srgbClr val="000000"/>
+                </a:solidFill>
+                <a:latin typeface="Arial"/>
+              </a:rPr>
+              <a:t>•  No parallelism</a:t>
+            </a:r>
+          </a:p>
+        </p:txBody>
+      </p:sp>
+      <p:sp>
+        <p:nvSpPr>
+          <p:cNvPr id="7" name="Rectangle 6"/>
+          <p:cNvSpPr/>
+          <p:nvPr/>
+        </p:nvSpPr>
+        <p:spPr>
+          <a:xfrm>
+            <a:off x="6613855" y="1828800"/>
+            <a:ext cx="4846320" cy="3657600"/>
+          </a:xfrm>
+          <a:prstGeom prst="rect">
+            <a:avLst/>
+          </a:prstGeom>
+          <a:noFill/>
+          <a:ln w="19050">
+            <a:solidFill>
+              <a:srgbClr val="000000"/>
+            </a:solidFill>
+          </a:ln>
+          <a:effectLst/>
+        </p:spPr>
+        <p:style>
+          <a:lnRef idx="1">
+            <a:schemeClr val="accent1"/>
+          </a:lnRef>
+          <a:fillRef idx="3">
+            <a:schemeClr val="accent1"/>
+          </a:fillRef>
+          <a:effectRef idx="2">
+            <a:schemeClr val="accent1"/>
+          </a:effectRef>
+          <a:fontRef idx="minor">
+            <a:schemeClr val="lt1"/>
+          </a:fontRef>
+        </p:style>
+        <p:txBody>
+          <a:bodyPr rtlCol="0" anchor="ctr"/>
+          <a:lstStyle/>
+          <a:p>
+            <a:pPr algn="ctr"/>
+          </a:p>
+        </p:txBody>
+      </p:sp>
+      <p:sp>
+        <p:nvSpPr>
+          <p:cNvPr id="8" name="TextBox 7"/>
+          <p:cNvSpPr txBox="1"/>
+          <p:nvPr/>
+        </p:nvSpPr>
+        <p:spPr>
+          <a:xfrm>
+            <a:off x="6796735" y="1965960"/>
+            <a:ext cx="4480560" cy="457200"/>
+          </a:xfrm>
+          <a:prstGeom prst="rect">
+            <a:avLst/>
+          </a:prstGeom>
+          <a:noFill/>
+        </p:spPr>
+        <p:txBody>
+          <a:bodyPr wrap="square">
+            <a:spAutoFit/>
+          </a:bodyPr>
+          <a:lstStyle/>
+          <a:p>
+            <a:pPr algn="ctr"/>
+            <a:r>
+              <a:rPr sz="1800" b="1" i="0" u="none">
+                <a:solidFill>
+                  <a:srgbClr val="000000"/>
+                </a:solidFill>
+                <a:latin typeface="Arial"/>
+              </a:rPr>
+              <a:t>Direct Sort</a:t>
+            </a:r>
+          </a:p>
+        </p:txBody>
+      </p:sp>
+      <p:sp>
+        <p:nvSpPr>
+          <p:cNvPr id="9" name="TextBox 8"/>
+          <p:cNvSpPr txBox="1"/>
+          <p:nvPr/>
+        </p:nvSpPr>
+        <p:spPr>
+          <a:xfrm>
+            <a:off x="6888175" y="2606040"/>
+            <a:ext cx="4297680" cy="2743200"/>
+          </a:xfrm>
+          <a:prstGeom prst="rect">
+            <a:avLst/>
+          </a:prstGeom>
+          <a:noFill/>
+        </p:spPr>
+        <p:txBody>
+          <a:bodyPr wrap="square">
+            <a:spAutoFit/>
+          </a:bodyPr>
+          <a:lstStyle/>
+          <a:p>
+            <a:pPr>
+              <a:spcAft>
+                <a:spcPts val="1200"/>
+              </a:spcAft>
+            </a:pPr>
+            <a:r>
+              <a:rPr sz="1500">
+                <a:solidFill>
+                  <a:srgbClr val="000000"/>
+                </a:solidFill>
+                <a:latin typeface="Arial"/>
+              </a:rPr>
+              <a:t>•  One score per candidate</a:t>
+            </a:r>
+          </a:p>
+          <a:p>
+            <a:pPr>
+              <a:spcAft>
+                <a:spcPts val="1200"/>
+              </a:spcAft>
+            </a:pPr>
+            <a:r>
+              <a:rPr sz="1500">
+                <a:solidFill>
+                  <a:srgbClr val="000000"/>
+                </a:solidFill>
+                <a:latin typeface="Arial"/>
+              </a:rPr>
+              <a:t>•  Sort directly — no tournament</a:t>
+            </a:r>
+          </a:p>
+          <a:p>
+            <a:pPr>
+              <a:spcAft>
+                <a:spcPts val="1200"/>
+              </a:spcAft>
+            </a:pPr>
+            <a:r>
+              <a:rPr sz="1500">
+                <a:solidFill>
+                  <a:srgbClr val="000000"/>
+                </a:solidFill>
+                <a:latin typeface="Arial"/>
+              </a:rPr>
+              <a:t>•  Fully parallel</a:t>
+            </a:r>
+          </a:p>
+        </p:txBody>
+      </p:sp>
+      <p:sp>
+        <p:nvSpPr>
+          <p:cNvPr id="10" name="TextBox 9"/>
+          <p:cNvSpPr txBox="1"/>
+          <p:nvPr/>
+        </p:nvSpPr>
+        <p:spPr>
+          <a:xfrm>
+            <a:off x="5577840" y="3383280"/>
+            <a:ext cx="1036015" cy="548640"/>
+          </a:xfrm>
+          <a:prstGeom prst="rect">
+            <a:avLst/>
+          </a:prstGeom>
+          <a:noFill/>
+        </p:spPr>
+        <p:txBody>
+          <a:bodyPr wrap="square">
+            <a:spAutoFit/>
+          </a:bodyPr>
+          <a:lstStyle/>
+          <a:p>
+            <a:pPr algn="ctr"/>
+            <a:r>
+              <a:rPr sz="2800" b="0" i="0" u="none">
+                <a:solidFill>
+                  <a:srgbClr val="000000"/>
+                </a:solidFill>
+                <a:latin typeface="Arial"/>
+              </a:rPr>
+              <a:t>→</a:t>
+            </a:r>
+          </a:p>
+        </p:txBody>
+      </p:sp>
+      <p:sp>
+        <p:nvSpPr>
+          <p:cNvPr id="11" name="TextBox 10"/>
+          <p:cNvSpPr txBox="1"/>
+          <p:nvPr/>
+        </p:nvSpPr>
+        <p:spPr>
+          <a:xfrm>
+            <a:off x="731520" y="6355080"/>
+            <a:ext cx="10728655" cy="365760"/>
+          </a:xfrm>
+          <a:prstGeom prst="rect">
+            <a:avLst/>
+          </a:prstGeom>
+          <a:noFill/>
+        </p:spPr>
+        <p:txBody>
+          <a:bodyPr wrap="square">
+            <a:spAutoFit/>
+          </a:bodyPr>
+          <a:lstStyle/>
+          <a:p>
+            <a:pPr algn="l"/>
+            <a:r>
+              <a:rPr sz="1200" b="0" i="1" u="none">
+                <a:solidFill>
+                  <a:srgbClr val="595959"/>
+                </a:solidFill>
+                <a:latin typeface="Arial"/>
+              </a:rPr>
+              <a:t>Result: well under half the model calls, ~4.5× lower latency (Results, ahead)</a:t>
+            </a:r>
+          </a:p>
+        </p:txBody>
+      </p:sp>
+    </p:spTree>
+  </p:cSld>
+  <p:clrMapOvr>
+    <a:masterClrMapping/>
+  </p:clrMapOvr>
+</p:sld>
+</file>
+
+<file path=ppt/slides/slide9.xml><?xml version="1.0" encoding="utf-8"?>
+<p:sld xmlns:a="http://schemas.openxmlformats.org/drawingml/2006/main" xmlns:p="http://schemas.openxmlformats.org/presentationml/2006/main" xmlns:r="http://schemas.openxmlformats.org/officeDocument/2006/relationships">
+  <p:cSld>
+    <p:bg>
+      <p:bgPr>
+        <a:solidFill>
+          <a:srgbClr val="FFFFFF"/>
+        </a:solidFill>
+        <a:effectLst/>
+      </p:bgPr>
+    </p:bg>
+    <p:spTree>
+      <p:nvGrpSpPr>
+        <p:cNvPr id="1" name=""/>
+        <p:cNvGrpSpPr/>
+        <p:nvPr/>
+      </p:nvGrpSpPr>
+      <p:grpSpPr/>
+      <p:sp>
+        <p:nvSpPr>
+          <p:cNvPr id="2" name="TextBox 1"/>
+          <p:cNvSpPr txBox="1"/>
+          <p:nvPr/>
+        </p:nvSpPr>
+        <p:spPr>
+          <a:xfrm>
+            <a:off x="731520" y="411480"/>
+            <a:ext cx="10728655" cy="320040"/>
+          </a:xfrm>
+          <a:prstGeom prst="rect">
+            <a:avLst/>
+          </a:prstGeom>
+          <a:noFill/>
+        </p:spPr>
+        <p:txBody>
+          <a:bodyPr wrap="square">
+            <a:spAutoFit/>
+          </a:bodyPr>
+          <a:lstStyle/>
+          <a:p>
+            <a:pPr algn="l"/>
+            <a:r>
+              <a:rPr sz="1300" b="1" i="0" u="none">
+                <a:solidFill>
+                  <a:srgbClr val="595959"/>
+                </a:solidFill>
+                <a:latin typeface="Arial"/>
+              </a:rPr>
+              <a:t>EXPERIMENTAL SETUP</a:t>
+            </a:r>
+          </a:p>
+        </p:txBody>
+      </p:sp>
+      <p:sp>
+        <p:nvSpPr>
+          <p:cNvPr id="3" name="TextBox 2"/>
+          <p:cNvSpPr txBox="1"/>
+          <p:nvPr/>
+        </p:nvSpPr>
+        <p:spPr>
+          <a:xfrm>
+            <a:off x="731520" y="777240"/>
+            <a:ext cx="10728655" cy="1005840"/>
+          </a:xfrm>
+          <a:prstGeom prst="rect">
+            <a:avLst/>
+          </a:prstGeom>
+          <a:noFill/>
+        </p:spPr>
+        <p:txBody>
+          <a:bodyPr wrap="square">
+            <a:spAutoFit/>
+          </a:bodyPr>
+          <a:lstStyle/>
+          <a:p>
+            <a:pPr algn="l"/>
+            <a:r>
+              <a:rPr sz="3000" b="1" i="0" u="none">
+                <a:solidFill>
+                  <a:srgbClr val="000000"/>
+                </a:solidFill>
+                <a:latin typeface="Arial"/>
+              </a:rPr>
+              <a:t>Experimental Setup</a:t>
+            </a:r>
+          </a:p>
+        </p:txBody>
+      </p:sp>
+      <p:sp>
+        <p:nvSpPr>
+          <p:cNvPr id="4" name="Rectangle 3"/>
+          <p:cNvSpPr/>
+          <p:nvPr/>
+        </p:nvSpPr>
+        <p:spPr>
+          <a:xfrm>
+            <a:off x="380847" y="2011680"/>
+            <a:ext cx="2651760" cy="1828800"/>
+          </a:xfrm>
+          <a:prstGeom prst="rect">
+            <a:avLst/>
+          </a:prstGeom>
+          <a:noFill/>
+          <a:ln w="19050">
+            <a:solidFill>
+              <a:srgbClr val="000000"/>
+            </a:solidFill>
+          </a:ln>
+          <a:effectLst/>
+        </p:spPr>
+        <p:style>
+          <a:lnRef idx="1">
+            <a:schemeClr val="accent1"/>
+          </a:lnRef>
+          <a:fillRef idx="3">
+            <a:schemeClr val="accent1"/>
+          </a:fillRef>
+          <a:effectRef idx="2">
+            <a:schemeClr val="accent1"/>
+          </a:effectRef>
+          <a:fontRef idx="minor">
+            <a:schemeClr val="lt1"/>
+          </a:fontRef>
+        </p:style>
+        <p:txBody>
+          <a:bodyPr rtlCol="0" anchor="ctr"/>
+          <a:lstStyle/>
+          <a:p>
+            <a:pPr algn="ctr"/>
+          </a:p>
+        </p:txBody>
+      </p:sp>
+      <p:sp>
+        <p:nvSpPr>
+          <p:cNvPr id="5" name="TextBox 4"/>
+          <p:cNvSpPr txBox="1"/>
+          <p:nvPr/>
+        </p:nvSpPr>
+        <p:spPr>
+          <a:xfrm>
+            <a:off x="380847" y="2286000"/>
+            <a:ext cx="2651760" cy="822960"/>
+          </a:xfrm>
+          <a:prstGeom prst="rect">
+            <a:avLst/>
+          </a:prstGeom>
+          <a:noFill/>
+        </p:spPr>
+        <p:txBody>
+          <a:bodyPr wrap="square">
+            <a:spAutoFit/>
+          </a:bodyPr>
+          <a:lstStyle/>
+          <a:p>
+            <a:pPr algn="ctr"/>
+            <a:r>
+              <a:rPr sz="3600" b="1" i="0" u="none">
+                <a:solidFill>
+                  <a:srgbClr val="000000"/>
+                </a:solidFill>
+                <a:latin typeface="Arial"/>
+              </a:rPr>
+              <a:t>273</a:t>
+            </a:r>
+          </a:p>
+        </p:txBody>
+      </p:sp>
+      <p:sp>
+        <p:nvSpPr>
+          <p:cNvPr id="6" name="TextBox 5"/>
+          <p:cNvSpPr txBox="1"/>
+          <p:nvPr/>
+        </p:nvSpPr>
+        <p:spPr>
+          <a:xfrm>
+            <a:off x="518007" y="3108960"/>
+            <a:ext cx="2377440" cy="640080"/>
+          </a:xfrm>
+          <a:prstGeom prst="rect">
+            <a:avLst/>
+          </a:prstGeom>
+          <a:noFill/>
+        </p:spPr>
+        <p:txBody>
+          <a:bodyPr wrap="square">
+            <a:spAutoFit/>
+          </a:bodyPr>
+          <a:lstStyle/>
+          <a:p>
+            <a:pPr algn="ctr"/>
+            <a:r>
+              <a:rPr sz="1300" b="0" i="0" u="none">
+                <a:solidFill>
+                  <a:srgbClr val="595959"/>
+                </a:solidFill>
+                <a:latin typeface="Arial"/>
+              </a:rPr>
+              <a:t>shortlisted (job, applicant) pairs</a:t>
+            </a:r>
+          </a:p>
+        </p:txBody>
+      </p:sp>
+      <p:sp>
+        <p:nvSpPr>
+          <p:cNvPr id="7" name="Rectangle 6"/>
+          <p:cNvSpPr/>
+          <p:nvPr/>
+        </p:nvSpPr>
+        <p:spPr>
+          <a:xfrm>
+            <a:off x="3306927" y="2011680"/>
+            <a:ext cx="2651760" cy="1828800"/>
+          </a:xfrm>
+          <a:prstGeom prst="rect">
+            <a:avLst/>
+          </a:prstGeom>
+          <a:noFill/>
+          <a:ln w="19050">
+            <a:solidFill>
+              <a:srgbClr val="000000"/>
+            </a:solidFill>
+          </a:ln>
+          <a:effectLst/>
+        </p:spPr>
+        <p:style>
+          <a:lnRef idx="1">
+            <a:schemeClr val="accent1"/>
+          </a:lnRef>
+          <a:fillRef idx="3">
+            <a:schemeClr val="accent1"/>
+          </a:fillRef>
+          <a:effectRef idx="2">
+            <a:schemeClr val="accent1"/>
+          </a:effectRef>
+          <a:fontRef idx="minor">
+            <a:schemeClr val="lt1"/>
+          </a:fontRef>
+        </p:style>
+        <p:txBody>
+          <a:bodyPr rtlCol="0" anchor="ctr"/>
+          <a:lstStyle/>
+          <a:p>
+            <a:pPr algn="ctr"/>
+          </a:p>
+        </p:txBody>
+      </p:sp>
+      <p:sp>
+        <p:nvSpPr>
+          <p:cNvPr id="8" name="TextBox 7"/>
+          <p:cNvSpPr txBox="1"/>
+          <p:nvPr/>
+        </p:nvSpPr>
+        <p:spPr>
+          <a:xfrm>
+            <a:off x="3306927" y="2286000"/>
+            <a:ext cx="2651760" cy="822960"/>
+          </a:xfrm>
+          <a:prstGeom prst="rect">
+            <a:avLst/>
+          </a:prstGeom>
+          <a:noFill/>
+        </p:spPr>
+        <p:txBody>
+          <a:bodyPr wrap="square">
+            <a:spAutoFit/>
+          </a:bodyPr>
+          <a:lstStyle/>
+          <a:p>
+            <a:pPr algn="ctr"/>
+            <a:r>
+              <a:rPr sz="3600" b="1" i="0" u="none">
+                <a:solidFill>
+                  <a:srgbClr val="000000"/>
+                </a:solidFill>
+                <a:latin typeface="Arial"/>
+              </a:rPr>
+              <a:t>10</a:t>
+            </a:r>
+          </a:p>
+        </p:txBody>
+      </p:sp>
+      <p:sp>
+        <p:nvSpPr>
+          <p:cNvPr id="9" name="TextBox 8"/>
+          <p:cNvSpPr txBox="1"/>
+          <p:nvPr/>
+        </p:nvSpPr>
+        <p:spPr>
+          <a:xfrm>
+            <a:off x="3444087" y="3108960"/>
+            <a:ext cx="2377440" cy="640080"/>
+          </a:xfrm>
+          <a:prstGeom prst="rect">
+            <a:avLst/>
+          </a:prstGeom>
+          <a:noFill/>
+        </p:spPr>
+        <p:txBody>
+          <a:bodyPr wrap="square">
+            <a:spAutoFit/>
+          </a:bodyPr>
+          <a:lstStyle/>
+          <a:p>
+            <a:pPr algn="ctr"/>
+            <a:r>
+              <a:rPr sz="1300" b="0" i="0" u="none">
+                <a:solidFill>
+                  <a:srgbClr val="595959"/>
+                </a:solidFill>
+                <a:latin typeface="Arial"/>
+              </a:rPr>
+              <a:t>job profiles</a:t>
+            </a:r>
+          </a:p>
+        </p:txBody>
+      </p:sp>
+      <p:sp>
+        <p:nvSpPr>
+          <p:cNvPr id="10" name="Rectangle 9"/>
+          <p:cNvSpPr/>
+          <p:nvPr/>
+        </p:nvSpPr>
+        <p:spPr>
+          <a:xfrm>
+            <a:off x="6233007" y="2011680"/>
+            <a:ext cx="2651760" cy="1828800"/>
+          </a:xfrm>
+          <a:prstGeom prst="rect">
+            <a:avLst/>
+          </a:prstGeom>
+          <a:noFill/>
+          <a:ln w="19050">
+            <a:solidFill>
+              <a:srgbClr val="000000"/>
+            </a:solidFill>
+          </a:ln>
+          <a:effectLst/>
+        </p:spPr>
+        <p:style>
+          <a:lnRef idx="1">
+            <a:schemeClr val="accent1"/>
+          </a:lnRef>
+          <a:fillRef idx="3">
+            <a:schemeClr val="accent1"/>
+          </a:fillRef>
+          <a:effectRef idx="2">
+            <a:schemeClr val="accent1"/>
+          </a:effectRef>
+          <a:fontRef idx="minor">
+            <a:schemeClr val="lt1"/>
+          </a:fontRef>
+        </p:style>
+        <p:txBody>
+          <a:bodyPr rtlCol="0" anchor="ctr"/>
+          <a:lstStyle/>
+          <a:p>
+            <a:pPr algn="ctr"/>
+          </a:p>
+        </p:txBody>
+      </p:sp>
+      <p:sp>
+        <p:nvSpPr>
+          <p:cNvPr id="11" name="TextBox 10"/>
+          <p:cNvSpPr txBox="1"/>
+          <p:nvPr/>
+        </p:nvSpPr>
+        <p:spPr>
+          <a:xfrm>
+            <a:off x="6233007" y="2286000"/>
+            <a:ext cx="2651760" cy="822960"/>
+          </a:xfrm>
+          <a:prstGeom prst="rect">
+            <a:avLst/>
+          </a:prstGeom>
+          <a:noFill/>
+        </p:spPr>
+        <p:txBody>
+          <a:bodyPr wrap="square">
+            <a:spAutoFit/>
+          </a:bodyPr>
+          <a:lstStyle/>
+          <a:p>
+            <a:pPr algn="ctr"/>
+            <a:r>
+              <a:rPr sz="3600" b="1" i="0" u="none">
+                <a:solidFill>
+                  <a:srgbClr val="000000"/>
+                </a:solidFill>
+                <a:latin typeface="Arial"/>
+              </a:rPr>
+              <a:t>501</a:t>
+            </a:r>
+          </a:p>
+        </p:txBody>
+      </p:sp>
+      <p:sp>
+        <p:nvSpPr>
+          <p:cNvPr id="12" name="TextBox 11"/>
+          <p:cNvSpPr txBox="1"/>
+          <p:nvPr/>
+        </p:nvSpPr>
+        <p:spPr>
+          <a:xfrm>
+            <a:off x="6370167" y="3108960"/>
+            <a:ext cx="2377440" cy="640080"/>
+          </a:xfrm>
+          <a:prstGeom prst="rect">
+            <a:avLst/>
+          </a:prstGeom>
+          <a:noFill/>
+        </p:spPr>
+        <p:txBody>
+          <a:bodyPr wrap="square">
+            <a:spAutoFit/>
+          </a:bodyPr>
+          <a:lstStyle/>
+          <a:p>
+            <a:pPr algn="ctr"/>
+            <a:r>
+              <a:rPr sz="1300" b="0" i="0" u="none">
+                <a:solidFill>
+                  <a:srgbClr val="595959"/>
+                </a:solidFill>
+                <a:latin typeface="Arial"/>
+              </a:rPr>
+              <a:t>resumes (500 synthetic + 1 real)</a:t>
+            </a:r>
+          </a:p>
+        </p:txBody>
+      </p:sp>
+      <p:sp>
+        <p:nvSpPr>
+          <p:cNvPr id="13" name="Rectangle 12"/>
+          <p:cNvSpPr/>
+          <p:nvPr/>
+        </p:nvSpPr>
+        <p:spPr>
+          <a:xfrm>
+            <a:off x="9159087" y="2011680"/>
+            <a:ext cx="2651760" cy="1828800"/>
+          </a:xfrm>
+          <a:prstGeom prst="rect">
+            <a:avLst/>
+          </a:prstGeom>
+          <a:noFill/>
+          <a:ln w="19050">
+            <a:solidFill>
+              <a:srgbClr val="000000"/>
+            </a:solidFill>
+          </a:ln>
+          <a:effectLst/>
+        </p:spPr>
+        <p:style>
+          <a:lnRef idx="1">
+            <a:schemeClr val="accent1"/>
+          </a:lnRef>
+          <a:fillRef idx="3">
+            <a:schemeClr val="accent1"/>
+          </a:fillRef>
+          <a:effectRef idx="2">
+            <a:schemeClr val="accent1"/>
+          </a:effectRef>
+          <a:fontRef idx="minor">
+            <a:schemeClr val="lt1"/>
+          </a:fontRef>
+        </p:style>
+        <p:txBody>
+          <a:bodyPr rtlCol="0" anchor="ctr"/>
+          <a:lstStyle/>
+          <a:p>
+            <a:pPr algn="ctr"/>
+          </a:p>
+        </p:txBody>
+      </p:sp>
+      <p:sp>
+        <p:nvSpPr>
+          <p:cNvPr id="14" name="TextBox 13"/>
+          <p:cNvSpPr txBox="1"/>
+          <p:nvPr/>
+        </p:nvSpPr>
+        <p:spPr>
+          <a:xfrm>
+            <a:off x="9159087" y="2286000"/>
+            <a:ext cx="2651760" cy="822960"/>
+          </a:xfrm>
+          <a:prstGeom prst="rect">
+            <a:avLst/>
+          </a:prstGeom>
+          <a:noFill/>
+        </p:spPr>
+        <p:txBody>
+          <a:bodyPr wrap="square">
+            <a:spAutoFit/>
+          </a:bodyPr>
+          <a:lstStyle/>
+          <a:p>
+            <a:pPr algn="ctr"/>
+            <a:r>
+              <a:rPr sz="3600" b="1" i="0" u="none">
+                <a:solidFill>
+                  <a:srgbClr val="000000"/>
+                </a:solidFill>
+                <a:latin typeface="Arial"/>
+              </a:rPr>
+              <a:t>3×</a:t>
+            </a:r>
+          </a:p>
+        </p:txBody>
+      </p:sp>
+      <p:sp>
+        <p:nvSpPr>
+          <p:cNvPr id="15" name="TextBox 14"/>
+          <p:cNvSpPr txBox="1"/>
+          <p:nvPr/>
+        </p:nvSpPr>
+        <p:spPr>
+          <a:xfrm>
+            <a:off x="9296247" y="3108960"/>
+            <a:ext cx="2377440" cy="640080"/>
+          </a:xfrm>
+          <a:prstGeom prst="rect">
+            <a:avLst/>
+          </a:prstGeom>
+          <a:noFill/>
+        </p:spPr>
+        <p:txBody>
+          <a:bodyPr wrap="square">
+            <a:spAutoFit/>
+          </a:bodyPr>
+          <a:lstStyle/>
+          <a:p>
+            <a:pPr algn="ctr"/>
+            <a:r>
+              <a:rPr sz="1300" b="0" i="0" u="none">
+                <a:solidFill>
+                  <a:srgbClr val="595959"/>
+                </a:solidFill>
+                <a:latin typeface="Arial"/>
+              </a:rPr>
+              <a:t>independent repeats per pair</a:t>
+            </a:r>
+          </a:p>
+        </p:txBody>
+      </p:sp>
+      <p:sp>
+        <p:nvSpPr>
+          <p:cNvPr id="16" name="TextBox 15"/>
+          <p:cNvSpPr txBox="1"/>
+          <p:nvPr/>
+        </p:nvSpPr>
+        <p:spPr>
+          <a:xfrm>
+            <a:off x="914400" y="4297680"/>
+            <a:ext cx="10362895" cy="731520"/>
+          </a:xfrm>
+          <a:prstGeom prst="rect">
+            <a:avLst/>
+          </a:prstGeom>
+          <a:noFill/>
+        </p:spPr>
+        <p:txBody>
+          <a:bodyPr wrap="square">
+            <a:spAutoFit/>
+          </a:bodyPr>
+          <a:lstStyle/>
+          <a:p>
+            <a:pPr algn="ctr"/>
+            <a:r>
+              <a:rPr sz="1500" b="0" i="1" u="none">
+                <a:solidFill>
+                  <a:srgbClr val="595959"/>
+                </a:solidFill>
+                <a:latin typeface="Arial"/>
+              </a:rPr>
+              <a:t>One variable changed between systems: the assessment step. 46.1% of extracted required skills were classified must-have.</a:t>
+            </a:r>
+          </a:p>
+        </p:txBody>
+      </p:sp>
+      <p:sp>
+        <p:nvSpPr>
+          <p:cNvPr id="17" name="TextBox 16"/>
+          <p:cNvSpPr txBox="1"/>
+          <p:nvPr/>
+        </p:nvSpPr>
+        <p:spPr>
+          <a:xfrm>
+            <a:off x="731520" y="6355080"/>
+            <a:ext cx="10728655" cy="365760"/>
+          </a:xfrm>
+          <a:prstGeom prst="rect">
+            <a:avLst/>
+          </a:prstGeom>
+          <a:noFill/>
+        </p:spPr>
+        <p:txBody>
+          <a:bodyPr wrap="square">
+            <a:spAutoFit/>
+          </a:bodyPr>
+          <a:lstStyle/>
+          <a:p>
+            <a:pPr algn="l"/>
+            <a:r>
+              <a:rPr sz="1200" b="0" i="1" u="none">
+                <a:solidFill>
+                  <a:srgbClr val="595959"/>
+                </a:solidFill>
+                <a:latin typeface="Arial"/>
+              </a:rPr>
+              <a:t>Section IV — Experimental Setup</a:t>
             </a:r>
           </a:p>
         </p:txBody>

</xml_diff>

<commit_message>
feat: rewrite ICAIDES deck, Slides 10-12 Results (5/6)
Adds the add_hero primitive: one large centered number/phrase + caption,
no shapes at all.

Co-Authored-By: Claude Sonnet 5 <noreply@anthropic.com>
</commit_message>
<xml_diff>
--- a/docs/presentation/icaides2026_jev.pptx
+++ b/docs/presentation/icaides2026_jev.pptx
@@ -14,6 +14,9 @@
     <p:sldId id="262" r:id="rId13"/>
     <p:sldId id="263" r:id="rId14"/>
     <p:sldId id="264" r:id="rId15"/>
+    <p:sldId id="265" r:id="rId16"/>
+    <p:sldId id="266" r:id="rId17"/>
+    <p:sldId id="267" r:id="rId18"/>
   </p:sldIdLst>
   <p:sldSz cx="12191695" cy="6858000" type="screen4x3"/>
   <p:notesSz cx="6858000" cy="9144000"/>
@@ -3240,6 +3243,714 @@
                 <a:latin typeface="Arial"/>
               </a:rPr>
               <a:t>Can a model that only fills in structured answers rank applicants better than one that writes free text?</a:t>
+            </a:r>
+          </a:p>
+        </p:txBody>
+      </p:sp>
+    </p:spTree>
+  </p:cSld>
+  <p:clrMapOvr>
+    <a:masterClrMapping/>
+  </p:clrMapOvr>
+</p:sld>
+</file>
+
+<file path=ppt/slides/slide10.xml><?xml version="1.0" encoding="utf-8"?>
+<p:sld xmlns:a="http://schemas.openxmlformats.org/drawingml/2006/main" xmlns:p="http://schemas.openxmlformats.org/presentationml/2006/main" xmlns:r="http://schemas.openxmlformats.org/officeDocument/2006/relationships">
+  <p:cSld>
+    <p:bg>
+      <p:bgPr>
+        <a:solidFill>
+          <a:srgbClr val="FFFFFF"/>
+        </a:solidFill>
+        <a:effectLst/>
+      </p:bgPr>
+    </p:bg>
+    <p:spTree>
+      <p:nvGrpSpPr>
+        <p:cNvPr id="1" name=""/>
+        <p:cNvGrpSpPr/>
+        <p:nvPr/>
+      </p:nvGrpSpPr>
+      <p:grpSpPr/>
+      <p:sp>
+        <p:nvSpPr>
+          <p:cNvPr id="2" name="TextBox 1"/>
+          <p:cNvSpPr txBox="1"/>
+          <p:nvPr/>
+        </p:nvSpPr>
+        <p:spPr>
+          <a:xfrm>
+            <a:off x="731520" y="411480"/>
+            <a:ext cx="10728655" cy="320040"/>
+          </a:xfrm>
+          <a:prstGeom prst="rect">
+            <a:avLst/>
+          </a:prstGeom>
+          <a:noFill/>
+        </p:spPr>
+        <p:txBody>
+          <a:bodyPr wrap="square">
+            <a:spAutoFit/>
+          </a:bodyPr>
+          <a:lstStyle/>
+          <a:p>
+            <a:pPr algn="l"/>
+            <a:r>
+              <a:rPr sz="1300" b="1" i="0" u="none">
+                <a:solidFill>
+                  <a:srgbClr val="595959"/>
+                </a:solidFill>
+                <a:latin typeface="Arial"/>
+              </a:rPr>
+              <a:t>RESULTS</a:t>
+            </a:r>
+          </a:p>
+        </p:txBody>
+      </p:sp>
+      <p:sp>
+        <p:nvSpPr>
+          <p:cNvPr id="3" name="TextBox 2"/>
+          <p:cNvSpPr txBox="1"/>
+          <p:nvPr/>
+        </p:nvSpPr>
+        <p:spPr>
+          <a:xfrm>
+            <a:off x="731520" y="777240"/>
+            <a:ext cx="10728655" cy="1005840"/>
+          </a:xfrm>
+          <a:prstGeom prst="rect">
+            <a:avLst/>
+          </a:prstGeom>
+          <a:noFill/>
+        </p:spPr>
+        <p:txBody>
+          <a:bodyPr wrap="square">
+            <a:spAutoFit/>
+          </a:bodyPr>
+          <a:lstStyle/>
+          <a:p>
+            <a:pPr algn="l"/>
+            <a:r>
+              <a:rPr sz="3000" b="1" i="0" u="none">
+                <a:solidFill>
+                  <a:srgbClr val="000000"/>
+                </a:solidFill>
+                <a:latin typeface="Arial"/>
+              </a:rPr>
+              <a:t>Result: Confidence Gain</a:t>
+            </a:r>
+          </a:p>
+        </p:txBody>
+      </p:sp>
+      <p:sp>
+        <p:nvSpPr>
+          <p:cNvPr id="4" name="TextBox 3"/>
+          <p:cNvSpPr txBox="1"/>
+          <p:nvPr/>
+        </p:nvSpPr>
+        <p:spPr>
+          <a:xfrm>
+            <a:off x="731520" y="2103120"/>
+            <a:ext cx="10728655" cy="1463040"/>
+          </a:xfrm>
+          <a:prstGeom prst="rect">
+            <a:avLst/>
+          </a:prstGeom>
+          <a:noFill/>
+        </p:spPr>
+        <p:txBody>
+          <a:bodyPr wrap="square">
+            <a:spAutoFit/>
+          </a:bodyPr>
+          <a:lstStyle/>
+          <a:p>
+            <a:pPr algn="ctr"/>
+            <a:r>
+              <a:rPr sz="6400" b="1" i="0" u="none">
+                <a:solidFill>
+                  <a:srgbClr val="000000"/>
+                </a:solidFill>
+                <a:latin typeface="Arial"/>
+              </a:rPr>
+              <a:t>0.672 → 0.894</a:t>
+            </a:r>
+          </a:p>
+        </p:txBody>
+      </p:sp>
+      <p:sp>
+        <p:nvSpPr>
+          <p:cNvPr id="5" name="TextBox 4"/>
+          <p:cNvSpPr txBox="1"/>
+          <p:nvPr/>
+        </p:nvSpPr>
+        <p:spPr>
+          <a:xfrm>
+            <a:off x="1188720" y="3703320"/>
+            <a:ext cx="9814255" cy="640080"/>
+          </a:xfrm>
+          <a:prstGeom prst="rect">
+            <a:avLst/>
+          </a:prstGeom>
+          <a:noFill/>
+        </p:spPr>
+        <p:txBody>
+          <a:bodyPr wrap="square">
+            <a:spAutoFit/>
+          </a:bodyPr>
+          <a:lstStyle/>
+          <a:p>
+            <a:pPr algn="ctr"/>
+            <a:r>
+              <a:rPr sz="2000" b="0" i="0" u="none">
+                <a:solidFill>
+                  <a:srgbClr val="000000"/>
+                </a:solidFill>
+                <a:latin typeface="Arial"/>
+              </a:rPr>
+              <a:t>Per-requirement answer confidence, bare scale vs. criteria-grounded design</a:t>
+            </a:r>
+          </a:p>
+        </p:txBody>
+      </p:sp>
+      <p:sp>
+        <p:nvSpPr>
+          <p:cNvPr id="6" name="TextBox 5"/>
+          <p:cNvSpPr txBox="1"/>
+          <p:nvPr/>
+        </p:nvSpPr>
+        <p:spPr>
+          <a:xfrm>
+            <a:off x="1371600" y="4434840"/>
+            <a:ext cx="9448495" cy="1188720"/>
+          </a:xfrm>
+          <a:prstGeom prst="rect">
+            <a:avLst/>
+          </a:prstGeom>
+          <a:noFill/>
+        </p:spPr>
+        <p:txBody>
+          <a:bodyPr wrap="square">
+            <a:spAutoFit/>
+          </a:bodyPr>
+          <a:lstStyle/>
+          <a:p>
+            <a:pPr algn="ctr"/>
+            <a:r>
+              <a:rPr sz="1400" b="0" i="1" u="none">
+                <a:solidFill>
+                  <a:srgbClr val="595959"/>
+                </a:solidFill>
+                <a:latin typeface="Arial"/>
+              </a:rPr>
+              <a:t>Also 0.635 → 0.766 for pooled seniority/education confidence.</a:t>
+            </a:r>
+          </a:p>
+        </p:txBody>
+      </p:sp>
+      <p:sp>
+        <p:nvSpPr>
+          <p:cNvPr id="7" name="TextBox 6"/>
+          <p:cNvSpPr txBox="1"/>
+          <p:nvPr/>
+        </p:nvSpPr>
+        <p:spPr>
+          <a:xfrm>
+            <a:off x="731520" y="6355080"/>
+            <a:ext cx="10728655" cy="365760"/>
+          </a:xfrm>
+          <a:prstGeom prst="rect">
+            <a:avLst/>
+          </a:prstGeom>
+          <a:noFill/>
+        </p:spPr>
+        <p:txBody>
+          <a:bodyPr wrap="square">
+            <a:spAutoFit/>
+          </a:bodyPr>
+          <a:lstStyle/>
+          <a:p>
+            <a:pPr algn="l"/>
+            <a:r>
+              <a:rPr sz="1200" b="0" i="1" u="none">
+                <a:solidFill>
+                  <a:srgbClr val="595959"/>
+                </a:solidFill>
+                <a:latin typeface="Arial"/>
+              </a:rPr>
+              <a:t>Section V — Results and Discussion</a:t>
+            </a:r>
+          </a:p>
+        </p:txBody>
+      </p:sp>
+    </p:spTree>
+  </p:cSld>
+  <p:clrMapOvr>
+    <a:masterClrMapping/>
+  </p:clrMapOvr>
+</p:sld>
+</file>
+
+<file path=ppt/slides/slide11.xml><?xml version="1.0" encoding="utf-8"?>
+<p:sld xmlns:a="http://schemas.openxmlformats.org/drawingml/2006/main" xmlns:p="http://schemas.openxmlformats.org/presentationml/2006/main" xmlns:r="http://schemas.openxmlformats.org/officeDocument/2006/relationships">
+  <p:cSld>
+    <p:bg>
+      <p:bgPr>
+        <a:solidFill>
+          <a:srgbClr val="FFFFFF"/>
+        </a:solidFill>
+        <a:effectLst/>
+      </p:bgPr>
+    </p:bg>
+    <p:spTree>
+      <p:nvGrpSpPr>
+        <p:cNvPr id="1" name=""/>
+        <p:cNvGrpSpPr/>
+        <p:nvPr/>
+      </p:nvGrpSpPr>
+      <p:grpSpPr/>
+      <p:sp>
+        <p:nvSpPr>
+          <p:cNvPr id="2" name="TextBox 1"/>
+          <p:cNvSpPr txBox="1"/>
+          <p:nvPr/>
+        </p:nvSpPr>
+        <p:spPr>
+          <a:xfrm>
+            <a:off x="731520" y="411480"/>
+            <a:ext cx="10728655" cy="320040"/>
+          </a:xfrm>
+          <a:prstGeom prst="rect">
+            <a:avLst/>
+          </a:prstGeom>
+          <a:noFill/>
+        </p:spPr>
+        <p:txBody>
+          <a:bodyPr wrap="square">
+            <a:spAutoFit/>
+          </a:bodyPr>
+          <a:lstStyle/>
+          <a:p>
+            <a:pPr algn="l"/>
+            <a:r>
+              <a:rPr sz="1300" b="1" i="0" u="none">
+                <a:solidFill>
+                  <a:srgbClr val="595959"/>
+                </a:solidFill>
+                <a:latin typeface="Arial"/>
+              </a:rPr>
+              <a:t>RESULTS</a:t>
+            </a:r>
+          </a:p>
+        </p:txBody>
+      </p:sp>
+      <p:sp>
+        <p:nvSpPr>
+          <p:cNvPr id="3" name="TextBox 2"/>
+          <p:cNvSpPr txBox="1"/>
+          <p:nvPr/>
+        </p:nvSpPr>
+        <p:spPr>
+          <a:xfrm>
+            <a:off x="731520" y="777240"/>
+            <a:ext cx="10728655" cy="1005840"/>
+          </a:xfrm>
+          <a:prstGeom prst="rect">
+            <a:avLst/>
+          </a:prstGeom>
+          <a:noFill/>
+        </p:spPr>
+        <p:txBody>
+          <a:bodyPr wrap="square">
+            <a:spAutoFit/>
+          </a:bodyPr>
+          <a:lstStyle/>
+          <a:p>
+            <a:pPr algn="l"/>
+            <a:r>
+              <a:rPr sz="3000" b="1" i="0" u="none">
+                <a:solidFill>
+                  <a:srgbClr val="000000"/>
+                </a:solidFill>
+                <a:latin typeface="Arial"/>
+              </a:rPr>
+              <a:t>Result: Efficiency</a:t>
+            </a:r>
+          </a:p>
+        </p:txBody>
+      </p:sp>
+      <p:sp>
+        <p:nvSpPr>
+          <p:cNvPr id="4" name="TextBox 3"/>
+          <p:cNvSpPr txBox="1"/>
+          <p:nvPr/>
+        </p:nvSpPr>
+        <p:spPr>
+          <a:xfrm>
+            <a:off x="731520" y="2103120"/>
+            <a:ext cx="10728655" cy="1463040"/>
+          </a:xfrm>
+          <a:prstGeom prst="rect">
+            <a:avLst/>
+          </a:prstGeom>
+          <a:noFill/>
+        </p:spPr>
+        <p:txBody>
+          <a:bodyPr wrap="square">
+            <a:spAutoFit/>
+          </a:bodyPr>
+          <a:lstStyle/>
+          <a:p>
+            <a:pPr algn="ctr"/>
+            <a:r>
+              <a:rPr sz="6400" b="1" i="0" u="none">
+                <a:solidFill>
+                  <a:srgbClr val="000000"/>
+                </a:solidFill>
+                <a:latin typeface="Arial"/>
+              </a:rPr>
+              <a:t>273 vs. ~2,061</a:t>
+            </a:r>
+          </a:p>
+        </p:txBody>
+      </p:sp>
+      <p:sp>
+        <p:nvSpPr>
+          <p:cNvPr id="5" name="TextBox 4"/>
+          <p:cNvSpPr txBox="1"/>
+          <p:nvPr/>
+        </p:nvSpPr>
+        <p:spPr>
+          <a:xfrm>
+            <a:off x="1188720" y="3703320"/>
+            <a:ext cx="9814255" cy="640080"/>
+          </a:xfrm>
+          <a:prstGeom prst="rect">
+            <a:avLst/>
+          </a:prstGeom>
+          <a:noFill/>
+        </p:spPr>
+        <p:txBody>
+          <a:bodyPr wrap="square">
+            <a:spAutoFit/>
+          </a:bodyPr>
+          <a:lstStyle/>
+          <a:p>
+            <a:pPr algn="ctr"/>
+            <a:r>
+              <a:rPr sz="2000" b="0" i="0" u="none">
+                <a:solidFill>
+                  <a:srgbClr val="000000"/>
+                </a:solidFill>
+                <a:latin typeface="Arial"/>
+              </a:rPr>
+              <a:t>Model calls, this pipeline vs. the prior tournament-based system</a:t>
+            </a:r>
+          </a:p>
+        </p:txBody>
+      </p:sp>
+      <p:sp>
+        <p:nvSpPr>
+          <p:cNvPr id="6" name="TextBox 5"/>
+          <p:cNvSpPr txBox="1"/>
+          <p:nvPr/>
+        </p:nvSpPr>
+        <p:spPr>
+          <a:xfrm>
+            <a:off x="1371600" y="4434840"/>
+            <a:ext cx="9448495" cy="1188720"/>
+          </a:xfrm>
+          <a:prstGeom prst="rect">
+            <a:avLst/>
+          </a:prstGeom>
+          <a:noFill/>
+        </p:spPr>
+        <p:txBody>
+          <a:bodyPr wrap="square">
+            <a:spAutoFit/>
+          </a:bodyPr>
+          <a:lstStyle/>
+          <a:p>
+            <a:pPr algn="ctr"/>
+            <a:r>
+              <a:rPr sz="1400" b="0" i="1" u="none">
+                <a:solidFill>
+                  <a:srgbClr val="595959"/>
+                </a:solidFill>
+                <a:latin typeface="Arial"/>
+              </a:rPr>
+              <a:t>~4.5× lower per-candidate latency. Output priced at zero by design — not billed per generated token (TypeSafe's claim on price, not independently measured).</a:t>
+            </a:r>
+          </a:p>
+        </p:txBody>
+      </p:sp>
+      <p:sp>
+        <p:nvSpPr>
+          <p:cNvPr id="7" name="TextBox 6"/>
+          <p:cNvSpPr txBox="1"/>
+          <p:nvPr/>
+        </p:nvSpPr>
+        <p:spPr>
+          <a:xfrm>
+            <a:off x="731520" y="6355080"/>
+            <a:ext cx="10728655" cy="365760"/>
+          </a:xfrm>
+          <a:prstGeom prst="rect">
+            <a:avLst/>
+          </a:prstGeom>
+          <a:noFill/>
+        </p:spPr>
+        <p:txBody>
+          <a:bodyPr wrap="square">
+            <a:spAutoFit/>
+          </a:bodyPr>
+          <a:lstStyle/>
+          <a:p>
+            <a:pPr algn="l"/>
+            <a:r>
+              <a:rPr sz="1200" b="0" i="1" u="none">
+                <a:solidFill>
+                  <a:srgbClr val="595959"/>
+                </a:solidFill>
+                <a:latin typeface="Arial"/>
+              </a:rPr>
+              <a:t>Section V — Results and Discussion</a:t>
+            </a:r>
+          </a:p>
+        </p:txBody>
+      </p:sp>
+    </p:spTree>
+  </p:cSld>
+  <p:clrMapOvr>
+    <a:masterClrMapping/>
+  </p:clrMapOvr>
+</p:sld>
+</file>
+
+<file path=ppt/slides/slide12.xml><?xml version="1.0" encoding="utf-8"?>
+<p:sld xmlns:a="http://schemas.openxmlformats.org/drawingml/2006/main" xmlns:p="http://schemas.openxmlformats.org/presentationml/2006/main" xmlns:r="http://schemas.openxmlformats.org/officeDocument/2006/relationships">
+  <p:cSld>
+    <p:bg>
+      <p:bgPr>
+        <a:solidFill>
+          <a:srgbClr val="FFFFFF"/>
+        </a:solidFill>
+        <a:effectLst/>
+      </p:bgPr>
+    </p:bg>
+    <p:spTree>
+      <p:nvGrpSpPr>
+        <p:cNvPr id="1" name=""/>
+        <p:cNvGrpSpPr/>
+        <p:nvPr/>
+      </p:nvGrpSpPr>
+      <p:grpSpPr/>
+      <p:sp>
+        <p:nvSpPr>
+          <p:cNvPr id="2" name="TextBox 1"/>
+          <p:cNvSpPr txBox="1"/>
+          <p:nvPr/>
+        </p:nvSpPr>
+        <p:spPr>
+          <a:xfrm>
+            <a:off x="731520" y="411480"/>
+            <a:ext cx="10728655" cy="320040"/>
+          </a:xfrm>
+          <a:prstGeom prst="rect">
+            <a:avLst/>
+          </a:prstGeom>
+          <a:noFill/>
+        </p:spPr>
+        <p:txBody>
+          <a:bodyPr wrap="square">
+            <a:spAutoFit/>
+          </a:bodyPr>
+          <a:lstStyle/>
+          <a:p>
+            <a:pPr algn="l"/>
+            <a:r>
+              <a:rPr sz="1300" b="1" i="0" u="none">
+                <a:solidFill>
+                  <a:srgbClr val="595959"/>
+                </a:solidFill>
+                <a:latin typeface="Arial"/>
+              </a:rPr>
+              <a:t>RESULTS</a:t>
+            </a:r>
+          </a:p>
+        </p:txBody>
+      </p:sp>
+      <p:sp>
+        <p:nvSpPr>
+          <p:cNvPr id="3" name="TextBox 2"/>
+          <p:cNvSpPr txBox="1"/>
+          <p:nvPr/>
+        </p:nvSpPr>
+        <p:spPr>
+          <a:xfrm>
+            <a:off x="731520" y="777240"/>
+            <a:ext cx="10728655" cy="1005840"/>
+          </a:xfrm>
+          <a:prstGeom prst="rect">
+            <a:avLst/>
+          </a:prstGeom>
+          <a:noFill/>
+        </p:spPr>
+        <p:txBody>
+          <a:bodyPr wrap="square">
+            <a:spAutoFit/>
+          </a:bodyPr>
+          <a:lstStyle/>
+          <a:p>
+            <a:pPr algn="l"/>
+            <a:r>
+              <a:rPr sz="3000" b="1" i="0" u="none">
+                <a:solidFill>
+                  <a:srgbClr val="000000"/>
+                </a:solidFill>
+                <a:latin typeface="Arial"/>
+              </a:rPr>
+              <a:t>Result: Calibration &amp; Stability</a:t>
+            </a:r>
+          </a:p>
+        </p:txBody>
+      </p:sp>
+      <p:sp>
+        <p:nvSpPr>
+          <p:cNvPr id="4" name="TextBox 3"/>
+          <p:cNvSpPr txBox="1"/>
+          <p:nvPr/>
+        </p:nvSpPr>
+        <p:spPr>
+          <a:xfrm>
+            <a:off x="731520" y="2103120"/>
+            <a:ext cx="10728655" cy="1463040"/>
+          </a:xfrm>
+          <a:prstGeom prst="rect">
+            <a:avLst/>
+          </a:prstGeom>
+          <a:noFill/>
+        </p:spPr>
+        <p:txBody>
+          <a:bodyPr wrap="square">
+            <a:spAutoFit/>
+          </a:bodyPr>
+          <a:lstStyle/>
+          <a:p>
+            <a:pPr algn="ctr"/>
+            <a:r>
+              <a:rPr sz="6400" b="1" i="0" u="none">
+                <a:solidFill>
+                  <a:srgbClr val="000000"/>
+                </a:solidFill>
+                <a:latin typeface="Arial"/>
+              </a:rPr>
+              <a:t>0.965 vs. ≈0.957</a:t>
+            </a:r>
+          </a:p>
+        </p:txBody>
+      </p:sp>
+      <p:sp>
+        <p:nvSpPr>
+          <p:cNvPr id="5" name="TextBox 4"/>
+          <p:cNvSpPr txBox="1"/>
+          <p:nvPr/>
+        </p:nvSpPr>
+        <p:spPr>
+          <a:xfrm>
+            <a:off x="1188720" y="3703320"/>
+            <a:ext cx="9814255" cy="640080"/>
+          </a:xfrm>
+          <a:prstGeom prst="rect">
+            <a:avLst/>
+          </a:prstGeom>
+          <a:noFill/>
+        </p:spPr>
+        <p:txBody>
+          <a:bodyPr wrap="square">
+            <a:spAutoFit/>
+          </a:bodyPr>
+          <a:lstStyle/>
+          <a:p>
+            <a:pPr algn="ctr"/>
+            <a:r>
+              <a:rPr sz="2000" b="0" i="0" u="none">
+                <a:solidFill>
+                  <a:srgbClr val="000000"/>
+                </a:solidFill>
+                <a:latin typeface="Arial"/>
+              </a:rPr>
+              <a:t>Kendall's τ ranking stability across 3 independent repeats, this system vs. the prior one</a:t>
+            </a:r>
+          </a:p>
+        </p:txBody>
+      </p:sp>
+      <p:sp>
+        <p:nvSpPr>
+          <p:cNvPr id="6" name="TextBox 5"/>
+          <p:cNvSpPr txBox="1"/>
+          <p:nvPr/>
+        </p:nvSpPr>
+        <p:spPr>
+          <a:xfrm>
+            <a:off x="1371600" y="4434840"/>
+            <a:ext cx="9448495" cy="1188720"/>
+          </a:xfrm>
+          <a:prstGeom prst="rect">
+            <a:avLst/>
+          </a:prstGeom>
+          <a:noFill/>
+        </p:spPr>
+        <p:txBody>
+          <a:bodyPr wrap="square">
+            <a:spAutoFit/>
+          </a:bodyPr>
+          <a:lstStyle/>
+          <a:p>
+            <a:pPr algn="ctr"/>
+            <a:r>
+              <a:rPr sz="1400" b="0" i="1" u="none">
+                <a:solidFill>
+                  <a:srgbClr val="595959"/>
+                </a:solidFill>
+                <a:latin typeface="Arial"/>
+              </a:rPr>
+              <a:t>Native calibrated confidence 0.894 vs. the prior system's Faithfulness 0.880 — different constructs, not a claim of higher accuracy.</a:t>
+            </a:r>
+          </a:p>
+        </p:txBody>
+      </p:sp>
+      <p:sp>
+        <p:nvSpPr>
+          <p:cNvPr id="7" name="TextBox 6"/>
+          <p:cNvSpPr txBox="1"/>
+          <p:nvPr/>
+        </p:nvSpPr>
+        <p:spPr>
+          <a:xfrm>
+            <a:off x="731520" y="6355080"/>
+            <a:ext cx="10728655" cy="365760"/>
+          </a:xfrm>
+          <a:prstGeom prst="rect">
+            <a:avLst/>
+          </a:prstGeom>
+          <a:noFill/>
+        </p:spPr>
+        <p:txBody>
+          <a:bodyPr wrap="square">
+            <a:spAutoFit/>
+          </a:bodyPr>
+          <a:lstStyle/>
+          <a:p>
+            <a:pPr algn="l"/>
+            <a:r>
+              <a:rPr sz="1200" b="0" i="1" u="none">
+                <a:solidFill>
+                  <a:srgbClr val="595959"/>
+                </a:solidFill>
+                <a:latin typeface="Arial"/>
+              </a:rPr>
+              <a:t>Section V — Results and Discussion</a:t>
             </a:r>
           </a:p>
         </p:txBody>

</xml_diff>

<commit_message>
feat: rewrite ICAIDES deck, Slides 13-14 Conclusion + Thank You (6/6)
Deck complete at 14 slides. Verified: white backgrounds, no solid black
fills, Arial throughout the whole deck.

Co-Authored-By: Claude Sonnet 5 <noreply@anthropic.com>
</commit_message>
<xml_diff>
--- a/docs/presentation/icaides2026_jev.pptx
+++ b/docs/presentation/icaides2026_jev.pptx
@@ -17,6 +17,8 @@
     <p:sldId id="265" r:id="rId16"/>
     <p:sldId id="266" r:id="rId17"/>
     <p:sldId id="267" r:id="rId18"/>
+    <p:sldId id="268" r:id="rId19"/>
+    <p:sldId id="269" r:id="rId20"/>
   </p:sldIdLst>
   <p:sldSz cx="12191695" cy="6858000" type="screen4x3"/>
   <p:notesSz cx="6858000" cy="9144000"/>
@@ -3951,6 +3953,492 @@
                 <a:latin typeface="Arial"/>
               </a:rPr>
               <a:t>Section V — Results and Discussion</a:t>
+            </a:r>
+          </a:p>
+        </p:txBody>
+      </p:sp>
+    </p:spTree>
+  </p:cSld>
+  <p:clrMapOvr>
+    <a:masterClrMapping/>
+  </p:clrMapOvr>
+</p:sld>
+</file>
+
+<file path=ppt/slides/slide13.xml><?xml version="1.0" encoding="utf-8"?>
+<p:sld xmlns:a="http://schemas.openxmlformats.org/drawingml/2006/main" xmlns:p="http://schemas.openxmlformats.org/presentationml/2006/main" xmlns:r="http://schemas.openxmlformats.org/officeDocument/2006/relationships">
+  <p:cSld>
+    <p:bg>
+      <p:bgPr>
+        <a:solidFill>
+          <a:srgbClr val="FFFFFF"/>
+        </a:solidFill>
+        <a:effectLst/>
+      </p:bgPr>
+    </p:bg>
+    <p:spTree>
+      <p:nvGrpSpPr>
+        <p:cNvPr id="1" name=""/>
+        <p:cNvGrpSpPr/>
+        <p:nvPr/>
+      </p:nvGrpSpPr>
+      <p:grpSpPr/>
+      <p:sp>
+        <p:nvSpPr>
+          <p:cNvPr id="2" name="TextBox 1"/>
+          <p:cNvSpPr txBox="1"/>
+          <p:nvPr/>
+        </p:nvSpPr>
+        <p:spPr>
+          <a:xfrm>
+            <a:off x="731520" y="411480"/>
+            <a:ext cx="10728655" cy="320040"/>
+          </a:xfrm>
+          <a:prstGeom prst="rect">
+            <a:avLst/>
+          </a:prstGeom>
+          <a:noFill/>
+        </p:spPr>
+        <p:txBody>
+          <a:bodyPr wrap="square">
+            <a:spAutoFit/>
+          </a:bodyPr>
+          <a:lstStyle/>
+          <a:p>
+            <a:pPr algn="l"/>
+            <a:r>
+              <a:rPr sz="1300" b="1" i="0" u="none">
+                <a:solidFill>
+                  <a:srgbClr val="595959"/>
+                </a:solidFill>
+                <a:latin typeface="Arial"/>
+              </a:rPr>
+              <a:t>CONCLUSION</a:t>
+            </a:r>
+          </a:p>
+        </p:txBody>
+      </p:sp>
+      <p:sp>
+        <p:nvSpPr>
+          <p:cNvPr id="3" name="TextBox 2"/>
+          <p:cNvSpPr txBox="1"/>
+          <p:nvPr/>
+        </p:nvSpPr>
+        <p:spPr>
+          <a:xfrm>
+            <a:off x="731520" y="777240"/>
+            <a:ext cx="10728655" cy="1005840"/>
+          </a:xfrm>
+          <a:prstGeom prst="rect">
+            <a:avLst/>
+          </a:prstGeom>
+          <a:noFill/>
+        </p:spPr>
+        <p:txBody>
+          <a:bodyPr wrap="square">
+            <a:spAutoFit/>
+          </a:bodyPr>
+          <a:lstStyle/>
+          <a:p>
+            <a:pPr algn="l"/>
+            <a:r>
+              <a:rPr sz="3000" b="1" i="0" u="none">
+                <a:solidFill>
+                  <a:srgbClr val="000000"/>
+                </a:solidFill>
+                <a:latin typeface="Arial"/>
+              </a:rPr>
+              <a:t>Conclusion</a:t>
+            </a:r>
+          </a:p>
+        </p:txBody>
+      </p:sp>
+      <p:sp>
+        <p:nvSpPr>
+          <p:cNvPr id="4" name="TextBox 3"/>
+          <p:cNvSpPr txBox="1"/>
+          <p:nvPr/>
+        </p:nvSpPr>
+        <p:spPr>
+          <a:xfrm>
+            <a:off x="822960" y="1828800"/>
+            <a:ext cx="10545775" cy="365760"/>
+          </a:xfrm>
+          <a:prstGeom prst="rect">
+            <a:avLst/>
+          </a:prstGeom>
+          <a:noFill/>
+        </p:spPr>
+        <p:txBody>
+          <a:bodyPr wrap="square">
+            <a:spAutoFit/>
+          </a:bodyPr>
+          <a:lstStyle/>
+          <a:p>
+            <a:pPr algn="l"/>
+            <a:r>
+              <a:rPr sz="1800" b="1" i="0" u="sng">
+                <a:solidFill>
+                  <a:srgbClr val="000000"/>
+                </a:solidFill>
+                <a:latin typeface="Arial"/>
+              </a:rPr>
+              <a:t>Key Takeaways</a:t>
+            </a:r>
+          </a:p>
+        </p:txBody>
+      </p:sp>
+      <p:sp>
+        <p:nvSpPr>
+          <p:cNvPr id="5" name="TextBox 4"/>
+          <p:cNvSpPr txBox="1"/>
+          <p:nvPr/>
+        </p:nvSpPr>
+        <p:spPr>
+          <a:xfrm>
+            <a:off x="1005840" y="2286000"/>
+            <a:ext cx="10180015" cy="1645920"/>
+          </a:xfrm>
+          <a:prstGeom prst="rect">
+            <a:avLst/>
+          </a:prstGeom>
+          <a:noFill/>
+        </p:spPr>
+        <p:txBody>
+          <a:bodyPr wrap="square">
+            <a:spAutoFit/>
+          </a:bodyPr>
+          <a:lstStyle/>
+          <a:p>
+            <a:pPr>
+              <a:spcAft>
+                <a:spcPts val="1200"/>
+              </a:spcAft>
+            </a:pPr>
+            <a:r>
+              <a:rPr sz="1600">
+                <a:solidFill>
+                  <a:srgbClr val="000000"/>
+                </a:solidFill>
+                <a:latin typeface="Arial"/>
+              </a:rPr>
+              <a:t>•  Confidence: 0.672 → 0.894 per requirement</a:t>
+            </a:r>
+          </a:p>
+          <a:p>
+            <a:pPr>
+              <a:spcAft>
+                <a:spcPts val="1200"/>
+              </a:spcAft>
+            </a:pPr>
+            <a:r>
+              <a:rPr sz="1600">
+                <a:solidFill>
+                  <a:srgbClr val="000000"/>
+                </a:solidFill>
+                <a:latin typeface="Arial"/>
+              </a:rPr>
+              <a:t>•  273 vs. ~2,061 model calls, ~4.5× lower latency</a:t>
+            </a:r>
+          </a:p>
+          <a:p>
+            <a:pPr>
+              <a:spcAft>
+                <a:spcPts val="1200"/>
+              </a:spcAft>
+            </a:pPr>
+            <a:r>
+              <a:rPr sz="1600">
+                <a:solidFill>
+                  <a:srgbClr val="000000"/>
+                </a:solidFill>
+                <a:latin typeface="Arial"/>
+              </a:rPr>
+              <a:t>•  Ranking stability: Kendall's τ = 0.965 vs. ≈0.957</a:t>
+            </a:r>
+          </a:p>
+        </p:txBody>
+      </p:sp>
+      <p:sp>
+        <p:nvSpPr>
+          <p:cNvPr id="6" name="TextBox 5"/>
+          <p:cNvSpPr txBox="1"/>
+          <p:nvPr/>
+        </p:nvSpPr>
+        <p:spPr>
+          <a:xfrm>
+            <a:off x="822960" y="4114800"/>
+            <a:ext cx="10545775" cy="365760"/>
+          </a:xfrm>
+          <a:prstGeom prst="rect">
+            <a:avLst/>
+          </a:prstGeom>
+          <a:noFill/>
+        </p:spPr>
+        <p:txBody>
+          <a:bodyPr wrap="square">
+            <a:spAutoFit/>
+          </a:bodyPr>
+          <a:lstStyle/>
+          <a:p>
+            <a:pPr algn="l"/>
+            <a:r>
+              <a:rPr sz="1800" b="1" i="0" u="sng">
+                <a:solidFill>
+                  <a:srgbClr val="000000"/>
+                </a:solidFill>
+                <a:latin typeface="Arial"/>
+              </a:rPr>
+              <a:t>Limitations &amp; Future Work</a:t>
+            </a:r>
+          </a:p>
+        </p:txBody>
+      </p:sp>
+      <p:sp>
+        <p:nvSpPr>
+          <p:cNvPr id="7" name="TextBox 6"/>
+          <p:cNvSpPr txBox="1"/>
+          <p:nvPr/>
+        </p:nvSpPr>
+        <p:spPr>
+          <a:xfrm>
+            <a:off x="1005840" y="4572000"/>
+            <a:ext cx="10180015" cy="1645920"/>
+          </a:xfrm>
+          <a:prstGeom prst="rect">
+            <a:avLst/>
+          </a:prstGeom>
+          <a:noFill/>
+        </p:spPr>
+        <p:txBody>
+          <a:bodyPr wrap="square">
+            <a:spAutoFit/>
+          </a:bodyPr>
+          <a:lstStyle/>
+          <a:p>
+            <a:pPr>
+              <a:spcAft>
+                <a:spcPts val="1200"/>
+              </a:spcAft>
+            </a:pPr>
+            <a:r>
+              <a:rPr sz="1600">
+                <a:solidFill>
+                  <a:srgbClr val="000000"/>
+                </a:solidFill>
+                <a:latin typeface="Arial"/>
+              </a:rPr>
+              <a:t>•  Calibration ≠ correctness — test against ground truth next</a:t>
+            </a:r>
+          </a:p>
+          <a:p>
+            <a:pPr>
+              <a:spcAft>
+                <a:spcPts val="1200"/>
+              </a:spcAft>
+            </a:pPr>
+            <a:r>
+              <a:rPr sz="1600">
+                <a:solidFill>
+                  <a:srgbClr val="000000"/>
+                </a:solidFill>
+                <a:latin typeface="Arial"/>
+              </a:rPr>
+              <a:t>•  Only a 5-level scale tested; Jev supports up to 10</a:t>
+            </a:r>
+          </a:p>
+          <a:p>
+            <a:pPr>
+              <a:spcAft>
+                <a:spcPts val="1200"/>
+              </a:spcAft>
+            </a:pPr>
+            <a:r>
+              <a:rPr sz="1600">
+                <a:solidFill>
+                  <a:srgbClr val="000000"/>
+                </a:solidFill>
+                <a:latin typeface="Arial"/>
+              </a:rPr>
+              <a:t>•  One pipeline — independent replication would strengthen the case</a:t>
+            </a:r>
+          </a:p>
+        </p:txBody>
+      </p:sp>
+      <p:sp>
+        <p:nvSpPr>
+          <p:cNvPr id="8" name="TextBox 7"/>
+          <p:cNvSpPr txBox="1"/>
+          <p:nvPr/>
+        </p:nvSpPr>
+        <p:spPr>
+          <a:xfrm>
+            <a:off x="731520" y="6355080"/>
+            <a:ext cx="10728655" cy="365760"/>
+          </a:xfrm>
+          <a:prstGeom prst="rect">
+            <a:avLst/>
+          </a:prstGeom>
+          <a:noFill/>
+        </p:spPr>
+        <p:txBody>
+          <a:bodyPr wrap="square">
+            <a:spAutoFit/>
+          </a:bodyPr>
+          <a:lstStyle/>
+          <a:p>
+            <a:pPr algn="l"/>
+            <a:r>
+              <a:rPr sz="1200" b="0" i="1" u="none">
+                <a:solidFill>
+                  <a:srgbClr val="595959"/>
+                </a:solidFill>
+                <a:latin typeface="Arial"/>
+              </a:rPr>
+              <a:t>Section VI — Conclusion</a:t>
+            </a:r>
+          </a:p>
+        </p:txBody>
+      </p:sp>
+    </p:spTree>
+  </p:cSld>
+  <p:clrMapOvr>
+    <a:masterClrMapping/>
+  </p:clrMapOvr>
+</p:sld>
+</file>
+
+<file path=ppt/slides/slide14.xml><?xml version="1.0" encoding="utf-8"?>
+<p:sld xmlns:a="http://schemas.openxmlformats.org/drawingml/2006/main" xmlns:p="http://schemas.openxmlformats.org/presentationml/2006/main" xmlns:r="http://schemas.openxmlformats.org/officeDocument/2006/relationships">
+  <p:cSld>
+    <p:bg>
+      <p:bgPr>
+        <a:solidFill>
+          <a:srgbClr val="FFFFFF"/>
+        </a:solidFill>
+        <a:effectLst/>
+      </p:bgPr>
+    </p:bg>
+    <p:spTree>
+      <p:nvGrpSpPr>
+        <p:cNvPr id="1" name=""/>
+        <p:cNvGrpSpPr/>
+        <p:nvPr/>
+      </p:nvGrpSpPr>
+      <p:grpSpPr/>
+      <p:sp>
+        <p:nvSpPr>
+          <p:cNvPr id="2" name="TextBox 1"/>
+          <p:cNvSpPr txBox="1"/>
+          <p:nvPr/>
+        </p:nvSpPr>
+        <p:spPr>
+          <a:xfrm>
+            <a:off x="731520" y="2377440"/>
+            <a:ext cx="10728655" cy="1097280"/>
+          </a:xfrm>
+          <a:prstGeom prst="rect">
+            <a:avLst/>
+          </a:prstGeom>
+          <a:noFill/>
+        </p:spPr>
+        <p:txBody>
+          <a:bodyPr wrap="square">
+            <a:spAutoFit/>
+          </a:bodyPr>
+          <a:lstStyle/>
+          <a:p>
+            <a:pPr algn="ctr"/>
+            <a:r>
+              <a:rPr sz="4800" b="1" i="0" u="none">
+                <a:solidFill>
+                  <a:srgbClr val="000000"/>
+                </a:solidFill>
+                <a:latin typeface="Arial"/>
+              </a:rPr>
+              <a:t>Thank You</a:t>
+            </a:r>
+          </a:p>
+        </p:txBody>
+      </p:sp>
+      <p:sp>
+        <p:nvSpPr>
+          <p:cNvPr id="3" name="TextBox 2"/>
+          <p:cNvSpPr txBox="1"/>
+          <p:nvPr/>
+        </p:nvSpPr>
+        <p:spPr>
+          <a:xfrm>
+            <a:off x="731520" y="3566160"/>
+            <a:ext cx="10728655" cy="548640"/>
+          </a:xfrm>
+          <a:prstGeom prst="rect">
+            <a:avLst/>
+          </a:prstGeom>
+          <a:noFill/>
+        </p:spPr>
+        <p:txBody>
+          <a:bodyPr wrap="square">
+            <a:spAutoFit/>
+          </a:bodyPr>
+          <a:lstStyle/>
+          <a:p>
+            <a:pPr algn="ctr"/>
+            <a:r>
+              <a:rPr sz="2200" b="0" i="0" u="none">
+                <a:solidFill>
+                  <a:srgbClr val="595959"/>
+                </a:solidFill>
+                <a:latin typeface="Arial"/>
+              </a:rPr>
+              <a:t>Questions &amp; Discussion</a:t>
+            </a:r>
+          </a:p>
+        </p:txBody>
+      </p:sp>
+      <p:sp>
+        <p:nvSpPr>
+          <p:cNvPr id="4" name="TextBox 3"/>
+          <p:cNvSpPr txBox="1"/>
+          <p:nvPr/>
+        </p:nvSpPr>
+        <p:spPr>
+          <a:xfrm>
+            <a:off x="731520" y="4663440"/>
+            <a:ext cx="10728655" cy="914400"/>
+          </a:xfrm>
+          <a:prstGeom prst="rect">
+            <a:avLst/>
+          </a:prstGeom>
+          <a:noFill/>
+        </p:spPr>
+        <p:txBody>
+          <a:bodyPr wrap="square">
+            <a:spAutoFit/>
+          </a:bodyPr>
+          <a:lstStyle/>
+          <a:p>
+            <a:pPr algn="ctr"/>
+            <a:r>
+              <a:rPr sz="1500" b="0" i="0" u="none">
+                <a:solidFill>
+                  <a:srgbClr val="595959"/>
+                </a:solidFill>
+                <a:latin typeface="Arial"/>
+              </a:rPr>
+              <a:t>Jessie Angelica · President University</a:t>
+            </a:r>
+          </a:p>
+          <a:p>
+            <a:pPr algn="ctr"/>
+            <a:r>
+              <a:rPr sz="1500" b="0" i="0" u="none">
+                <a:solidFill>
+                  <a:srgbClr val="595959"/>
+                </a:solidFill>
+                <a:latin typeface="Arial"/>
+              </a:rPr>
+              <a:t>fahmi.zuhri@unitar.my</a:t>
             </a:r>
           </a:p>
         </p:txBody>

</xml_diff>

<commit_message>
feat: rebuild Slides 2, 4, 5, 13 as diagrams instead of paragraph bullets
Reuses the existing add_compare and outline_box primitives (no new
helpers) so the remaining paragraph-style slides match the box/diagram
visual language already used on Slides 3, 6-8, and 10-12. Still
outline-only, no fills, no icons, per the approved visual system.

Co-Authored-By: Claude Sonnet 5 <noreply@anthropic.com>
</commit_message>
<xml_diff>
--- a/docs/presentation/icaides2026_jev.pptx
+++ b/docs/presentation/icaides2026_jev.pptx
@@ -4061,7 +4061,7 @@
         </p:nvSpPr>
         <p:spPr>
           <a:xfrm>
-            <a:off x="822960" y="1828800"/>
+            <a:off x="822960" y="1691640"/>
             <a:ext cx="10545775" cy="365760"/>
           </a:xfrm>
           <a:prstGeom prst="rect">
@@ -4090,84 +4090,355 @@
       </p:sp>
       <p:sp>
         <p:nvSpPr>
-          <p:cNvPr id="5" name="TextBox 4"/>
-          <p:cNvSpPr txBox="1"/>
-          <p:nvPr/>
-        </p:nvSpPr>
-        <p:spPr>
-          <a:xfrm>
-            <a:off x="1005840" y="2286000"/>
-            <a:ext cx="10180015" cy="1645920"/>
-          </a:xfrm>
-          <a:prstGeom prst="rect">
-            <a:avLst/>
-          </a:prstGeom>
-          <a:noFill/>
-        </p:spPr>
-        <p:txBody>
-          <a:bodyPr wrap="square">
-            <a:spAutoFit/>
-          </a:bodyPr>
-          <a:lstStyle/>
-          <a:p>
-            <a:pPr>
-              <a:spcAft>
-                <a:spcPts val="1200"/>
-              </a:spcAft>
-            </a:pPr>
-            <a:r>
-              <a:rPr sz="1600">
+          <p:cNvPr id="5" name="Rectangle 4"/>
+          <p:cNvSpPr/>
+          <p:nvPr/>
+        </p:nvSpPr>
+        <p:spPr>
+          <a:xfrm>
+            <a:off x="746607" y="2194560"/>
+            <a:ext cx="3383280" cy="1371600"/>
+          </a:xfrm>
+          <a:prstGeom prst="rect">
+            <a:avLst/>
+          </a:prstGeom>
+          <a:noFill/>
+          <a:ln w="19050">
+            <a:solidFill>
+              <a:srgbClr val="000000"/>
+            </a:solidFill>
+          </a:ln>
+          <a:effectLst/>
+        </p:spPr>
+        <p:style>
+          <a:lnRef idx="1">
+            <a:schemeClr val="accent1"/>
+          </a:lnRef>
+          <a:fillRef idx="3">
+            <a:schemeClr val="accent1"/>
+          </a:fillRef>
+          <a:effectRef idx="2">
+            <a:schemeClr val="accent1"/>
+          </a:effectRef>
+          <a:fontRef idx="minor">
+            <a:schemeClr val="lt1"/>
+          </a:fontRef>
+        </p:style>
+        <p:txBody>
+          <a:bodyPr rtlCol="0" anchor="ctr"/>
+          <a:lstStyle/>
+          <a:p>
+            <a:pPr algn="ctr"/>
+          </a:p>
+        </p:txBody>
+      </p:sp>
+      <p:sp>
+        <p:nvSpPr>
+          <p:cNvPr id="6" name="TextBox 5"/>
+          <p:cNvSpPr txBox="1"/>
+          <p:nvPr/>
+        </p:nvSpPr>
+        <p:spPr>
+          <a:xfrm>
+            <a:off x="746607" y="2331720"/>
+            <a:ext cx="3383280" cy="548640"/>
+          </a:xfrm>
+          <a:prstGeom prst="rect">
+            <a:avLst/>
+          </a:prstGeom>
+          <a:noFill/>
+        </p:spPr>
+        <p:txBody>
+          <a:bodyPr wrap="square">
+            <a:spAutoFit/>
+          </a:bodyPr>
+          <a:lstStyle/>
+          <a:p>
+            <a:pPr algn="ctr"/>
+            <a:r>
+              <a:rPr sz="1900" b="1" i="0" u="none">
                 <a:solidFill>
                   <a:srgbClr val="000000"/>
                 </a:solidFill>
                 <a:latin typeface="Arial"/>
               </a:rPr>
-              <a:t>•  Confidence: 0.672 → 0.894 per requirement</a:t>
-            </a:r>
-          </a:p>
-          <a:p>
-            <a:pPr>
-              <a:spcAft>
-                <a:spcPts val="1200"/>
-              </a:spcAft>
-            </a:pPr>
-            <a:r>
-              <a:rPr sz="1600">
+              <a:t>0.672 → 0.894</a:t>
+            </a:r>
+          </a:p>
+        </p:txBody>
+      </p:sp>
+      <p:sp>
+        <p:nvSpPr>
+          <p:cNvPr id="7" name="TextBox 6"/>
+          <p:cNvSpPr txBox="1"/>
+          <p:nvPr/>
+        </p:nvSpPr>
+        <p:spPr>
+          <a:xfrm>
+            <a:off x="883767" y="2971800"/>
+            <a:ext cx="3108960" cy="548640"/>
+          </a:xfrm>
+          <a:prstGeom prst="rect">
+            <a:avLst/>
+          </a:prstGeom>
+          <a:noFill/>
+        </p:spPr>
+        <p:txBody>
+          <a:bodyPr wrap="square">
+            <a:spAutoFit/>
+          </a:bodyPr>
+          <a:lstStyle/>
+          <a:p>
+            <a:pPr algn="ctr"/>
+            <a:r>
+              <a:rPr sz="1200" b="0" i="0" u="none">
+                <a:solidFill>
+                  <a:srgbClr val="595959"/>
+                </a:solidFill>
+                <a:latin typeface="Arial"/>
+              </a:rPr>
+              <a:t>confidence per requirement</a:t>
+            </a:r>
+          </a:p>
+        </p:txBody>
+      </p:sp>
+      <p:sp>
+        <p:nvSpPr>
+          <p:cNvPr id="8" name="Rectangle 7"/>
+          <p:cNvSpPr/>
+          <p:nvPr/>
+        </p:nvSpPr>
+        <p:spPr>
+          <a:xfrm>
+            <a:off x="4404207" y="2194560"/>
+            <a:ext cx="3383280" cy="1371600"/>
+          </a:xfrm>
+          <a:prstGeom prst="rect">
+            <a:avLst/>
+          </a:prstGeom>
+          <a:noFill/>
+          <a:ln w="19050">
+            <a:solidFill>
+              <a:srgbClr val="000000"/>
+            </a:solidFill>
+          </a:ln>
+          <a:effectLst/>
+        </p:spPr>
+        <p:style>
+          <a:lnRef idx="1">
+            <a:schemeClr val="accent1"/>
+          </a:lnRef>
+          <a:fillRef idx="3">
+            <a:schemeClr val="accent1"/>
+          </a:fillRef>
+          <a:effectRef idx="2">
+            <a:schemeClr val="accent1"/>
+          </a:effectRef>
+          <a:fontRef idx="minor">
+            <a:schemeClr val="lt1"/>
+          </a:fontRef>
+        </p:style>
+        <p:txBody>
+          <a:bodyPr rtlCol="0" anchor="ctr"/>
+          <a:lstStyle/>
+          <a:p>
+            <a:pPr algn="ctr"/>
+          </a:p>
+        </p:txBody>
+      </p:sp>
+      <p:sp>
+        <p:nvSpPr>
+          <p:cNvPr id="9" name="TextBox 8"/>
+          <p:cNvSpPr txBox="1"/>
+          <p:nvPr/>
+        </p:nvSpPr>
+        <p:spPr>
+          <a:xfrm>
+            <a:off x="4404207" y="2331720"/>
+            <a:ext cx="3383280" cy="548640"/>
+          </a:xfrm>
+          <a:prstGeom prst="rect">
+            <a:avLst/>
+          </a:prstGeom>
+          <a:noFill/>
+        </p:spPr>
+        <p:txBody>
+          <a:bodyPr wrap="square">
+            <a:spAutoFit/>
+          </a:bodyPr>
+          <a:lstStyle/>
+          <a:p>
+            <a:pPr algn="ctr"/>
+            <a:r>
+              <a:rPr sz="1900" b="1" i="0" u="none">
                 <a:solidFill>
                   <a:srgbClr val="000000"/>
                 </a:solidFill>
                 <a:latin typeface="Arial"/>
               </a:rPr>
-              <a:t>•  273 vs. ~2,061 model calls, ~4.5× lower latency</a:t>
-            </a:r>
-          </a:p>
-          <a:p>
-            <a:pPr>
-              <a:spcAft>
-                <a:spcPts val="1200"/>
-              </a:spcAft>
-            </a:pPr>
-            <a:r>
-              <a:rPr sz="1600">
+              <a:t>273 vs. ~2,061</a:t>
+            </a:r>
+          </a:p>
+        </p:txBody>
+      </p:sp>
+      <p:sp>
+        <p:nvSpPr>
+          <p:cNvPr id="10" name="TextBox 9"/>
+          <p:cNvSpPr txBox="1"/>
+          <p:nvPr/>
+        </p:nvSpPr>
+        <p:spPr>
+          <a:xfrm>
+            <a:off x="4541367" y="2971800"/>
+            <a:ext cx="3108960" cy="548640"/>
+          </a:xfrm>
+          <a:prstGeom prst="rect">
+            <a:avLst/>
+          </a:prstGeom>
+          <a:noFill/>
+        </p:spPr>
+        <p:txBody>
+          <a:bodyPr wrap="square">
+            <a:spAutoFit/>
+          </a:bodyPr>
+          <a:lstStyle/>
+          <a:p>
+            <a:pPr algn="ctr"/>
+            <a:r>
+              <a:rPr sz="1200" b="0" i="0" u="none">
+                <a:solidFill>
+                  <a:srgbClr val="595959"/>
+                </a:solidFill>
+                <a:latin typeface="Arial"/>
+              </a:rPr>
+              <a:t>model calls, ~4.5× faster</a:t>
+            </a:r>
+          </a:p>
+        </p:txBody>
+      </p:sp>
+      <p:sp>
+        <p:nvSpPr>
+          <p:cNvPr id="11" name="Rectangle 10"/>
+          <p:cNvSpPr/>
+          <p:nvPr/>
+        </p:nvSpPr>
+        <p:spPr>
+          <a:xfrm>
+            <a:off x="8061807" y="2194560"/>
+            <a:ext cx="3383280" cy="1371600"/>
+          </a:xfrm>
+          <a:prstGeom prst="rect">
+            <a:avLst/>
+          </a:prstGeom>
+          <a:noFill/>
+          <a:ln w="19050">
+            <a:solidFill>
+              <a:srgbClr val="000000"/>
+            </a:solidFill>
+          </a:ln>
+          <a:effectLst/>
+        </p:spPr>
+        <p:style>
+          <a:lnRef idx="1">
+            <a:schemeClr val="accent1"/>
+          </a:lnRef>
+          <a:fillRef idx="3">
+            <a:schemeClr val="accent1"/>
+          </a:fillRef>
+          <a:effectRef idx="2">
+            <a:schemeClr val="accent1"/>
+          </a:effectRef>
+          <a:fontRef idx="minor">
+            <a:schemeClr val="lt1"/>
+          </a:fontRef>
+        </p:style>
+        <p:txBody>
+          <a:bodyPr rtlCol="0" anchor="ctr"/>
+          <a:lstStyle/>
+          <a:p>
+            <a:pPr algn="ctr"/>
+          </a:p>
+        </p:txBody>
+      </p:sp>
+      <p:sp>
+        <p:nvSpPr>
+          <p:cNvPr id="12" name="TextBox 11"/>
+          <p:cNvSpPr txBox="1"/>
+          <p:nvPr/>
+        </p:nvSpPr>
+        <p:spPr>
+          <a:xfrm>
+            <a:off x="8061807" y="2331720"/>
+            <a:ext cx="3383280" cy="548640"/>
+          </a:xfrm>
+          <a:prstGeom prst="rect">
+            <a:avLst/>
+          </a:prstGeom>
+          <a:noFill/>
+        </p:spPr>
+        <p:txBody>
+          <a:bodyPr wrap="square">
+            <a:spAutoFit/>
+          </a:bodyPr>
+          <a:lstStyle/>
+          <a:p>
+            <a:pPr algn="ctr"/>
+            <a:r>
+              <a:rPr sz="1900" b="1" i="0" u="none">
                 <a:solidFill>
                   <a:srgbClr val="000000"/>
                 </a:solidFill>
                 <a:latin typeface="Arial"/>
               </a:rPr>
-              <a:t>•  Ranking stability: Kendall's τ = 0.965 vs. ≈0.957</a:t>
-            </a:r>
-          </a:p>
-        </p:txBody>
-      </p:sp>
-      <p:sp>
-        <p:nvSpPr>
-          <p:cNvPr id="6" name="TextBox 5"/>
-          <p:cNvSpPr txBox="1"/>
-          <p:nvPr/>
-        </p:nvSpPr>
-        <p:spPr>
-          <a:xfrm>
-            <a:off x="822960" y="4114800"/>
+              <a:t>0.965 vs. ≈0.957</a:t>
+            </a:r>
+          </a:p>
+        </p:txBody>
+      </p:sp>
+      <p:sp>
+        <p:nvSpPr>
+          <p:cNvPr id="13" name="TextBox 12"/>
+          <p:cNvSpPr txBox="1"/>
+          <p:nvPr/>
+        </p:nvSpPr>
+        <p:spPr>
+          <a:xfrm>
+            <a:off x="8198967" y="2971800"/>
+            <a:ext cx="3108960" cy="548640"/>
+          </a:xfrm>
+          <a:prstGeom prst="rect">
+            <a:avLst/>
+          </a:prstGeom>
+          <a:noFill/>
+        </p:spPr>
+        <p:txBody>
+          <a:bodyPr wrap="square">
+            <a:spAutoFit/>
+          </a:bodyPr>
+          <a:lstStyle/>
+          <a:p>
+            <a:pPr algn="ctr"/>
+            <a:r>
+              <a:rPr sz="1200" b="0" i="0" u="none">
+                <a:solidFill>
+                  <a:srgbClr val="595959"/>
+                </a:solidFill>
+                <a:latin typeface="Arial"/>
+              </a:rPr>
+              <a:t>ranking stability (Kendall's τ)</a:t>
+            </a:r>
+          </a:p>
+        </p:txBody>
+      </p:sp>
+      <p:sp>
+        <p:nvSpPr>
+          <p:cNvPr id="14" name="TextBox 13"/>
+          <p:cNvSpPr txBox="1"/>
+          <p:nvPr/>
+        </p:nvSpPr>
+        <p:spPr>
+          <a:xfrm>
+            <a:off x="822960" y="3840480"/>
             <a:ext cx="10545775" cy="365760"/>
           </a:xfrm>
           <a:prstGeom prst="rect">
@@ -4196,78 +4467,349 @@
       </p:sp>
       <p:sp>
         <p:nvSpPr>
-          <p:cNvPr id="7" name="TextBox 6"/>
-          <p:cNvSpPr txBox="1"/>
-          <p:nvPr/>
-        </p:nvSpPr>
-        <p:spPr>
-          <a:xfrm>
-            <a:off x="1005840" y="4572000"/>
-            <a:ext cx="10180015" cy="1645920"/>
-          </a:xfrm>
-          <a:prstGeom prst="rect">
-            <a:avLst/>
-          </a:prstGeom>
-          <a:noFill/>
-        </p:spPr>
-        <p:txBody>
-          <a:bodyPr wrap="square">
-            <a:spAutoFit/>
-          </a:bodyPr>
-          <a:lstStyle/>
-          <a:p>
-            <a:pPr>
-              <a:spcAft>
-                <a:spcPts val="1200"/>
-              </a:spcAft>
-            </a:pPr>
-            <a:r>
-              <a:rPr sz="1600">
+          <p:cNvPr id="15" name="Rectangle 14"/>
+          <p:cNvSpPr/>
+          <p:nvPr/>
+        </p:nvSpPr>
+        <p:spPr>
+          <a:xfrm>
+            <a:off x="746607" y="4343400"/>
+            <a:ext cx="3383280" cy="1554480"/>
+          </a:xfrm>
+          <a:prstGeom prst="rect">
+            <a:avLst/>
+          </a:prstGeom>
+          <a:noFill/>
+          <a:ln w="19050">
+            <a:solidFill>
+              <a:srgbClr val="000000"/>
+            </a:solidFill>
+          </a:ln>
+          <a:effectLst/>
+        </p:spPr>
+        <p:style>
+          <a:lnRef idx="1">
+            <a:schemeClr val="accent1"/>
+          </a:lnRef>
+          <a:fillRef idx="3">
+            <a:schemeClr val="accent1"/>
+          </a:fillRef>
+          <a:effectRef idx="2">
+            <a:schemeClr val="accent1"/>
+          </a:effectRef>
+          <a:fontRef idx="minor">
+            <a:schemeClr val="lt1"/>
+          </a:fontRef>
+        </p:style>
+        <p:txBody>
+          <a:bodyPr rtlCol="0" anchor="ctr"/>
+          <a:lstStyle/>
+          <a:p>
+            <a:pPr algn="ctr"/>
+          </a:p>
+        </p:txBody>
+      </p:sp>
+      <p:sp>
+        <p:nvSpPr>
+          <p:cNvPr id="16" name="TextBox 15"/>
+          <p:cNvSpPr txBox="1"/>
+          <p:nvPr/>
+        </p:nvSpPr>
+        <p:spPr>
+          <a:xfrm>
+            <a:off x="883767" y="4526280"/>
+            <a:ext cx="3108960" cy="640080"/>
+          </a:xfrm>
+          <a:prstGeom prst="rect">
+            <a:avLst/>
+          </a:prstGeom>
+          <a:noFill/>
+        </p:spPr>
+        <p:txBody>
+          <a:bodyPr wrap="square">
+            <a:spAutoFit/>
+          </a:bodyPr>
+          <a:lstStyle/>
+          <a:p>
+            <a:pPr algn="ctr"/>
+            <a:r>
+              <a:rPr sz="1500" b="1" i="0" u="none">
                 <a:solidFill>
                   <a:srgbClr val="000000"/>
                 </a:solidFill>
                 <a:latin typeface="Arial"/>
               </a:rPr>
-              <a:t>•  Calibration ≠ correctness — test against ground truth next</a:t>
-            </a:r>
-          </a:p>
-          <a:p>
-            <a:pPr>
-              <a:spcAft>
-                <a:spcPts val="1200"/>
-              </a:spcAft>
-            </a:pPr>
-            <a:r>
-              <a:rPr sz="1600">
+              <a:t>Calibration ≠ correctness</a:t>
+            </a:r>
+          </a:p>
+        </p:txBody>
+      </p:sp>
+      <p:sp>
+        <p:nvSpPr>
+          <p:cNvPr id="17" name="TextBox 16"/>
+          <p:cNvSpPr txBox="1"/>
+          <p:nvPr/>
+        </p:nvSpPr>
+        <p:spPr>
+          <a:xfrm>
+            <a:off x="883767" y="5212080"/>
+            <a:ext cx="3108960" cy="640080"/>
+          </a:xfrm>
+          <a:prstGeom prst="rect">
+            <a:avLst/>
+          </a:prstGeom>
+          <a:noFill/>
+        </p:spPr>
+        <p:txBody>
+          <a:bodyPr wrap="square">
+            <a:spAutoFit/>
+          </a:bodyPr>
+          <a:lstStyle/>
+          <a:p>
+            <a:pPr algn="ctr"/>
+            <a:r>
+              <a:rPr sz="1200" b="0" i="0" u="none">
+                <a:solidFill>
+                  <a:srgbClr val="595959"/>
+                </a:solidFill>
+                <a:latin typeface="Arial"/>
+              </a:rPr>
+              <a:t>test against ground truth next</a:t>
+            </a:r>
+          </a:p>
+        </p:txBody>
+      </p:sp>
+      <p:sp>
+        <p:nvSpPr>
+          <p:cNvPr id="18" name="Rectangle 17"/>
+          <p:cNvSpPr/>
+          <p:nvPr/>
+        </p:nvSpPr>
+        <p:spPr>
+          <a:xfrm>
+            <a:off x="4404207" y="4343400"/>
+            <a:ext cx="3383280" cy="1554480"/>
+          </a:xfrm>
+          <a:prstGeom prst="rect">
+            <a:avLst/>
+          </a:prstGeom>
+          <a:noFill/>
+          <a:ln w="19050">
+            <a:solidFill>
+              <a:srgbClr val="000000"/>
+            </a:solidFill>
+          </a:ln>
+          <a:effectLst/>
+        </p:spPr>
+        <p:style>
+          <a:lnRef idx="1">
+            <a:schemeClr val="accent1"/>
+          </a:lnRef>
+          <a:fillRef idx="3">
+            <a:schemeClr val="accent1"/>
+          </a:fillRef>
+          <a:effectRef idx="2">
+            <a:schemeClr val="accent1"/>
+          </a:effectRef>
+          <a:fontRef idx="minor">
+            <a:schemeClr val="lt1"/>
+          </a:fontRef>
+        </p:style>
+        <p:txBody>
+          <a:bodyPr rtlCol="0" anchor="ctr"/>
+          <a:lstStyle/>
+          <a:p>
+            <a:pPr algn="ctr"/>
+          </a:p>
+        </p:txBody>
+      </p:sp>
+      <p:sp>
+        <p:nvSpPr>
+          <p:cNvPr id="19" name="TextBox 18"/>
+          <p:cNvSpPr txBox="1"/>
+          <p:nvPr/>
+        </p:nvSpPr>
+        <p:spPr>
+          <a:xfrm>
+            <a:off x="4541367" y="4526280"/>
+            <a:ext cx="3108960" cy="640080"/>
+          </a:xfrm>
+          <a:prstGeom prst="rect">
+            <a:avLst/>
+          </a:prstGeom>
+          <a:noFill/>
+        </p:spPr>
+        <p:txBody>
+          <a:bodyPr wrap="square">
+            <a:spAutoFit/>
+          </a:bodyPr>
+          <a:lstStyle/>
+          <a:p>
+            <a:pPr algn="ctr"/>
+            <a:r>
+              <a:rPr sz="1500" b="1" i="0" u="none">
                 <a:solidFill>
                   <a:srgbClr val="000000"/>
                 </a:solidFill>
                 <a:latin typeface="Arial"/>
               </a:rPr>
-              <a:t>•  Only a 5-level scale tested; Jev supports up to 10</a:t>
-            </a:r>
-          </a:p>
-          <a:p>
-            <a:pPr>
-              <a:spcAft>
-                <a:spcPts val="1200"/>
-              </a:spcAft>
-            </a:pPr>
-            <a:r>
-              <a:rPr sz="1600">
+              <a:t>5 levels tested</a:t>
+            </a:r>
+          </a:p>
+        </p:txBody>
+      </p:sp>
+      <p:sp>
+        <p:nvSpPr>
+          <p:cNvPr id="20" name="TextBox 19"/>
+          <p:cNvSpPr txBox="1"/>
+          <p:nvPr/>
+        </p:nvSpPr>
+        <p:spPr>
+          <a:xfrm>
+            <a:off x="4541367" y="5212080"/>
+            <a:ext cx="3108960" cy="640080"/>
+          </a:xfrm>
+          <a:prstGeom prst="rect">
+            <a:avLst/>
+          </a:prstGeom>
+          <a:noFill/>
+        </p:spPr>
+        <p:txBody>
+          <a:bodyPr wrap="square">
+            <a:spAutoFit/>
+          </a:bodyPr>
+          <a:lstStyle/>
+          <a:p>
+            <a:pPr algn="ctr"/>
+            <a:r>
+              <a:rPr sz="1200" b="0" i="0" u="none">
+                <a:solidFill>
+                  <a:srgbClr val="595959"/>
+                </a:solidFill>
+                <a:latin typeface="Arial"/>
+              </a:rPr>
+              <a:t>Jev supports up to 10</a:t>
+            </a:r>
+          </a:p>
+        </p:txBody>
+      </p:sp>
+      <p:sp>
+        <p:nvSpPr>
+          <p:cNvPr id="21" name="Rectangle 20"/>
+          <p:cNvSpPr/>
+          <p:nvPr/>
+        </p:nvSpPr>
+        <p:spPr>
+          <a:xfrm>
+            <a:off x="8061807" y="4343400"/>
+            <a:ext cx="3383280" cy="1554480"/>
+          </a:xfrm>
+          <a:prstGeom prst="rect">
+            <a:avLst/>
+          </a:prstGeom>
+          <a:noFill/>
+          <a:ln w="19050">
+            <a:solidFill>
+              <a:srgbClr val="000000"/>
+            </a:solidFill>
+          </a:ln>
+          <a:effectLst/>
+        </p:spPr>
+        <p:style>
+          <a:lnRef idx="1">
+            <a:schemeClr val="accent1"/>
+          </a:lnRef>
+          <a:fillRef idx="3">
+            <a:schemeClr val="accent1"/>
+          </a:fillRef>
+          <a:effectRef idx="2">
+            <a:schemeClr val="accent1"/>
+          </a:effectRef>
+          <a:fontRef idx="minor">
+            <a:schemeClr val="lt1"/>
+          </a:fontRef>
+        </p:style>
+        <p:txBody>
+          <a:bodyPr rtlCol="0" anchor="ctr"/>
+          <a:lstStyle/>
+          <a:p>
+            <a:pPr algn="ctr"/>
+          </a:p>
+        </p:txBody>
+      </p:sp>
+      <p:sp>
+        <p:nvSpPr>
+          <p:cNvPr id="22" name="TextBox 21"/>
+          <p:cNvSpPr txBox="1"/>
+          <p:nvPr/>
+        </p:nvSpPr>
+        <p:spPr>
+          <a:xfrm>
+            <a:off x="8198967" y="4526280"/>
+            <a:ext cx="3108960" cy="640080"/>
+          </a:xfrm>
+          <a:prstGeom prst="rect">
+            <a:avLst/>
+          </a:prstGeom>
+          <a:noFill/>
+        </p:spPr>
+        <p:txBody>
+          <a:bodyPr wrap="square">
+            <a:spAutoFit/>
+          </a:bodyPr>
+          <a:lstStyle/>
+          <a:p>
+            <a:pPr algn="ctr"/>
+            <a:r>
+              <a:rPr sz="1500" b="1" i="0" u="none">
                 <a:solidFill>
                   <a:srgbClr val="000000"/>
                 </a:solidFill>
                 <a:latin typeface="Arial"/>
               </a:rPr>
-              <a:t>•  One pipeline — independent replication would strengthen the case</a:t>
-            </a:r>
-          </a:p>
-        </p:txBody>
-      </p:sp>
-      <p:sp>
-        <p:nvSpPr>
-          <p:cNvPr id="8" name="TextBox 7"/>
+              <a:t>One pipeline</a:t>
+            </a:r>
+          </a:p>
+        </p:txBody>
+      </p:sp>
+      <p:sp>
+        <p:nvSpPr>
+          <p:cNvPr id="23" name="TextBox 22"/>
+          <p:cNvSpPr txBox="1"/>
+          <p:nvPr/>
+        </p:nvSpPr>
+        <p:spPr>
+          <a:xfrm>
+            <a:off x="8198967" y="5212080"/>
+            <a:ext cx="3108960" cy="640080"/>
+          </a:xfrm>
+          <a:prstGeom prst="rect">
+            <a:avLst/>
+          </a:prstGeom>
+          <a:noFill/>
+        </p:spPr>
+        <p:txBody>
+          <a:bodyPr wrap="square">
+            <a:spAutoFit/>
+          </a:bodyPr>
+          <a:lstStyle/>
+          <a:p>
+            <a:pPr algn="ctr"/>
+            <a:r>
+              <a:rPr sz="1200" b="0" i="0" u="none">
+                <a:solidFill>
+                  <a:srgbClr val="595959"/>
+                </a:solidFill>
+                <a:latin typeface="Arial"/>
+              </a:rPr>
+              <a:t>replication would strengthen the case</a:t>
+            </a:r>
+          </a:p>
+        </p:txBody>
+      </p:sp>
+      <p:sp>
+        <p:nvSpPr>
+          <p:cNvPr id="24" name="TextBox 23"/>
           <p:cNvSpPr txBox="1"/>
           <p:nvPr/>
         </p:nvSpPr>
@@ -4541,14 +5083,93 @@
       </p:sp>
       <p:sp>
         <p:nvSpPr>
-          <p:cNvPr id="4" name="TextBox 3"/>
-          <p:cNvSpPr txBox="1"/>
-          <p:nvPr/>
-        </p:nvSpPr>
-        <p:spPr>
-          <a:xfrm>
-            <a:off x="1005840" y="2103120"/>
-            <a:ext cx="10180015" cy="3200400"/>
+          <p:cNvPr id="4" name="Rectangle 3"/>
+          <p:cNvSpPr/>
+          <p:nvPr/>
+        </p:nvSpPr>
+        <p:spPr>
+          <a:xfrm>
+            <a:off x="731520" y="1828800"/>
+            <a:ext cx="4846320" cy="3657600"/>
+          </a:xfrm>
+          <a:prstGeom prst="rect">
+            <a:avLst/>
+          </a:prstGeom>
+          <a:noFill/>
+          <a:ln w="19050">
+            <a:solidFill>
+              <a:srgbClr val="000000"/>
+            </a:solidFill>
+          </a:ln>
+          <a:effectLst/>
+        </p:spPr>
+        <p:style>
+          <a:lnRef idx="1">
+            <a:schemeClr val="accent1"/>
+          </a:lnRef>
+          <a:fillRef idx="3">
+            <a:schemeClr val="accent1"/>
+          </a:fillRef>
+          <a:effectRef idx="2">
+            <a:schemeClr val="accent1"/>
+          </a:effectRef>
+          <a:fontRef idx="minor">
+            <a:schemeClr val="lt1"/>
+          </a:fontRef>
+        </p:style>
+        <p:txBody>
+          <a:bodyPr rtlCol="0" anchor="ctr"/>
+          <a:lstStyle/>
+          <a:p>
+            <a:pPr algn="ctr"/>
+          </a:p>
+        </p:txBody>
+      </p:sp>
+      <p:sp>
+        <p:nvSpPr>
+          <p:cNvPr id="5" name="TextBox 4"/>
+          <p:cNvSpPr txBox="1"/>
+          <p:nvPr/>
+        </p:nvSpPr>
+        <p:spPr>
+          <a:xfrm>
+            <a:off x="914400" y="1965960"/>
+            <a:ext cx="4480560" cy="457200"/>
+          </a:xfrm>
+          <a:prstGeom prst="rect">
+            <a:avLst/>
+          </a:prstGeom>
+          <a:noFill/>
+        </p:spPr>
+        <p:txBody>
+          <a:bodyPr wrap="square">
+            <a:spAutoFit/>
+          </a:bodyPr>
+          <a:lstStyle/>
+          <a:p>
+            <a:pPr algn="ctr"/>
+            <a:r>
+              <a:rPr sz="1800" b="1" i="0" u="none">
+                <a:solidFill>
+                  <a:srgbClr val="000000"/>
+                </a:solidFill>
+                <a:latin typeface="Arial"/>
+              </a:rPr>
+              <a:t>Free-Text Assessment</a:t>
+            </a:r>
+          </a:p>
+        </p:txBody>
+      </p:sp>
+      <p:sp>
+        <p:nvSpPr>
+          <p:cNvPr id="6" name="TextBox 5"/>
+          <p:cNvSpPr txBox="1"/>
+          <p:nvPr/>
+        </p:nvSpPr>
+        <p:spPr>
+          <a:xfrm>
+            <a:off x="1005840" y="2606040"/>
+            <a:ext cx="4297680" cy="2743200"/>
           </a:xfrm>
           <a:prstGeom prst="rect">
             <a:avLst/>
@@ -4567,13 +5188,13 @@
               </a:spcAft>
             </a:pPr>
             <a:r>
-              <a:rPr sz="2000">
+              <a:rPr sz="1500">
                 <a:solidFill>
                   <a:srgbClr val="000000"/>
                 </a:solidFill>
                 <a:latin typeface="Arial"/>
               </a:rPr>
-              <a:t>•  Free-text assessment can assert a strength or weakness the resume never supports — a hallucination — with no built-in confidence signal.</a:t>
+              <a:t>•  Writes a paragraph verdict per candidate</a:t>
             </a:r>
           </a:p>
           <a:p>
@@ -4583,13 +5204,13 @@
               </a:spcAft>
             </a:pPr>
             <a:r>
-              <a:rPr sz="2000">
+              <a:rPr sz="1500">
                 <a:solidFill>
                   <a:srgbClr val="000000"/>
                 </a:solidFill>
                 <a:latin typeface="Arial"/>
               </a:rPr>
-              <a:t>•  In September 2026, TypeSafe released Jev, the first “System One Model.”</a:t>
+              <a:t>•  Can assert a strength the resume never supports</a:t>
             </a:r>
           </a:p>
           <a:p>
@@ -4599,20 +5220,205 @@
               </a:spcAft>
             </a:pPr>
             <a:r>
-              <a:rPr sz="2000">
+              <a:rPr sz="1500">
                 <a:solidFill>
                   <a:srgbClr val="000000"/>
                 </a:solidFill>
                 <a:latin typeface="Arial"/>
               </a:rPr>
-              <a:t>•  No independent, peer-reviewed evaluation of it existed before this paper.</a:t>
-            </a:r>
-          </a:p>
-        </p:txBody>
-      </p:sp>
-      <p:sp>
-        <p:nvSpPr>
-          <p:cNvPr id="5" name="TextBox 4"/>
+              <a:t>•  No built-in confidence signal</a:t>
+            </a:r>
+          </a:p>
+        </p:txBody>
+      </p:sp>
+      <p:sp>
+        <p:nvSpPr>
+          <p:cNvPr id="7" name="Rectangle 6"/>
+          <p:cNvSpPr/>
+          <p:nvPr/>
+        </p:nvSpPr>
+        <p:spPr>
+          <a:xfrm>
+            <a:off x="6613855" y="1828800"/>
+            <a:ext cx="4846320" cy="3657600"/>
+          </a:xfrm>
+          <a:prstGeom prst="rect">
+            <a:avLst/>
+          </a:prstGeom>
+          <a:noFill/>
+          <a:ln w="19050">
+            <a:solidFill>
+              <a:srgbClr val="000000"/>
+            </a:solidFill>
+          </a:ln>
+          <a:effectLst/>
+        </p:spPr>
+        <p:style>
+          <a:lnRef idx="1">
+            <a:schemeClr val="accent1"/>
+          </a:lnRef>
+          <a:fillRef idx="3">
+            <a:schemeClr val="accent1"/>
+          </a:fillRef>
+          <a:effectRef idx="2">
+            <a:schemeClr val="accent1"/>
+          </a:effectRef>
+          <a:fontRef idx="minor">
+            <a:schemeClr val="lt1"/>
+          </a:fontRef>
+        </p:style>
+        <p:txBody>
+          <a:bodyPr rtlCol="0" anchor="ctr"/>
+          <a:lstStyle/>
+          <a:p>
+            <a:pPr algn="ctr"/>
+          </a:p>
+        </p:txBody>
+      </p:sp>
+      <p:sp>
+        <p:nvSpPr>
+          <p:cNvPr id="8" name="TextBox 7"/>
+          <p:cNvSpPr txBox="1"/>
+          <p:nvPr/>
+        </p:nvSpPr>
+        <p:spPr>
+          <a:xfrm>
+            <a:off x="6796735" y="1965960"/>
+            <a:ext cx="4480560" cy="457200"/>
+          </a:xfrm>
+          <a:prstGeom prst="rect">
+            <a:avLst/>
+          </a:prstGeom>
+          <a:noFill/>
+        </p:spPr>
+        <p:txBody>
+          <a:bodyPr wrap="square">
+            <a:spAutoFit/>
+          </a:bodyPr>
+          <a:lstStyle/>
+          <a:p>
+            <a:pPr algn="ctr"/>
+            <a:r>
+              <a:rPr sz="1800" b="1" i="0" u="none">
+                <a:solidFill>
+                  <a:srgbClr val="000000"/>
+                </a:solidFill>
+                <a:latin typeface="Arial"/>
+              </a:rPr>
+              <a:t>The Gap</a:t>
+            </a:r>
+          </a:p>
+        </p:txBody>
+      </p:sp>
+      <p:sp>
+        <p:nvSpPr>
+          <p:cNvPr id="9" name="TextBox 8"/>
+          <p:cNvSpPr txBox="1"/>
+          <p:nvPr/>
+        </p:nvSpPr>
+        <p:spPr>
+          <a:xfrm>
+            <a:off x="6888175" y="2606040"/>
+            <a:ext cx="4297680" cy="2743200"/>
+          </a:xfrm>
+          <a:prstGeom prst="rect">
+            <a:avLst/>
+          </a:prstGeom>
+          <a:noFill/>
+        </p:spPr>
+        <p:txBody>
+          <a:bodyPr wrap="square">
+            <a:spAutoFit/>
+          </a:bodyPr>
+          <a:lstStyle/>
+          <a:p>
+            <a:pPr>
+              <a:spcAft>
+                <a:spcPts val="1200"/>
+              </a:spcAft>
+            </a:pPr>
+            <a:r>
+              <a:rPr sz="1500">
+                <a:solidFill>
+                  <a:srgbClr val="000000"/>
+                </a:solidFill>
+                <a:latin typeface="Arial"/>
+              </a:rPr>
+              <a:t>•  TypeSafe released Jev in September 2026</a:t>
+            </a:r>
+          </a:p>
+          <a:p>
+            <a:pPr>
+              <a:spcAft>
+                <a:spcPts val="1200"/>
+              </a:spcAft>
+            </a:pPr>
+            <a:r>
+              <a:rPr sz="1500">
+                <a:solidFill>
+                  <a:srgbClr val="000000"/>
+                </a:solidFill>
+                <a:latin typeface="Arial"/>
+              </a:rPr>
+              <a:t>•  The first “System One Model”</a:t>
+            </a:r>
+          </a:p>
+          <a:p>
+            <a:pPr>
+              <a:spcAft>
+                <a:spcPts val="1200"/>
+              </a:spcAft>
+            </a:pPr>
+            <a:r>
+              <a:rPr sz="1500">
+                <a:solidFill>
+                  <a:srgbClr val="000000"/>
+                </a:solidFill>
+                <a:latin typeface="Arial"/>
+              </a:rPr>
+              <a:t>•  No independent evaluation existed before this paper</a:t>
+            </a:r>
+          </a:p>
+        </p:txBody>
+      </p:sp>
+      <p:sp>
+        <p:nvSpPr>
+          <p:cNvPr id="10" name="TextBox 9"/>
+          <p:cNvSpPr txBox="1"/>
+          <p:nvPr/>
+        </p:nvSpPr>
+        <p:spPr>
+          <a:xfrm>
+            <a:off x="5577840" y="3383280"/>
+            <a:ext cx="1036015" cy="548640"/>
+          </a:xfrm>
+          <a:prstGeom prst="rect">
+            <a:avLst/>
+          </a:prstGeom>
+          <a:noFill/>
+        </p:spPr>
+        <p:txBody>
+          <a:bodyPr wrap="square">
+            <a:spAutoFit/>
+          </a:bodyPr>
+          <a:lstStyle/>
+          <a:p>
+            <a:pPr algn="ctr"/>
+            <a:r>
+              <a:rPr sz="2800" b="0" i="0" u="none">
+                <a:solidFill>
+                  <a:srgbClr val="000000"/>
+                </a:solidFill>
+                <a:latin typeface="Arial"/>
+              </a:rPr>
+              <a:t>→</a:t>
+            </a:r>
+          </a:p>
+        </p:txBody>
+      </p:sp>
+      <p:sp>
+        <p:nvSpPr>
+          <p:cNvPr id="11" name="TextBox 10"/>
           <p:cNvSpPr txBox="1"/>
           <p:nvPr/>
         </p:nvSpPr>
@@ -5110,72 +5916,414 @@
         </p:nvSpPr>
         <p:spPr>
           <a:xfrm>
-            <a:off x="1005840" y="2103120"/>
-            <a:ext cx="10180015" cy="3200400"/>
-          </a:xfrm>
-          <a:prstGeom prst="rect">
-            <a:avLst/>
-          </a:prstGeom>
-          <a:noFill/>
-        </p:spPr>
-        <p:txBody>
-          <a:bodyPr wrap="square">
-            <a:spAutoFit/>
-          </a:bodyPr>
-          <a:lstStyle/>
-          <a:p>
-            <a:pPr>
-              <a:spcAft>
-                <a:spcPts val="1200"/>
-              </a:spcAft>
-            </a:pPr>
-            <a:r>
-              <a:rPr sz="2000">
+            <a:off x="914400" y="1828800"/>
+            <a:ext cx="10362895" cy="640080"/>
+          </a:xfrm>
+          <a:prstGeom prst="rect">
+            <a:avLst/>
+          </a:prstGeom>
+          <a:noFill/>
+        </p:spPr>
+        <p:txBody>
+          <a:bodyPr wrap="square">
+            <a:spAutoFit/>
+          </a:bodyPr>
+          <a:lstStyle/>
+          <a:p>
+            <a:pPr algn="ctr"/>
+            <a:r>
+              <a:rPr sz="1800" b="0" i="0" u="none">
                 <a:solidFill>
                   <a:srgbClr val="000000"/>
                 </a:solidFill>
                 <a:latin typeface="Arial"/>
               </a:rPr>
-              <a:t>•  Non-autoregressive: answers typed questions in one parallel pass — no generated tokens.</a:t>
-            </a:r>
-          </a:p>
-          <a:p>
-            <a:pPr>
-              <a:spcAft>
-                <a:spcPts val="1200"/>
-              </a:spcAft>
-            </a:pPr>
-            <a:r>
-              <a:rPr sz="2000">
+              <a:t>Non-autoregressive: answers typed questions in one parallel pass — no generated tokens.</a:t>
+            </a:r>
+          </a:p>
+        </p:txBody>
+      </p:sp>
+      <p:sp>
+        <p:nvSpPr>
+          <p:cNvPr id="5" name="Rectangle 4"/>
+          <p:cNvSpPr/>
+          <p:nvPr/>
+        </p:nvSpPr>
+        <p:spPr>
+          <a:xfrm>
+            <a:off x="929487" y="2834640"/>
+            <a:ext cx="3200400" cy="1828800"/>
+          </a:xfrm>
+          <a:prstGeom prst="rect">
+            <a:avLst/>
+          </a:prstGeom>
+          <a:noFill/>
+          <a:ln w="19050">
+            <a:solidFill>
+              <a:srgbClr val="000000"/>
+            </a:solidFill>
+          </a:ln>
+          <a:effectLst/>
+        </p:spPr>
+        <p:style>
+          <a:lnRef idx="1">
+            <a:schemeClr val="accent1"/>
+          </a:lnRef>
+          <a:fillRef idx="3">
+            <a:schemeClr val="accent1"/>
+          </a:fillRef>
+          <a:effectRef idx="2">
+            <a:schemeClr val="accent1"/>
+          </a:effectRef>
+          <a:fontRef idx="minor">
+            <a:schemeClr val="lt1"/>
+          </a:fontRef>
+        </p:style>
+        <p:txBody>
+          <a:bodyPr rtlCol="0" anchor="ctr"/>
+          <a:lstStyle/>
+          <a:p>
+            <a:pPr algn="ctr"/>
+          </a:p>
+        </p:txBody>
+      </p:sp>
+      <p:sp>
+        <p:nvSpPr>
+          <p:cNvPr id="6" name="TextBox 5"/>
+          <p:cNvSpPr txBox="1"/>
+          <p:nvPr/>
+        </p:nvSpPr>
+        <p:spPr>
+          <a:xfrm>
+            <a:off x="929487" y="3108960"/>
+            <a:ext cx="3200400" cy="548640"/>
+          </a:xfrm>
+          <a:prstGeom prst="rect">
+            <a:avLst/>
+          </a:prstGeom>
+          <a:noFill/>
+        </p:spPr>
+        <p:txBody>
+          <a:bodyPr wrap="square">
+            <a:spAutoFit/>
+          </a:bodyPr>
+          <a:lstStyle/>
+          <a:p>
+            <a:pPr algn="ctr"/>
+            <a:r>
+              <a:rPr sz="2200" b="0" i="0" u="none">
                 <a:solidFill>
                   <a:srgbClr val="000000"/>
                 </a:solidFill>
                 <a:latin typeface="Arial"/>
               </a:rPr>
-              <a:t>•  Three typed primitives: Noul (yes/no + confidence), Choice (multiple-choice), Score (ordinal scale).</a:t>
-            </a:r>
-          </a:p>
-          <a:p>
-            <a:pPr>
-              <a:spcAft>
-                <a:spcPts val="1200"/>
-              </a:spcAft>
-            </a:pPr>
-            <a:r>
-              <a:rPr sz="2000">
+              <a:t>Noul</a:t>
+            </a:r>
+          </a:p>
+        </p:txBody>
+      </p:sp>
+      <p:sp>
+        <p:nvSpPr>
+          <p:cNvPr id="7" name="TextBox 6"/>
+          <p:cNvSpPr txBox="1"/>
+          <p:nvPr/>
+        </p:nvSpPr>
+        <p:spPr>
+          <a:xfrm>
+            <a:off x="1112367" y="3840480"/>
+            <a:ext cx="2834640" cy="731520"/>
+          </a:xfrm>
+          <a:prstGeom prst="rect">
+            <a:avLst/>
+          </a:prstGeom>
+          <a:noFill/>
+        </p:spPr>
+        <p:txBody>
+          <a:bodyPr wrap="square">
+            <a:spAutoFit/>
+          </a:bodyPr>
+          <a:lstStyle/>
+          <a:p>
+            <a:pPr algn="ctr"/>
+            <a:r>
+              <a:rPr sz="1400" b="0" i="0" u="none">
+                <a:solidFill>
+                  <a:srgbClr val="595959"/>
+                </a:solidFill>
+                <a:latin typeface="Arial"/>
+              </a:rPr>
+              <a:t>yes/no</a:t>
+            </a:r>
+          </a:p>
+          <a:p>
+            <a:pPr algn="ctr"/>
+            <a:r>
+              <a:rPr sz="1400" b="0" i="0" u="none">
+                <a:solidFill>
+                  <a:srgbClr val="595959"/>
+                </a:solidFill>
+                <a:latin typeface="Arial"/>
+              </a:rPr>
+              <a:t>+ confidence</a:t>
+            </a:r>
+          </a:p>
+        </p:txBody>
+      </p:sp>
+      <p:sp>
+        <p:nvSpPr>
+          <p:cNvPr id="8" name="Rectangle 7"/>
+          <p:cNvSpPr/>
+          <p:nvPr/>
+        </p:nvSpPr>
+        <p:spPr>
+          <a:xfrm>
+            <a:off x="4495647" y="2834640"/>
+            <a:ext cx="3200400" cy="1828800"/>
+          </a:xfrm>
+          <a:prstGeom prst="rect">
+            <a:avLst/>
+          </a:prstGeom>
+          <a:noFill/>
+          <a:ln w="19050">
+            <a:solidFill>
+              <a:srgbClr val="000000"/>
+            </a:solidFill>
+          </a:ln>
+          <a:effectLst/>
+        </p:spPr>
+        <p:style>
+          <a:lnRef idx="1">
+            <a:schemeClr val="accent1"/>
+          </a:lnRef>
+          <a:fillRef idx="3">
+            <a:schemeClr val="accent1"/>
+          </a:fillRef>
+          <a:effectRef idx="2">
+            <a:schemeClr val="accent1"/>
+          </a:effectRef>
+          <a:fontRef idx="minor">
+            <a:schemeClr val="lt1"/>
+          </a:fontRef>
+        </p:style>
+        <p:txBody>
+          <a:bodyPr rtlCol="0" anchor="ctr"/>
+          <a:lstStyle/>
+          <a:p>
+            <a:pPr algn="ctr"/>
+          </a:p>
+        </p:txBody>
+      </p:sp>
+      <p:sp>
+        <p:nvSpPr>
+          <p:cNvPr id="9" name="TextBox 8"/>
+          <p:cNvSpPr txBox="1"/>
+          <p:nvPr/>
+        </p:nvSpPr>
+        <p:spPr>
+          <a:xfrm>
+            <a:off x="4495647" y="3108960"/>
+            <a:ext cx="3200400" cy="548640"/>
+          </a:xfrm>
+          <a:prstGeom prst="rect">
+            <a:avLst/>
+          </a:prstGeom>
+          <a:noFill/>
+        </p:spPr>
+        <p:txBody>
+          <a:bodyPr wrap="square">
+            <a:spAutoFit/>
+          </a:bodyPr>
+          <a:lstStyle/>
+          <a:p>
+            <a:pPr algn="ctr"/>
+            <a:r>
+              <a:rPr sz="2200" b="0" i="0" u="none">
                 <a:solidFill>
                   <a:srgbClr val="000000"/>
                 </a:solidFill>
                 <a:latin typeface="Arial"/>
               </a:rPr>
-              <a:t>•  This paper's questions all use Score.</a:t>
-            </a:r>
-          </a:p>
-        </p:txBody>
-      </p:sp>
-      <p:sp>
-        <p:nvSpPr>
-          <p:cNvPr id="5" name="TextBox 4"/>
+              <a:t>Choice</a:t>
+            </a:r>
+          </a:p>
+        </p:txBody>
+      </p:sp>
+      <p:sp>
+        <p:nvSpPr>
+          <p:cNvPr id="10" name="TextBox 9"/>
+          <p:cNvSpPr txBox="1"/>
+          <p:nvPr/>
+        </p:nvSpPr>
+        <p:spPr>
+          <a:xfrm>
+            <a:off x="4678527" y="3840480"/>
+            <a:ext cx="2834640" cy="731520"/>
+          </a:xfrm>
+          <a:prstGeom prst="rect">
+            <a:avLst/>
+          </a:prstGeom>
+          <a:noFill/>
+        </p:spPr>
+        <p:txBody>
+          <a:bodyPr wrap="square">
+            <a:spAutoFit/>
+          </a:bodyPr>
+          <a:lstStyle/>
+          <a:p>
+            <a:pPr algn="ctr"/>
+            <a:r>
+              <a:rPr sz="1400" b="0" i="0" u="none">
+                <a:solidFill>
+                  <a:srgbClr val="595959"/>
+                </a:solidFill>
+                <a:latin typeface="Arial"/>
+              </a:rPr>
+              <a:t>multiple-</a:t>
+            </a:r>
+          </a:p>
+          <a:p>
+            <a:pPr algn="ctr"/>
+            <a:r>
+              <a:rPr sz="1400" b="0" i="0" u="none">
+                <a:solidFill>
+                  <a:srgbClr val="595959"/>
+                </a:solidFill>
+                <a:latin typeface="Arial"/>
+              </a:rPr>
+              <a:t>choice</a:t>
+            </a:r>
+          </a:p>
+        </p:txBody>
+      </p:sp>
+      <p:sp>
+        <p:nvSpPr>
+          <p:cNvPr id="11" name="Rectangle 10"/>
+          <p:cNvSpPr/>
+          <p:nvPr/>
+        </p:nvSpPr>
+        <p:spPr>
+          <a:xfrm>
+            <a:off x="8061807" y="2834640"/>
+            <a:ext cx="3200400" cy="1828800"/>
+          </a:xfrm>
+          <a:prstGeom prst="rect">
+            <a:avLst/>
+          </a:prstGeom>
+          <a:noFill/>
+          <a:ln w="19050">
+            <a:solidFill>
+              <a:srgbClr val="000000"/>
+            </a:solidFill>
+          </a:ln>
+          <a:effectLst/>
+        </p:spPr>
+        <p:style>
+          <a:lnRef idx="1">
+            <a:schemeClr val="accent1"/>
+          </a:lnRef>
+          <a:fillRef idx="3">
+            <a:schemeClr val="accent1"/>
+          </a:fillRef>
+          <a:effectRef idx="2">
+            <a:schemeClr val="accent1"/>
+          </a:effectRef>
+          <a:fontRef idx="minor">
+            <a:schemeClr val="lt1"/>
+          </a:fontRef>
+        </p:style>
+        <p:txBody>
+          <a:bodyPr rtlCol="0" anchor="ctr"/>
+          <a:lstStyle/>
+          <a:p>
+            <a:pPr algn="ctr"/>
+          </a:p>
+        </p:txBody>
+      </p:sp>
+      <p:sp>
+        <p:nvSpPr>
+          <p:cNvPr id="12" name="TextBox 11"/>
+          <p:cNvSpPr txBox="1"/>
+          <p:nvPr/>
+        </p:nvSpPr>
+        <p:spPr>
+          <a:xfrm>
+            <a:off x="8061807" y="3108960"/>
+            <a:ext cx="3200400" cy="548640"/>
+          </a:xfrm>
+          <a:prstGeom prst="rect">
+            <a:avLst/>
+          </a:prstGeom>
+          <a:noFill/>
+        </p:spPr>
+        <p:txBody>
+          <a:bodyPr wrap="square">
+            <a:spAutoFit/>
+          </a:bodyPr>
+          <a:lstStyle/>
+          <a:p>
+            <a:pPr algn="ctr"/>
+            <a:r>
+              <a:rPr sz="2200" b="1" i="0" u="sng">
+                <a:solidFill>
+                  <a:srgbClr val="000000"/>
+                </a:solidFill>
+                <a:latin typeface="Arial"/>
+              </a:rPr>
+              <a:t>Score</a:t>
+            </a:r>
+          </a:p>
+        </p:txBody>
+      </p:sp>
+      <p:sp>
+        <p:nvSpPr>
+          <p:cNvPr id="13" name="TextBox 12"/>
+          <p:cNvSpPr txBox="1"/>
+          <p:nvPr/>
+        </p:nvSpPr>
+        <p:spPr>
+          <a:xfrm>
+            <a:off x="8244687" y="3840480"/>
+            <a:ext cx="2834640" cy="731520"/>
+          </a:xfrm>
+          <a:prstGeom prst="rect">
+            <a:avLst/>
+          </a:prstGeom>
+          <a:noFill/>
+        </p:spPr>
+        <p:txBody>
+          <a:bodyPr wrap="square">
+            <a:spAutoFit/>
+          </a:bodyPr>
+          <a:lstStyle/>
+          <a:p>
+            <a:pPr algn="ctr"/>
+            <a:r>
+              <a:rPr sz="1400" b="0" i="0" u="none">
+                <a:solidFill>
+                  <a:srgbClr val="595959"/>
+                </a:solidFill>
+                <a:latin typeface="Arial"/>
+              </a:rPr>
+              <a:t>ordinal scale</a:t>
+            </a:r>
+          </a:p>
+          <a:p>
+            <a:pPr algn="ctr"/>
+            <a:r>
+              <a:rPr sz="1400" b="0" i="0" u="none">
+                <a:solidFill>
+                  <a:srgbClr val="595959"/>
+                </a:solidFill>
+                <a:latin typeface="Arial"/>
+              </a:rPr>
+              <a:t>(used here)</a:t>
+            </a:r>
+          </a:p>
+        </p:txBody>
+      </p:sp>
+      <p:sp>
+        <p:nvSpPr>
+          <p:cNvPr id="14" name="TextBox 13"/>
           <p:cNvSpPr txBox="1"/>
           <p:nvPr/>
         </p:nvSpPr>
@@ -5306,78 +6454,213 @@
       </p:sp>
       <p:sp>
         <p:nvSpPr>
-          <p:cNvPr id="4" name="TextBox 3"/>
-          <p:cNvSpPr txBox="1"/>
-          <p:nvPr/>
-        </p:nvSpPr>
-        <p:spPr>
-          <a:xfrm>
-            <a:off x="1005840" y="2103120"/>
-            <a:ext cx="10180015" cy="3200400"/>
-          </a:xfrm>
-          <a:prstGeom prst="rect">
-            <a:avLst/>
-          </a:prstGeom>
-          <a:noFill/>
-        </p:spPr>
-        <p:txBody>
-          <a:bodyPr wrap="square">
-            <a:spAutoFit/>
-          </a:bodyPr>
-          <a:lstStyle/>
-          <a:p>
-            <a:pPr>
-              <a:spcAft>
-                <a:spcPts val="1200"/>
-              </a:spcAft>
-            </a:pPr>
-            <a:r>
-              <a:rPr sz="2000">
+          <p:cNvPr id="4" name="Rectangle 3"/>
+          <p:cNvSpPr/>
+          <p:nvPr/>
+        </p:nvSpPr>
+        <p:spPr>
+          <a:xfrm>
+            <a:off x="1615287" y="1920240"/>
+            <a:ext cx="4206240" cy="2011680"/>
+          </a:xfrm>
+          <a:prstGeom prst="rect">
+            <a:avLst/>
+          </a:prstGeom>
+          <a:noFill/>
+          <a:ln w="19050">
+            <a:solidFill>
+              <a:srgbClr val="000000"/>
+            </a:solidFill>
+          </a:ln>
+          <a:effectLst/>
+        </p:spPr>
+        <p:style>
+          <a:lnRef idx="1">
+            <a:schemeClr val="accent1"/>
+          </a:lnRef>
+          <a:fillRef idx="3">
+            <a:schemeClr val="accent1"/>
+          </a:fillRef>
+          <a:effectRef idx="2">
+            <a:schemeClr val="accent1"/>
+          </a:effectRef>
+          <a:fontRef idx="minor">
+            <a:schemeClr val="lt1"/>
+          </a:fontRef>
+        </p:style>
+        <p:txBody>
+          <a:bodyPr rtlCol="0" anchor="ctr" wrap="square" lIns="127000" rIns="127000"/>
+          <a:lstStyle/>
+          <a:p>
+            <a:pPr algn="ctr"/>
+            <a:r>
+              <a:rPr sz="1500" b="0">
                 <a:solidFill>
                   <a:srgbClr val="000000"/>
                 </a:solidFill>
                 <a:latin typeface="Arial"/>
               </a:rPr>
-              <a:t>•  Each Score level is judged alone — no view of neighboring levels, so a bare number carries no signal.</a:t>
-            </a:r>
-          </a:p>
-          <a:p>
-            <a:pPr>
-              <a:spcAft>
-                <a:spcPts val="1200"/>
-              </a:spcAft>
-            </a:pPr>
-            <a:r>
-              <a:rPr sz="2000">
+              <a:t>“50”</a:t>
+            </a:r>
+          </a:p>
+          <a:p>
+            <a:pPr algn="ctr"/>
+          </a:p>
+          <a:p>
+            <a:pPr algn="ctr"/>
+            <a:r>
+              <a:rPr sz="1500" b="0">
                 <a:solidFill>
                   <a:srgbClr val="000000"/>
                 </a:solidFill>
                 <a:latin typeface="Arial"/>
               </a:rPr>
-              <a:t>•  A concrete situation gives the model resume evidence to check against.</a:t>
-            </a:r>
-          </a:p>
-          <a:p>
-            <a:pPr>
-              <a:spcAft>
-                <a:spcPts val="1200"/>
-              </a:spcAft>
-            </a:pPr>
-            <a:r>
-              <a:rPr sz="2000">
+              <a:t>judged alone, no neighbors to compare — no signal to check</a:t>
+            </a:r>
+          </a:p>
+        </p:txBody>
+      </p:sp>
+      <p:sp>
+        <p:nvSpPr>
+          <p:cNvPr id="5" name="Rectangle 4"/>
+          <p:cNvSpPr/>
+          <p:nvPr/>
+        </p:nvSpPr>
+        <p:spPr>
+          <a:xfrm>
+            <a:off x="6370167" y="1920240"/>
+            <a:ext cx="4206240" cy="2011680"/>
+          </a:xfrm>
+          <a:prstGeom prst="rect">
+            <a:avLst/>
+          </a:prstGeom>
+          <a:noFill/>
+          <a:ln w="19050">
+            <a:solidFill>
+              <a:srgbClr val="000000"/>
+            </a:solidFill>
+          </a:ln>
+          <a:effectLst/>
+        </p:spPr>
+        <p:style>
+          <a:lnRef idx="1">
+            <a:schemeClr val="accent1"/>
+          </a:lnRef>
+          <a:fillRef idx="3">
+            <a:schemeClr val="accent1"/>
+          </a:fillRef>
+          <a:effectRef idx="2">
+            <a:schemeClr val="accent1"/>
+          </a:effectRef>
+          <a:fontRef idx="minor">
+            <a:schemeClr val="lt1"/>
+          </a:fontRef>
+        </p:style>
+        <p:txBody>
+          <a:bodyPr rtlCol="0" anchor="ctr" wrap="square" lIns="127000" rIns="127000"/>
+          <a:lstStyle/>
+          <a:p>
+            <a:pPr algn="ctr"/>
+            <a:r>
+              <a:rPr sz="1500" b="0">
                 <a:solidFill>
                   <a:srgbClr val="000000"/>
                 </a:solidFill>
                 <a:latin typeface="Arial"/>
               </a:rPr>
-              <a:t>•  Trained via RLCD, a reward for calibration — not human preference (RLHF) or a verifiable outcome (RLVR).</a:t>
-            </a:r>
-          </a:p>
-        </p:txBody>
-      </p:sp>
-      <p:sp>
-        <p:nvSpPr>
-          <p:cNvPr id="5" name="TextBox 4"/>
+              <a:t>“Used substantively in a real project”</a:t>
+            </a:r>
+          </a:p>
+          <a:p>
+            <a:pPr algn="ctr"/>
+          </a:p>
+          <a:p>
+            <a:pPr algn="ctr"/>
+            <a:r>
+              <a:rPr sz="1500" b="0">
+                <a:solidFill>
+                  <a:srgbClr val="000000"/>
+                </a:solidFill>
+                <a:latin typeface="Arial"/>
+              </a:rPr>
+              <a:t>resume evidence Jev can check</a:t>
+            </a:r>
+          </a:p>
+        </p:txBody>
+      </p:sp>
+      <p:sp>
+        <p:nvSpPr>
+          <p:cNvPr id="6" name="TextBox 5"/>
+          <p:cNvSpPr txBox="1"/>
+          <p:nvPr/>
+        </p:nvSpPr>
+        <p:spPr>
+          <a:xfrm>
+            <a:off x="5821527" y="2651760"/>
+            <a:ext cx="548640" cy="548640"/>
+          </a:xfrm>
+          <a:prstGeom prst="rect">
+            <a:avLst/>
+          </a:prstGeom>
+          <a:noFill/>
+        </p:spPr>
+        <p:txBody>
+          <a:bodyPr wrap="square">
+            <a:spAutoFit/>
+          </a:bodyPr>
+          <a:lstStyle/>
+          <a:p>
+            <a:pPr algn="ctr"/>
+            <a:r>
+              <a:rPr sz="2600" b="0" i="0" u="none">
+                <a:solidFill>
+                  <a:srgbClr val="000000"/>
+                </a:solidFill>
+                <a:latin typeface="Arial"/>
+              </a:rPr>
+              <a:t>→</a:t>
+            </a:r>
+          </a:p>
+        </p:txBody>
+      </p:sp>
+      <p:sp>
+        <p:nvSpPr>
+          <p:cNvPr id="7" name="TextBox 6"/>
+          <p:cNvSpPr txBox="1"/>
+          <p:nvPr/>
+        </p:nvSpPr>
+        <p:spPr>
+          <a:xfrm>
+            <a:off x="914400" y="4297680"/>
+            <a:ext cx="10362895" cy="914400"/>
+          </a:xfrm>
+          <a:prstGeom prst="rect">
+            <a:avLst/>
+          </a:prstGeom>
+          <a:noFill/>
+        </p:spPr>
+        <p:txBody>
+          <a:bodyPr wrap="square">
+            <a:spAutoFit/>
+          </a:bodyPr>
+          <a:lstStyle/>
+          <a:p>
+            <a:pPr algn="ctr"/>
+            <a:r>
+              <a:rPr sz="1600" b="0" i="1" u="none">
+                <a:solidFill>
+                  <a:srgbClr val="595959"/>
+                </a:solidFill>
+                <a:latin typeface="Arial"/>
+              </a:rPr>
+              <a:t>Trained via RLCD, a reward for calibration — not human preference (RLHF) or a verifiable outcome (RLVR). Calibration ≠ correctness.</a:t>
+            </a:r>
+          </a:p>
+        </p:txBody>
+      </p:sp>
+      <p:sp>
+        <p:nvSpPr>
+          <p:cNvPr id="8" name="TextBox 7"/>
           <p:cNvSpPr txBox="1"/>
           <p:nvPr/>
         </p:nvSpPr>

</xml_diff>